<commit_message>
fix(E02): correct Tier 1 card format in second-pass slides to match PLAN_CARD_CREATION
E02 introduces only Upgrades 1 and 3 (improved selection + in-context
format). Upgrade 4 (original sentence) comes in E03. Cards now show:
  Frente: modified dictionary sentence with target word in [MAIÚSCULO]
  Verso:  word = translation (no "Minha frase", no cloze blank)
Each card includes the dictionary example and the 1-word substitution
step, matching the scaffolding ladder (Level 1 — Substituição) from
section 6.4.2 of PLAN_CARD_CREATION.md.

Co-Authored-By: Claude Sonnet 4.6 <noreply@anthropic.com>
</commit_message>
<xml_diff>
--- a/placement_exam/planning_E02/E02_slides_Tier1_Duas_Passagem_v1.0.pptx
+++ b/placement_exam/planning_E02/E02_slides_Tier1_Duas_Passagem_v1.0.pptx
@@ -9073,7 +9073,7 @@
         <p:spPr>
           <a:xfrm>
             <a:off x="365760" y="4572000"/>
-            <a:ext cx="11430000" cy="1234440"/>
+            <a:ext cx="11430000" cy="1508760"/>
           </a:xfrm>
           <a:prstGeom prst="rect">
             <a:avLst/>
@@ -9116,7 +9116,7 @@
         <p:spPr>
           <a:xfrm>
             <a:off x="548640" y="4709160"/>
-            <a:ext cx="11109960" cy="1005840"/>
+            <a:ext cx="11109960" cy="1280160"/>
           </a:xfrm>
           <a:prstGeom prst="rect">
             <a:avLst/>
@@ -9141,7 +9141,7 @@
                 </a:solidFill>
                 <a:latin typeface="Courier New"/>
               </a:rPr>
-              <a:t>Frente: "Brazil _______ its first World Cup in 1958."</a:t>
+              <a:t>Dicionário: "Our team won the championship last year."</a:t>
             </a:r>
           </a:p>
           <a:p>
@@ -9157,7 +9157,7 @@
                 </a:solidFill>
                 <a:latin typeface="Courier New"/>
               </a:rPr>
-              <a:t>Verso:  won — ganhou</a:t>
+              <a:t>Substituição: trocar "Our team" → "My university"</a:t>
             </a:r>
           </a:p>
           <a:p>
@@ -9173,7 +9173,39 @@
                 </a:solidFill>
                 <a:latin typeface="Courier New"/>
               </a:rPr>
-              <a:t>        Minha frase: "My team won the game yesterday."</a:t>
+              <a:t> </a:t>
+            </a:r>
+          </a:p>
+          <a:p>
+            <a:pPr>
+              <a:spcBef>
+                <a:spcPts val="200"/>
+              </a:spcBef>
+            </a:pPr>
+            <a:r>
+              <a:rPr sz="1500">
+                <a:solidFill>
+                  <a:srgbClr val="A8FFC8"/>
+                </a:solidFill>
+                <a:latin typeface="Courier New"/>
+              </a:rPr>
+              <a:t>Frente: "My university [WON] the state championship last year."</a:t>
+            </a:r>
+          </a:p>
+          <a:p>
+            <a:pPr>
+              <a:spcBef>
+                <a:spcPts val="200"/>
+              </a:spcBef>
+            </a:pPr>
+            <a:r>
+              <a:rPr sz="1500">
+                <a:solidFill>
+                  <a:srgbClr val="A8FFC8"/>
+                </a:solidFill>
+                <a:latin typeface="Courier New"/>
+              </a:rPr>
+              <a:t>Verso:  won = ganhou</a:t>
             </a:r>
           </a:p>
         </p:txBody>
@@ -10417,7 +10449,7 @@
                 </a:solidFill>
                 <a:latin typeface="Courier New"/>
               </a:rPr>
-              <a:t>Frente: "Brazil defeated Sweden and _______ the trophy."</a:t>
+              <a:t>Dicionário: "The captain lifted the trophy after the final."</a:t>
             </a:r>
           </a:p>
           <a:p>
@@ -10433,7 +10465,7 @@
                 </a:solidFill>
                 <a:latin typeface="Courier New"/>
               </a:rPr>
-              <a:t>Verso:  lifted — levantou, ergueu</a:t>
+              <a:t>Substituição: trocar "The captain" → "Our team leader"</a:t>
             </a:r>
           </a:p>
           <a:p>
@@ -10449,7 +10481,7 @@
                 </a:solidFill>
                 <a:latin typeface="Courier New"/>
               </a:rPr>
-              <a:t>        Colocação: lift the trophy</a:t>
+              <a:t> </a:t>
             </a:r>
           </a:p>
           <a:p>
@@ -10465,7 +10497,23 @@
                 </a:solidFill>
                 <a:latin typeface="Courier New"/>
               </a:rPr>
-              <a:t>        Minha frase: "The captain lifted the trophy after the final."</a:t>
+              <a:t>Frente: "Our team leader [LIFTED] the award at the ceremony."</a:t>
+            </a:r>
+          </a:p>
+          <a:p>
+            <a:pPr>
+              <a:spcBef>
+                <a:spcPts val="200"/>
+              </a:spcBef>
+            </a:pPr>
+            <a:r>
+              <a:rPr sz="1400">
+                <a:solidFill>
+                  <a:srgbClr val="A8FFC8"/>
+                </a:solidFill>
+                <a:latin typeface="Courier New"/>
+              </a:rPr>
+              <a:t>Verso:  lifted = ergueu, levantou</a:t>
             </a:r>
           </a:p>
         </p:txBody>
@@ -11483,7 +11531,7 @@
         <p:spPr>
           <a:xfrm>
             <a:off x="365760" y="4572000"/>
-            <a:ext cx="11430000" cy="1280160"/>
+            <a:ext cx="11430000" cy="1417320"/>
           </a:xfrm>
           <a:prstGeom prst="rect">
             <a:avLst/>
@@ -11526,7 +11574,7 @@
         <p:spPr>
           <a:xfrm>
             <a:off x="548640" y="4709160"/>
-            <a:ext cx="11109960" cy="1051560"/>
+            <a:ext cx="11109960" cy="1188720"/>
           </a:xfrm>
           <a:prstGeom prst="rect">
             <a:avLst/>
@@ -11551,7 +11599,7 @@
                 </a:solidFill>
                 <a:latin typeface="Courier New"/>
               </a:rPr>
-              <a:t>Frente: "Brazil _______ Sweden in the final."</a:t>
+              <a:t>Dicionário: "Brazil defeated their opponents in the final."</a:t>
             </a:r>
           </a:p>
           <a:p>
@@ -11567,7 +11615,7 @@
                 </a:solidFill>
                 <a:latin typeface="Courier New"/>
               </a:rPr>
-              <a:t>Verso:  defeated — derrotou</a:t>
+              <a:t>Substituição: trocar "Brazil" → "Our class team"</a:t>
             </a:r>
           </a:p>
           <a:p>
@@ -11583,7 +11631,7 @@
                 </a:solidFill>
                 <a:latin typeface="Courier New"/>
               </a:rPr>
-              <a:t>        Colocação: defeat a team / defeat an opponent</a:t>
+              <a:t> </a:t>
             </a:r>
           </a:p>
           <a:p>
@@ -11599,7 +11647,23 @@
                 </a:solidFill>
                 <a:latin typeface="Courier New"/>
               </a:rPr>
-              <a:t>        Minha frase: "Brazil defeated Argentina in the semifinals."</a:t>
+              <a:t>Frente: "Our class team [DEFEATED] the opponents in the tournament."</a:t>
+            </a:r>
+          </a:p>
+          <a:p>
+            <a:pPr>
+              <a:spcBef>
+                <a:spcPts val="200"/>
+              </a:spcBef>
+            </a:pPr>
+            <a:r>
+              <a:rPr sz="1400">
+                <a:solidFill>
+                  <a:srgbClr val="A8FFC8"/>
+                </a:solidFill>
+                <a:latin typeface="Courier New"/>
+              </a:rPr>
+              <a:t>Verso:  defeated = derrotou</a:t>
             </a:r>
           </a:p>
         </p:txBody>
@@ -14379,7 +14443,7 @@
         <p:spPr>
           <a:xfrm>
             <a:off x="365760" y="4663440"/>
-            <a:ext cx="11430000" cy="1280160"/>
+            <a:ext cx="11430000" cy="1417320"/>
           </a:xfrm>
           <a:prstGeom prst="rect">
             <a:avLst/>
@@ -14422,7 +14486,7 @@
         <p:spPr>
           <a:xfrm>
             <a:off x="548640" y="4800600"/>
-            <a:ext cx="11109960" cy="1051560"/>
+            <a:ext cx="11109960" cy="1188720"/>
           </a:xfrm>
           <a:prstGeom prst="rect">
             <a:avLst/>
@@ -14447,7 +14511,7 @@
                 </a:solidFill>
                 <a:latin typeface="Courier New"/>
               </a:rPr>
-              <a:t>Frente: "Brazil has _______ in every single World Cup."</a:t>
+              <a:t>Dicionário: "The team competed in the national tournament."</a:t>
             </a:r>
           </a:p>
           <a:p>
@@ -14463,7 +14527,7 @@
                 </a:solidFill>
                 <a:latin typeface="Courier New"/>
               </a:rPr>
-              <a:t>Verso:  competed — competiu, participou</a:t>
+              <a:t>Substituição: trocar "The team" → "My university"</a:t>
             </a:r>
           </a:p>
           <a:p>
@@ -14479,7 +14543,7 @@
                 </a:solidFill>
                 <a:latin typeface="Courier New"/>
               </a:rPr>
-              <a:t>        Colocação: compete in the World Cup</a:t>
+              <a:t> </a:t>
             </a:r>
           </a:p>
           <a:p>
@@ -14495,7 +14559,23 @@
                 </a:solidFill>
                 <a:latin typeface="Courier New"/>
               </a:rPr>
-              <a:t>        Minha frase: "My university competed in the national championship."</a:t>
+              <a:t>Frente: "My university [COMPETED] in the regional tournament."</a:t>
+            </a:r>
+          </a:p>
+          <a:p>
+            <a:pPr>
+              <a:spcBef>
+                <a:spcPts val="200"/>
+              </a:spcBef>
+            </a:pPr>
+            <a:r>
+              <a:rPr sz="1400">
+                <a:solidFill>
+                  <a:srgbClr val="A8FFC8"/>
+                </a:solidFill>
+                <a:latin typeface="Courier New"/>
+              </a:rPr>
+              <a:t>Verso:  competed = competiu, participou</a:t>
             </a:r>
           </a:p>
         </p:txBody>
@@ -15514,7 +15594,7 @@
         <p:spPr>
           <a:xfrm>
             <a:off x="365760" y="4572000"/>
-            <a:ext cx="11430000" cy="1188720"/>
+            <a:ext cx="11430000" cy="1417320"/>
           </a:xfrm>
           <a:prstGeom prst="rect">
             <a:avLst/>
@@ -15557,7 +15637,7 @@
         <p:spPr>
           <a:xfrm>
             <a:off x="548640" y="4709160"/>
-            <a:ext cx="11109960" cy="960120"/>
+            <a:ext cx="11109960" cy="1188720"/>
           </a:xfrm>
           <a:prstGeom prst="rect">
             <a:avLst/>
@@ -15582,7 +15662,7 @@
                 </a:solidFill>
                 <a:latin typeface="Courier New"/>
               </a:rPr>
-              <a:t>Frente: "Many experts consider the 1970 _______ the best team ever."</a:t>
+              <a:t>Dicionário: "The coach selected the squad for the championship."</a:t>
             </a:r>
           </a:p>
           <a:p>
@@ -15598,7 +15678,7 @@
                 </a:solidFill>
                 <a:latin typeface="Courier New"/>
               </a:rPr>
-              <a:t>Verso:  squad — elenco, seleção</a:t>
+              <a:t>Substituição: trocar "The coach" → "Our professor"</a:t>
             </a:r>
           </a:p>
           <a:p>
@@ -15614,7 +15694,39 @@
                 </a:solidFill>
                 <a:latin typeface="Courier New"/>
               </a:rPr>
-              <a:t>        Minha frase: "The coach announced the squad for the World Cup."</a:t>
+              <a:t> </a:t>
+            </a:r>
+          </a:p>
+          <a:p>
+            <a:pPr>
+              <a:spcBef>
+                <a:spcPts val="200"/>
+              </a:spcBef>
+            </a:pPr>
+            <a:r>
+              <a:rPr sz="1400">
+                <a:solidFill>
+                  <a:srgbClr val="A8FFC8"/>
+                </a:solidFill>
+                <a:latin typeface="Courier New"/>
+              </a:rPr>
+              <a:t>Frente: "Our professor selected the [SQUAD] for the science fair."</a:t>
+            </a:r>
+          </a:p>
+          <a:p>
+            <a:pPr>
+              <a:spcBef>
+                <a:spcPts val="200"/>
+              </a:spcBef>
+            </a:pPr>
+            <a:r>
+              <a:rPr sz="1400">
+                <a:solidFill>
+                  <a:srgbClr val="A8FFC8"/>
+                </a:solidFill>
+                <a:latin typeface="Courier New"/>
+              </a:rPr>
+              <a:t>Verso:  squad = elenco, grupo selecionado</a:t>
             </a:r>
           </a:p>
         </p:txBody>
@@ -16555,7 +16667,7 @@
         <p:spPr>
           <a:xfrm>
             <a:off x="365760" y="3794760"/>
-            <a:ext cx="11430000" cy="594360"/>
+            <a:ext cx="11430000" cy="502920"/>
           </a:xfrm>
           <a:prstGeom prst="rect">
             <a:avLst/>
@@ -16598,7 +16710,7 @@
         <p:spPr>
           <a:xfrm>
             <a:off x="502920" y="3886200"/>
-            <a:ext cx="11201400" cy="457200"/>
+            <a:ext cx="11201400" cy="365760"/>
           </a:xfrm>
           <a:prstGeom prst="rect">
             <a:avLst/>
@@ -16618,7 +16730,7 @@
                   <a:srgbClr val="FFFFFF"/>
                 </a:solidFill>
               </a:rPr>
-              <a:t>ℹ  title é cognato parcial — o aluno pode reconhecer. O valor está na colocação: win the title / World Cup title.</a:t>
+              <a:t>ℹ  title parece título — cognato parcial. O aluno provavelmente já sabe.</a:t>
             </a:r>
           </a:p>
         </p:txBody>
@@ -16631,8 +16743,8 @@
         </p:nvSpPr>
         <p:spPr>
           <a:xfrm>
-            <a:off x="365760" y="4572000"/>
-            <a:ext cx="11430000" cy="1234440"/>
+            <a:off x="365760" y="4480560"/>
+            <a:ext cx="11430000" cy="1417320"/>
           </a:xfrm>
           <a:prstGeom prst="rect">
             <a:avLst/>
@@ -16674,8 +16786,8 @@
         </p:nvSpPr>
         <p:spPr>
           <a:xfrm>
-            <a:off x="548640" y="4709160"/>
-            <a:ext cx="11109960" cy="1005840"/>
+            <a:off x="548640" y="4617720"/>
+            <a:ext cx="11109960" cy="1188720"/>
           </a:xfrm>
           <a:prstGeom prst="rect">
             <a:avLst/>
@@ -16700,7 +16812,7 @@
                 </a:solidFill>
                 <a:latin typeface="Courier New"/>
               </a:rPr>
-              <a:t>Frente: "Brazil has won five World Cup _______."  </a:t>
+              <a:t>Dicionário: "The team won the championship title last year."</a:t>
             </a:r>
           </a:p>
           <a:p>
@@ -16716,7 +16828,7 @@
                 </a:solidFill>
                 <a:latin typeface="Courier New"/>
               </a:rPr>
-              <a:t>Verso:  title — título</a:t>
+              <a:t>Substituição: trocar "The team" → "Our lab"</a:t>
             </a:r>
           </a:p>
           <a:p>
@@ -16732,7 +16844,7 @@
                 </a:solidFill>
                 <a:latin typeface="Courier New"/>
               </a:rPr>
-              <a:t>        Colocação: win a title / World Cup title</a:t>
+              <a:t> </a:t>
             </a:r>
           </a:p>
           <a:p>
@@ -16748,7 +16860,23 @@
                 </a:solidFill>
                 <a:latin typeface="Courier New"/>
               </a:rPr>
-              <a:t>        Minha frase: "Brazil wants to win a sixth title in 2026."</a:t>
+              <a:t>Frente: "Our lab won the innovation [TITLE] at the conference."</a:t>
+            </a:r>
+          </a:p>
+          <a:p>
+            <a:pPr>
+              <a:spcBef>
+                <a:spcPts val="200"/>
+              </a:spcBef>
+            </a:pPr>
+            <a:r>
+              <a:rPr sz="1400">
+                <a:solidFill>
+                  <a:srgbClr val="A8FFC8"/>
+                </a:solidFill>
+                <a:latin typeface="Courier New"/>
+              </a:rPr>
+              <a:t>Verso:  title = título</a:t>
             </a:r>
           </a:p>
         </p:txBody>
@@ -17689,7 +17817,7 @@
         <p:spPr>
           <a:xfrm>
             <a:off x="365760" y="3794760"/>
-            <a:ext cx="11430000" cy="594360"/>
+            <a:ext cx="11430000" cy="502920"/>
           </a:xfrm>
           <a:prstGeom prst="rect">
             <a:avLst/>
@@ -17732,7 +17860,7 @@
         <p:spPr>
           <a:xfrm>
             <a:off x="502920" y="3886200"/>
-            <a:ext cx="11201400" cy="457200"/>
+            <a:ext cx="11201400" cy="365760"/>
           </a:xfrm>
           <a:prstGeom prst="rect">
             <a:avLst/>
@@ -17752,7 +17880,7 @@
                   <a:srgbClr val="FFFFFF"/>
                 </a:solidFill>
               </a:rPr>
-              <a:t>ℹ  rival é cognato direto — o aluno reconhece na hora. O valor do cartão está na colocação greatest rival.</a:t>
+              <a:t>ℹ  rival é cognato direto — o aluno reconhece na hora. Mesmo assim vale criar o cartão: a palavra existe no contexto do texto.</a:t>
             </a:r>
           </a:p>
         </p:txBody>
@@ -17765,8 +17893,8 @@
         </p:nvSpPr>
         <p:spPr>
           <a:xfrm>
-            <a:off x="365760" y="4572000"/>
-            <a:ext cx="11430000" cy="1234440"/>
+            <a:off x="365760" y="4480560"/>
+            <a:ext cx="11430000" cy="1417320"/>
           </a:xfrm>
           <a:prstGeom prst="rect">
             <a:avLst/>
@@ -17808,8 +17936,8 @@
         </p:nvSpPr>
         <p:spPr>
           <a:xfrm>
-            <a:off x="548640" y="4709160"/>
-            <a:ext cx="11109960" cy="1005840"/>
+            <a:off x="548640" y="4617720"/>
+            <a:ext cx="11109960" cy="1188720"/>
           </a:xfrm>
           <a:prstGeom prst="rect">
             <a:avLst/>
@@ -17834,7 +17962,7 @@
                 </a:solidFill>
                 <a:latin typeface="Courier New"/>
               </a:rPr>
-              <a:t>Frente: "Brazil's _______ rival is Argentina."</a:t>
+              <a:t>Dicionário: "The two clubs are great rivals in the championship."</a:t>
             </a:r>
           </a:p>
           <a:p>
@@ -17850,7 +17978,7 @@
                 </a:solidFill>
                 <a:latin typeface="Courier New"/>
               </a:rPr>
-              <a:t>Verso:  greatest rival — maior rival</a:t>
+              <a:t>Substituição: trocar "clubs" → "universities"</a:t>
             </a:r>
           </a:p>
           <a:p>
@@ -17866,7 +17994,7 @@
                 </a:solidFill>
                 <a:latin typeface="Courier New"/>
               </a:rPr>
-              <a:t>        Colocação: greatest rival / fierce rival</a:t>
+              <a:t> </a:t>
             </a:r>
           </a:p>
           <a:p>
@@ -17882,7 +18010,23 @@
                 </a:solidFill>
                 <a:latin typeface="Courier New"/>
               </a:rPr>
-              <a:t>        Minha frase: "Real Madrid's greatest rival is Barcelona."</a:t>
+              <a:t>Frente: "The two universities are great [RIVALS] in the championship."</a:t>
+            </a:r>
+          </a:p>
+          <a:p>
+            <a:pPr>
+              <a:spcBef>
+                <a:spcPts val="200"/>
+              </a:spcBef>
+            </a:pPr>
+            <a:r>
+              <a:rPr sz="1400">
+                <a:solidFill>
+                  <a:srgbClr val="A8FFC8"/>
+                </a:solidFill>
+                <a:latin typeface="Courier New"/>
+              </a:rPr>
+              <a:t>Verso:  rival = rival</a:t>
             </a:r>
           </a:p>
         </p:txBody>
@@ -18900,7 +19044,7 @@
         <p:spPr>
           <a:xfrm>
             <a:off x="365760" y="4572000"/>
-            <a:ext cx="11430000" cy="1234440"/>
+            <a:ext cx="11430000" cy="1417320"/>
           </a:xfrm>
           <a:prstGeom prst="rect">
             <a:avLst/>
@@ -18943,7 +19087,7 @@
         <p:spPr>
           <a:xfrm>
             <a:off x="548640" y="4709160"/>
-            <a:ext cx="11109960" cy="1005840"/>
+            <a:ext cx="11109960" cy="1188720"/>
           </a:xfrm>
           <a:prstGeom prst="rect">
             <a:avLst/>
@@ -18968,7 +19112,7 @@
                 </a:solidFill>
                 <a:latin typeface="Courier New"/>
               </a:rPr>
-              <a:t>Frente: "The two teams compete _______."  </a:t>
+              <a:t>Dicionário: "The athletes competed fiercely for the medal."</a:t>
             </a:r>
           </a:p>
           <a:p>
@@ -18984,7 +19128,7 @@
                 </a:solidFill>
                 <a:latin typeface="Courier New"/>
               </a:rPr>
-              <a:t>Verso:  fiercely — ferozmente, com intensidade</a:t>
+              <a:t>Substituição: trocar "The athletes" → "The students"</a:t>
             </a:r>
           </a:p>
           <a:p>
@@ -19000,7 +19144,7 @@
                 </a:solidFill>
                 <a:latin typeface="Courier New"/>
               </a:rPr>
-              <a:t>        Colocação: compete fiercely</a:t>
+              <a:t> </a:t>
             </a:r>
           </a:p>
           <a:p>
@@ -19016,7 +19160,23 @@
                 </a:solidFill>
                 <a:latin typeface="Courier New"/>
               </a:rPr>
-              <a:t>        Minha frase: "The students competed fiercely for the scholarship."</a:t>
+              <a:t>Frente: "The students competed [FIERCELY] for the scholarship."</a:t>
+            </a:r>
+          </a:p>
+          <a:p>
+            <a:pPr>
+              <a:spcBef>
+                <a:spcPts val="200"/>
+              </a:spcBef>
+            </a:pPr>
+            <a:r>
+              <a:rPr sz="1400">
+                <a:solidFill>
+                  <a:srgbClr val="A8FFC8"/>
+                </a:solidFill>
+                <a:latin typeface="Courier New"/>
+              </a:rPr>
+              <a:t>Verso:  fiercely = ferozmente, com intensidade</a:t>
             </a:r>
           </a:p>
         </p:txBody>
@@ -20034,7 +20194,7 @@
         <p:spPr>
           <a:xfrm>
             <a:off x="365760" y="4572000"/>
-            <a:ext cx="11430000" cy="1188720"/>
+            <a:ext cx="11430000" cy="1417320"/>
           </a:xfrm>
           <a:prstGeom prst="rect">
             <a:avLst/>
@@ -20077,7 +20237,7 @@
         <p:spPr>
           <a:xfrm>
             <a:off x="548640" y="4709160"/>
-            <a:ext cx="11109960" cy="960120"/>
+            <a:ext cx="11109960" cy="1188720"/>
           </a:xfrm>
           <a:prstGeom prst="rect">
             <a:avLst/>
@@ -20102,7 +20262,7 @@
                 </a:solidFill>
                 <a:latin typeface="Courier New"/>
               </a:rPr>
-              <a:t>Frente: "The team has talented players and a _______ squad."</a:t>
+              <a:t>Dicionário: "The project has a solid plan."</a:t>
             </a:r>
           </a:p>
           <a:p>
@@ -20118,7 +20278,7 @@
                 </a:solidFill>
                 <a:latin typeface="Courier New"/>
               </a:rPr>
-              <a:t>Verso:  solid — sólido, forte, consistente</a:t>
+              <a:t>Substituição: trocar "project" → "experiment"</a:t>
             </a:r>
           </a:p>
           <a:p>
@@ -20134,7 +20294,39 @@
                 </a:solidFill>
                 <a:latin typeface="Courier New"/>
               </a:rPr>
-              <a:t>        Minha frase: "Brazil has a solid squad for the 2026 World Cup."</a:t>
+              <a:t> </a:t>
+            </a:r>
+          </a:p>
+          <a:p>
+            <a:pPr>
+              <a:spcBef>
+                <a:spcPts val="200"/>
+              </a:spcBef>
+            </a:pPr>
+            <a:r>
+              <a:rPr sz="1400">
+                <a:solidFill>
+                  <a:srgbClr val="A8FFC8"/>
+                </a:solidFill>
+                <a:latin typeface="Courier New"/>
+              </a:rPr>
+              <a:t>Frente: "The experiment has a [SOLID] design."</a:t>
+            </a:r>
+          </a:p>
+          <a:p>
+            <a:pPr>
+              <a:spcBef>
+                <a:spcPts val="200"/>
+              </a:spcBef>
+            </a:pPr>
+            <a:r>
+              <a:rPr sz="1400">
+                <a:solidFill>
+                  <a:srgbClr val="A8FFC8"/>
+                </a:solidFill>
+                <a:latin typeface="Courier New"/>
+              </a:rPr>
+              <a:t>Verso:  solid = sólido, consistente</a:t>
             </a:r>
           </a:p>
         </p:txBody>
@@ -21152,7 +21344,7 @@
         <p:spPr>
           <a:xfrm>
             <a:off x="365760" y="4526280"/>
-            <a:ext cx="11430000" cy="1280160"/>
+            <a:ext cx="11430000" cy="1417320"/>
           </a:xfrm>
           <a:prstGeom prst="rect">
             <a:avLst/>
@@ -21195,7 +21387,7 @@
         <p:spPr>
           <a:xfrm>
             <a:off x="548640" y="4663440"/>
-            <a:ext cx="11109960" cy="1051560"/>
+            <a:ext cx="11109960" cy="1188720"/>
           </a:xfrm>
           <a:prstGeom prst="rect">
             <a:avLst/>
@@ -21220,7 +21412,7 @@
                 </a:solidFill>
                 <a:latin typeface="Courier New"/>
               </a:rPr>
-              <a:t>Frente: "_______ around the world hope Brazil will win a sixth title."</a:t>
+              <a:t>Dicionário: "Fans around the world watched the match on TV."</a:t>
             </a:r>
           </a:p>
           <a:p>
@@ -21236,7 +21428,7 @@
                 </a:solidFill>
                 <a:latin typeface="Courier New"/>
               </a:rPr>
-              <a:t>Verso:  fans — torcedores, fãs</a:t>
+              <a:t>Substituição: trocar "match" → "launch event"</a:t>
             </a:r>
           </a:p>
           <a:p>
@@ -21252,7 +21444,7 @@
                 </a:solidFill>
                 <a:latin typeface="Courier New"/>
               </a:rPr>
-              <a:t>        Colocação: fans around the world / football fans</a:t>
+              <a:t> </a:t>
             </a:r>
           </a:p>
           <a:p>
@@ -21268,7 +21460,23 @@
                 </a:solidFill>
                 <a:latin typeface="Courier New"/>
               </a:rPr>
-              <a:t>        Minha frase: "Fans around the world watched the final on TV."</a:t>
+              <a:t>Frente: "[FANS] of technology filled the auditorium for the launch event."</a:t>
+            </a:r>
+          </a:p>
+          <a:p>
+            <a:pPr>
+              <a:spcBef>
+                <a:spcPts val="200"/>
+              </a:spcBef>
+            </a:pPr>
+            <a:r>
+              <a:rPr sz="1400">
+                <a:solidFill>
+                  <a:srgbClr val="A8FFC8"/>
+                </a:solidFill>
+                <a:latin typeface="Courier New"/>
+              </a:rPr>
+              <a:t>Verso:  fans = torcedores, fãs</a:t>
             </a:r>
           </a:p>
         </p:txBody>
@@ -21772,7 +21980,7 @@
                   <a:srgbClr val="FFFFFF"/>
                 </a:solidFill>
               </a:rPr>
-              <a:t>Criou 10 cartões com frente cloze e frase própria</a:t>
+              <a:t>Criou 10 cartões no formato [MAIÚSCULO] com 1 substituição pessoal</a:t>
             </a:r>
           </a:p>
         </p:txBody>
@@ -23476,7 +23684,7 @@
                   <a:srgbClr val="2ECC71"/>
                 </a:solidFill>
               </a:rPr>
-              <a:t>10 cartões prontos para revisão</a:t>
+              <a:t>10 cartões: [MAIÚSCULO] + 1 substituição pessoal</a:t>
             </a:r>
           </a:p>
         </p:txBody>
@@ -24244,7 +24452,7 @@
                 </a:solidFill>
                 <a:latin typeface="Courier New"/>
               </a:rPr>
-              <a:t>"Copie a frase do texto e retire a palavra (deixe um blank).</a:t>
+              <a:t>"Encontre 1 exemplo de frase com a palavra num dicionário online.</a:t>
             </a:r>
           </a:p>
           <a:p>
@@ -24260,7 +24468,39 @@
                 </a:solidFill>
                 <a:latin typeface="Courier New"/>
               </a:rPr>
-              <a:t>No verso: escreva a tradução + uma frase sua trocando 1 palavra por algo da sua vida."</a:t>
+              <a:t>Troque 1 palavra do exemplo por algo da sua área ou vida.</a:t>
+            </a:r>
+          </a:p>
+          <a:p>
+            <a:pPr>
+              <a:spcBef>
+                <a:spcPts val="200"/>
+              </a:spcBef>
+            </a:pPr>
+            <a:r>
+              <a:rPr sz="1500">
+                <a:solidFill>
+                  <a:srgbClr val="A8FFC8"/>
+                </a:solidFill>
+                <a:latin typeface="Courier New"/>
+              </a:rPr>
+              <a:t>Frente: frase modificada com a palavra em [MAIÚSCULO].</a:t>
+            </a:r>
+          </a:p>
+          <a:p>
+            <a:pPr>
+              <a:spcBef>
+                <a:spcPts val="200"/>
+              </a:spcBef>
+            </a:pPr>
+            <a:r>
+              <a:rPr sz="1500">
+                <a:solidFill>
+                  <a:srgbClr val="A8FFC8"/>
+                </a:solidFill>
+                <a:latin typeface="Courier New"/>
+              </a:rPr>
+              <a:t>Verso:  palavra = tradução em português."</a:t>
             </a:r>
           </a:p>
         </p:txBody>

</xml_diff>

<commit_message>
feat(tools): add .env support to manage_users.py
- Script auto-loads manage_users.env from its own directory
- All CLI params now have .env equivalents (LOCAL_DB, PROD_HOST, etc.)
- Added manage_users.env.example as template (not committed)
- Added manage_users.env to .gitignore
- Updated MANAGE_USERS_QUICKSTART.md with simplified commands

Co-Authored-By: Claude Sonnet 4.6 <noreply@anthropic.com>
</commit_message>
<xml_diff>
--- a/placement_exam/planning_E02/E02_slides_Tier1_Duas_Passagem_v1.0.pptx
+++ b/placement_exam/planning_E02/E02_slides_Tier1_Duas_Passagem_v1.0.pptx
@@ -5,37 +5,37 @@
     <p:sldMasterId id="2147483648" r:id="rId1"/>
   </p:sldMasterIdLst>
   <p:sldIdLst>
-    <p:sldId id="256" r:id="rId7"/>
-    <p:sldId id="257" r:id="rId8"/>
-    <p:sldId id="258" r:id="rId9"/>
-    <p:sldId id="259" r:id="rId10"/>
-    <p:sldId id="260" r:id="rId11"/>
-    <p:sldId id="261" r:id="rId12"/>
-    <p:sldId id="262" r:id="rId13"/>
-    <p:sldId id="263" r:id="rId14"/>
-    <p:sldId id="264" r:id="rId15"/>
-    <p:sldId id="265" r:id="rId16"/>
-    <p:sldId id="266" r:id="rId17"/>
-    <p:sldId id="267" r:id="rId18"/>
-    <p:sldId id="268" r:id="rId19"/>
-    <p:sldId id="269" r:id="rId20"/>
-    <p:sldId id="270" r:id="rId21"/>
-    <p:sldId id="271" r:id="rId22"/>
-    <p:sldId id="272" r:id="rId23"/>
-    <p:sldId id="273" r:id="rId24"/>
-    <p:sldId id="274" r:id="rId25"/>
-    <p:sldId id="275" r:id="rId26"/>
-    <p:sldId id="276" r:id="rId27"/>
-    <p:sldId id="277" r:id="rId28"/>
-    <p:sldId id="278" r:id="rId29"/>
-    <p:sldId id="279" r:id="rId30"/>
-    <p:sldId id="280" r:id="rId31"/>
-    <p:sldId id="281" r:id="rId32"/>
-    <p:sldId id="282" r:id="rId33"/>
-    <p:sldId id="283" r:id="rId34"/>
-    <p:sldId id="284" r:id="rId35"/>
+    <p:sldId id="256" r:id="rId2"/>
+    <p:sldId id="257" r:id="rId3"/>
+    <p:sldId id="258" r:id="rId4"/>
+    <p:sldId id="259" r:id="rId5"/>
+    <p:sldId id="260" r:id="rId6"/>
+    <p:sldId id="261" r:id="rId7"/>
+    <p:sldId id="262" r:id="rId8"/>
+    <p:sldId id="263" r:id="rId9"/>
+    <p:sldId id="264" r:id="rId10"/>
+    <p:sldId id="265" r:id="rId11"/>
+    <p:sldId id="266" r:id="rId12"/>
+    <p:sldId id="267" r:id="rId13"/>
+    <p:sldId id="268" r:id="rId14"/>
+    <p:sldId id="269" r:id="rId15"/>
+    <p:sldId id="270" r:id="rId16"/>
+    <p:sldId id="271" r:id="rId17"/>
+    <p:sldId id="272" r:id="rId18"/>
+    <p:sldId id="273" r:id="rId19"/>
+    <p:sldId id="274" r:id="rId20"/>
+    <p:sldId id="275" r:id="rId21"/>
+    <p:sldId id="276" r:id="rId22"/>
+    <p:sldId id="277" r:id="rId23"/>
+    <p:sldId id="278" r:id="rId24"/>
+    <p:sldId id="279" r:id="rId25"/>
+    <p:sldId id="280" r:id="rId26"/>
+    <p:sldId id="281" r:id="rId27"/>
+    <p:sldId id="282" r:id="rId28"/>
+    <p:sldId id="283" r:id="rId29"/>
+    <p:sldId id="284" r:id="rId30"/>
   </p:sldIdLst>
-  <p:sldSz cx="12188952" cy="6858000" type="screen4x3"/>
+  <p:sldSz cx="12188825" cy="6858000"/>
   <p:notesSz cx="6858000" cy="9144000"/>
   <p:defaultTextStyle>
     <a:defPPr>
@@ -132,6 +132,22 @@
       </a:defRPr>
     </a:lvl9pPr>
   </p:defaultTextStyle>
+  <p:extLst>
+    <p:ext uri="{EFAFB233-063F-42B5-8137-9DF3F51BA10A}">
+      <p15:sldGuideLst xmlns:p15="http://schemas.microsoft.com/office/powerpoint/2012/main">
+        <p15:guide id="1" orient="horz" pos="2160">
+          <p15:clr>
+            <a:srgbClr val="A4A3A4"/>
+          </p15:clr>
+        </p15:guide>
+        <p15:guide id="2" pos="2880">
+          <p15:clr>
+            <a:srgbClr val="A4A3A4"/>
+          </p15:clr>
+        </p15:guide>
+      </p15:sldGuideLst>
+    </p:ext>
+  </p:extLst>
 </p:presentation>
 </file>
 
@@ -173,10 +189,9 @@
           <a:lstStyle/>
           <a:p>
             <a:r>
-              <a:rPr lang="en-US" smtClean="0"/>
+              <a:rPr lang="en-US"/>
               <a:t>Click to edit Master title style</a:t>
             </a:r>
-            <a:endParaRPr lang="en-US"/>
           </a:p>
         </p:txBody>
       </p:sp>
@@ -292,10 +307,9 @@
           </a:lstStyle>
           <a:p>
             <a:r>
-              <a:rPr lang="en-US" smtClean="0"/>
+              <a:rPr lang="en-US"/>
               <a:t>Click to edit Master subtitle style</a:t>
             </a:r>
-            <a:endParaRPr lang="en-US"/>
           </a:p>
         </p:txBody>
       </p:sp>
@@ -316,7 +330,7 @@
           <a:p>
             <a:fld id="{5BCAD085-E8A6-8845-BD4E-CB4CCA059FC4}" type="datetimeFigureOut">
               <a:rPr lang="en-US" smtClean="0"/>
-              <a:t>1/27/13</a:t>
+              <a:t>4/6/26</a:t>
             </a:fld>
             <a:endParaRPr lang="en-US"/>
           </a:p>
@@ -410,10 +424,9 @@
           <a:lstStyle/>
           <a:p>
             <a:r>
-              <a:rPr lang="en-US" smtClean="0"/>
+              <a:rPr lang="en-US"/>
               <a:t>Click to edit Master title style</a:t>
             </a:r>
-            <a:endParaRPr lang="en-US"/>
           </a:p>
         </p:txBody>
       </p:sp>
@@ -434,38 +447,37 @@
           <a:p>
             <a:pPr lvl="0"/>
             <a:r>
-              <a:rPr lang="en-US" smtClean="0"/>
+              <a:rPr lang="en-US"/>
               <a:t>Click to edit Master text styles</a:t>
             </a:r>
           </a:p>
           <a:p>
             <a:pPr lvl="1"/>
             <a:r>
-              <a:rPr lang="en-US" smtClean="0"/>
+              <a:rPr lang="en-US"/>
               <a:t>Second level</a:t>
             </a:r>
           </a:p>
           <a:p>
             <a:pPr lvl="2"/>
             <a:r>
-              <a:rPr lang="en-US" smtClean="0"/>
+              <a:rPr lang="en-US"/>
               <a:t>Third level</a:t>
             </a:r>
           </a:p>
           <a:p>
             <a:pPr lvl="3"/>
             <a:r>
-              <a:rPr lang="en-US" smtClean="0"/>
+              <a:rPr lang="en-US"/>
               <a:t>Fourth level</a:t>
             </a:r>
           </a:p>
           <a:p>
             <a:pPr lvl="4"/>
             <a:r>
-              <a:rPr lang="en-US" smtClean="0"/>
+              <a:rPr lang="en-US"/>
               <a:t>Fifth level</a:t>
             </a:r>
-            <a:endParaRPr lang="en-US"/>
           </a:p>
         </p:txBody>
       </p:sp>
@@ -486,7 +498,7 @@
           <a:p>
             <a:fld id="{5BCAD085-E8A6-8845-BD4E-CB4CCA059FC4}" type="datetimeFigureOut">
               <a:rPr lang="en-US" smtClean="0"/>
-              <a:t>1/27/13</a:t>
+              <a:t>4/6/26</a:t>
             </a:fld>
             <a:endParaRPr lang="en-US"/>
           </a:p>
@@ -585,10 +597,9 @@
           <a:lstStyle/>
           <a:p>
             <a:r>
-              <a:rPr lang="en-US" smtClean="0"/>
+              <a:rPr lang="en-US"/>
               <a:t>Click to edit Master title style</a:t>
             </a:r>
-            <a:endParaRPr lang="en-US"/>
           </a:p>
         </p:txBody>
       </p:sp>
@@ -614,38 +625,37 @@
           <a:p>
             <a:pPr lvl="0"/>
             <a:r>
-              <a:rPr lang="en-US" smtClean="0"/>
+              <a:rPr lang="en-US"/>
               <a:t>Click to edit Master text styles</a:t>
             </a:r>
           </a:p>
           <a:p>
             <a:pPr lvl="1"/>
             <a:r>
-              <a:rPr lang="en-US" smtClean="0"/>
+              <a:rPr lang="en-US"/>
               <a:t>Second level</a:t>
             </a:r>
           </a:p>
           <a:p>
             <a:pPr lvl="2"/>
             <a:r>
-              <a:rPr lang="en-US" smtClean="0"/>
+              <a:rPr lang="en-US"/>
               <a:t>Third level</a:t>
             </a:r>
           </a:p>
           <a:p>
             <a:pPr lvl="3"/>
             <a:r>
-              <a:rPr lang="en-US" smtClean="0"/>
+              <a:rPr lang="en-US"/>
               <a:t>Fourth level</a:t>
             </a:r>
           </a:p>
           <a:p>
             <a:pPr lvl="4"/>
             <a:r>
-              <a:rPr lang="en-US" smtClean="0"/>
+              <a:rPr lang="en-US"/>
               <a:t>Fifth level</a:t>
             </a:r>
-            <a:endParaRPr lang="en-US"/>
           </a:p>
         </p:txBody>
       </p:sp>
@@ -666,7 +676,7 @@
           <a:p>
             <a:fld id="{5BCAD085-E8A6-8845-BD4E-CB4CCA059FC4}" type="datetimeFigureOut">
               <a:rPr lang="en-US" smtClean="0"/>
-              <a:t>1/27/13</a:t>
+              <a:t>4/6/26</a:t>
             </a:fld>
             <a:endParaRPr lang="en-US"/>
           </a:p>
@@ -760,10 +770,9 @@
           <a:lstStyle/>
           <a:p>
             <a:r>
-              <a:rPr lang="en-US" smtClean="0"/>
+              <a:rPr lang="en-US"/>
               <a:t>Click to edit Master title style</a:t>
             </a:r>
-            <a:endParaRPr lang="en-US"/>
           </a:p>
         </p:txBody>
       </p:sp>
@@ -784,38 +793,37 @@
           <a:p>
             <a:pPr lvl="0"/>
             <a:r>
-              <a:rPr lang="en-US" smtClean="0"/>
+              <a:rPr lang="en-US"/>
               <a:t>Click to edit Master text styles</a:t>
             </a:r>
           </a:p>
           <a:p>
             <a:pPr lvl="1"/>
             <a:r>
-              <a:rPr lang="en-US" smtClean="0"/>
+              <a:rPr lang="en-US"/>
               <a:t>Second level</a:t>
             </a:r>
           </a:p>
           <a:p>
             <a:pPr lvl="2"/>
             <a:r>
-              <a:rPr lang="en-US" smtClean="0"/>
+              <a:rPr lang="en-US"/>
               <a:t>Third level</a:t>
             </a:r>
           </a:p>
           <a:p>
             <a:pPr lvl="3"/>
             <a:r>
-              <a:rPr lang="en-US" smtClean="0"/>
+              <a:rPr lang="en-US"/>
               <a:t>Fourth level</a:t>
             </a:r>
           </a:p>
           <a:p>
             <a:pPr lvl="4"/>
             <a:r>
-              <a:rPr lang="en-US" smtClean="0"/>
+              <a:rPr lang="en-US"/>
               <a:t>Fifth level</a:t>
             </a:r>
-            <a:endParaRPr lang="en-US"/>
           </a:p>
         </p:txBody>
       </p:sp>
@@ -836,7 +844,7 @@
           <a:p>
             <a:fld id="{5BCAD085-E8A6-8845-BD4E-CB4CCA059FC4}" type="datetimeFigureOut">
               <a:rPr lang="en-US" smtClean="0"/>
-              <a:t>1/27/13</a:t>
+              <a:t>4/6/26</a:t>
             </a:fld>
             <a:endParaRPr lang="en-US"/>
           </a:p>
@@ -939,10 +947,9 @@
           </a:lstStyle>
           <a:p>
             <a:r>
-              <a:rPr lang="en-US" smtClean="0"/>
+              <a:rPr lang="en-US"/>
               <a:t>Click to edit Master title style</a:t>
             </a:r>
-            <a:endParaRPr lang="en-US"/>
           </a:p>
         </p:txBody>
       </p:sp>
@@ -1059,7 +1066,7 @@
           <a:p>
             <a:pPr lvl="0"/>
             <a:r>
-              <a:rPr lang="en-US" smtClean="0"/>
+              <a:rPr lang="en-US"/>
               <a:t>Click to edit Master text styles</a:t>
             </a:r>
           </a:p>
@@ -1082,7 +1089,7 @@
           <a:p>
             <a:fld id="{5BCAD085-E8A6-8845-BD4E-CB4CCA059FC4}" type="datetimeFigureOut">
               <a:rPr lang="en-US" smtClean="0"/>
-              <a:t>1/27/13</a:t>
+              <a:t>4/6/26</a:t>
             </a:fld>
             <a:endParaRPr lang="en-US"/>
           </a:p>
@@ -1176,10 +1183,9 @@
           <a:lstStyle/>
           <a:p>
             <a:r>
-              <a:rPr lang="en-US" smtClean="0"/>
+              <a:rPr lang="en-US"/>
               <a:t>Click to edit Master title style</a:t>
             </a:r>
-            <a:endParaRPr lang="en-US"/>
           </a:p>
         </p:txBody>
       </p:sp>
@@ -1233,38 +1239,37 @@
           <a:p>
             <a:pPr lvl="0"/>
             <a:r>
-              <a:rPr lang="en-US" smtClean="0"/>
+              <a:rPr lang="en-US"/>
               <a:t>Click to edit Master text styles</a:t>
             </a:r>
           </a:p>
           <a:p>
             <a:pPr lvl="1"/>
             <a:r>
-              <a:rPr lang="en-US" smtClean="0"/>
+              <a:rPr lang="en-US"/>
               <a:t>Second level</a:t>
             </a:r>
           </a:p>
           <a:p>
             <a:pPr lvl="2"/>
             <a:r>
-              <a:rPr lang="en-US" smtClean="0"/>
+              <a:rPr lang="en-US"/>
               <a:t>Third level</a:t>
             </a:r>
           </a:p>
           <a:p>
             <a:pPr lvl="3"/>
             <a:r>
-              <a:rPr lang="en-US" smtClean="0"/>
+              <a:rPr lang="en-US"/>
               <a:t>Fourth level</a:t>
             </a:r>
           </a:p>
           <a:p>
             <a:pPr lvl="4"/>
             <a:r>
-              <a:rPr lang="en-US" smtClean="0"/>
+              <a:rPr lang="en-US"/>
               <a:t>Fifth level</a:t>
             </a:r>
-            <a:endParaRPr lang="en-US"/>
           </a:p>
         </p:txBody>
       </p:sp>
@@ -1318,38 +1323,37 @@
           <a:p>
             <a:pPr lvl="0"/>
             <a:r>
-              <a:rPr lang="en-US" smtClean="0"/>
+              <a:rPr lang="en-US"/>
               <a:t>Click to edit Master text styles</a:t>
             </a:r>
           </a:p>
           <a:p>
             <a:pPr lvl="1"/>
             <a:r>
-              <a:rPr lang="en-US" smtClean="0"/>
+              <a:rPr lang="en-US"/>
               <a:t>Second level</a:t>
             </a:r>
           </a:p>
           <a:p>
             <a:pPr lvl="2"/>
             <a:r>
-              <a:rPr lang="en-US" smtClean="0"/>
+              <a:rPr lang="en-US"/>
               <a:t>Third level</a:t>
             </a:r>
           </a:p>
           <a:p>
             <a:pPr lvl="3"/>
             <a:r>
-              <a:rPr lang="en-US" smtClean="0"/>
+              <a:rPr lang="en-US"/>
               <a:t>Fourth level</a:t>
             </a:r>
           </a:p>
           <a:p>
             <a:pPr lvl="4"/>
             <a:r>
-              <a:rPr lang="en-US" smtClean="0"/>
+              <a:rPr lang="en-US"/>
               <a:t>Fifth level</a:t>
             </a:r>
-            <a:endParaRPr lang="en-US"/>
           </a:p>
         </p:txBody>
       </p:sp>
@@ -1370,7 +1374,7 @@
           <a:p>
             <a:fld id="{5BCAD085-E8A6-8845-BD4E-CB4CCA059FC4}" type="datetimeFigureOut">
               <a:rPr lang="en-US" smtClean="0"/>
-              <a:t>1/27/13</a:t>
+              <a:t>4/6/26</a:t>
             </a:fld>
             <a:endParaRPr lang="en-US"/>
           </a:p>
@@ -1468,10 +1472,9 @@
           </a:lstStyle>
           <a:p>
             <a:r>
-              <a:rPr lang="en-US" smtClean="0"/>
+              <a:rPr lang="en-US"/>
               <a:t>Click to edit Master title style</a:t>
             </a:r>
-            <a:endParaRPr lang="en-US"/>
           </a:p>
         </p:txBody>
       </p:sp>
@@ -1534,7 +1537,7 @@
           <a:p>
             <a:pPr lvl="0"/>
             <a:r>
-              <a:rPr lang="en-US" smtClean="0"/>
+              <a:rPr lang="en-US"/>
               <a:t>Click to edit Master text styles</a:t>
             </a:r>
           </a:p>
@@ -1590,38 +1593,37 @@
           <a:p>
             <a:pPr lvl="0"/>
             <a:r>
-              <a:rPr lang="en-US" smtClean="0"/>
+              <a:rPr lang="en-US"/>
               <a:t>Click to edit Master text styles</a:t>
             </a:r>
           </a:p>
           <a:p>
             <a:pPr lvl="1"/>
             <a:r>
-              <a:rPr lang="en-US" smtClean="0"/>
+              <a:rPr lang="en-US"/>
               <a:t>Second level</a:t>
             </a:r>
           </a:p>
           <a:p>
             <a:pPr lvl="2"/>
             <a:r>
-              <a:rPr lang="en-US" smtClean="0"/>
+              <a:rPr lang="en-US"/>
               <a:t>Third level</a:t>
             </a:r>
           </a:p>
           <a:p>
             <a:pPr lvl="3"/>
             <a:r>
-              <a:rPr lang="en-US" smtClean="0"/>
+              <a:rPr lang="en-US"/>
               <a:t>Fourth level</a:t>
             </a:r>
           </a:p>
           <a:p>
             <a:pPr lvl="4"/>
             <a:r>
-              <a:rPr lang="en-US" smtClean="0"/>
+              <a:rPr lang="en-US"/>
               <a:t>Fifth level</a:t>
             </a:r>
-            <a:endParaRPr lang="en-US"/>
           </a:p>
         </p:txBody>
       </p:sp>
@@ -1684,7 +1686,7 @@
           <a:p>
             <a:pPr lvl="0"/>
             <a:r>
-              <a:rPr lang="en-US" smtClean="0"/>
+              <a:rPr lang="en-US"/>
               <a:t>Click to edit Master text styles</a:t>
             </a:r>
           </a:p>
@@ -1740,38 +1742,37 @@
           <a:p>
             <a:pPr lvl="0"/>
             <a:r>
-              <a:rPr lang="en-US" smtClean="0"/>
+              <a:rPr lang="en-US"/>
               <a:t>Click to edit Master text styles</a:t>
             </a:r>
           </a:p>
           <a:p>
             <a:pPr lvl="1"/>
             <a:r>
-              <a:rPr lang="en-US" smtClean="0"/>
+              <a:rPr lang="en-US"/>
               <a:t>Second level</a:t>
             </a:r>
           </a:p>
           <a:p>
             <a:pPr lvl="2"/>
             <a:r>
-              <a:rPr lang="en-US" smtClean="0"/>
+              <a:rPr lang="en-US"/>
               <a:t>Third level</a:t>
             </a:r>
           </a:p>
           <a:p>
             <a:pPr lvl="3"/>
             <a:r>
-              <a:rPr lang="en-US" smtClean="0"/>
+              <a:rPr lang="en-US"/>
               <a:t>Fourth level</a:t>
             </a:r>
           </a:p>
           <a:p>
             <a:pPr lvl="4"/>
             <a:r>
-              <a:rPr lang="en-US" smtClean="0"/>
+              <a:rPr lang="en-US"/>
               <a:t>Fifth level</a:t>
             </a:r>
-            <a:endParaRPr lang="en-US"/>
           </a:p>
         </p:txBody>
       </p:sp>
@@ -1792,7 +1793,7 @@
           <a:p>
             <a:fld id="{5BCAD085-E8A6-8845-BD4E-CB4CCA059FC4}" type="datetimeFigureOut">
               <a:rPr lang="en-US" smtClean="0"/>
-              <a:t>1/27/13</a:t>
+              <a:t>4/6/26</a:t>
             </a:fld>
             <a:endParaRPr lang="en-US"/>
           </a:p>
@@ -1886,10 +1887,9 @@
           <a:lstStyle/>
           <a:p>
             <a:r>
-              <a:rPr lang="en-US" smtClean="0"/>
+              <a:rPr lang="en-US"/>
               <a:t>Click to edit Master title style</a:t>
             </a:r>
-            <a:endParaRPr lang="en-US"/>
           </a:p>
         </p:txBody>
       </p:sp>
@@ -1910,7 +1910,7 @@
           <a:p>
             <a:fld id="{5BCAD085-E8A6-8845-BD4E-CB4CCA059FC4}" type="datetimeFigureOut">
               <a:rPr lang="en-US" smtClean="0"/>
-              <a:t>1/27/13</a:t>
+              <a:t>4/6/26</a:t>
             </a:fld>
             <a:endParaRPr lang="en-US"/>
           </a:p>
@@ -2005,7 +2005,7 @@
           <a:p>
             <a:fld id="{5BCAD085-E8A6-8845-BD4E-CB4CCA059FC4}" type="datetimeFigureOut">
               <a:rPr lang="en-US" smtClean="0"/>
-              <a:t>1/27/13</a:t>
+              <a:t>4/6/26</a:t>
             </a:fld>
             <a:endParaRPr lang="en-US"/>
           </a:p>
@@ -2108,10 +2108,9 @@
           </a:lstStyle>
           <a:p>
             <a:r>
-              <a:rPr lang="en-US" smtClean="0"/>
+              <a:rPr lang="en-US"/>
               <a:t>Click to edit Master title style</a:t>
             </a:r>
-            <a:endParaRPr lang="en-US"/>
           </a:p>
         </p:txBody>
       </p:sp>
@@ -2165,38 +2164,37 @@
           <a:p>
             <a:pPr lvl="0"/>
             <a:r>
-              <a:rPr lang="en-US" smtClean="0"/>
+              <a:rPr lang="en-US"/>
               <a:t>Click to edit Master text styles</a:t>
             </a:r>
           </a:p>
           <a:p>
             <a:pPr lvl="1"/>
             <a:r>
-              <a:rPr lang="en-US" smtClean="0"/>
+              <a:rPr lang="en-US"/>
               <a:t>Second level</a:t>
             </a:r>
           </a:p>
           <a:p>
             <a:pPr lvl="2"/>
             <a:r>
-              <a:rPr lang="en-US" smtClean="0"/>
+              <a:rPr lang="en-US"/>
               <a:t>Third level</a:t>
             </a:r>
           </a:p>
           <a:p>
             <a:pPr lvl="3"/>
             <a:r>
-              <a:rPr lang="en-US" smtClean="0"/>
+              <a:rPr lang="en-US"/>
               <a:t>Fourth level</a:t>
             </a:r>
           </a:p>
           <a:p>
             <a:pPr lvl="4"/>
             <a:r>
-              <a:rPr lang="en-US" smtClean="0"/>
+              <a:rPr lang="en-US"/>
               <a:t>Fifth level</a:t>
             </a:r>
-            <a:endParaRPr lang="en-US"/>
           </a:p>
         </p:txBody>
       </p:sp>
@@ -2259,7 +2257,7 @@
           <a:p>
             <a:pPr lvl="0"/>
             <a:r>
-              <a:rPr lang="en-US" smtClean="0"/>
+              <a:rPr lang="en-US"/>
               <a:t>Click to edit Master text styles</a:t>
             </a:r>
           </a:p>
@@ -2282,7 +2280,7 @@
           <a:p>
             <a:fld id="{5BCAD085-E8A6-8845-BD4E-CB4CCA059FC4}" type="datetimeFigureOut">
               <a:rPr lang="en-US" smtClean="0"/>
-              <a:t>1/27/13</a:t>
+              <a:t>4/6/26</a:t>
             </a:fld>
             <a:endParaRPr lang="en-US"/>
           </a:p>
@@ -2385,10 +2383,9 @@
           </a:lstStyle>
           <a:p>
             <a:r>
-              <a:rPr lang="en-US" smtClean="0"/>
+              <a:rPr lang="en-US"/>
               <a:t>Click to edit Master title style</a:t>
             </a:r>
-            <a:endParaRPr lang="en-US"/>
           </a:p>
         </p:txBody>
       </p:sp>
@@ -2512,7 +2509,7 @@
           <a:p>
             <a:pPr lvl="0"/>
             <a:r>
-              <a:rPr lang="en-US" smtClean="0"/>
+              <a:rPr lang="en-US"/>
               <a:t>Click to edit Master text styles</a:t>
             </a:r>
           </a:p>
@@ -2535,7 +2532,7 @@
           <a:p>
             <a:fld id="{5BCAD085-E8A6-8845-BD4E-CB4CCA059FC4}" type="datetimeFigureOut">
               <a:rPr lang="en-US" smtClean="0"/>
-              <a:t>1/27/13</a:t>
+              <a:t>4/6/26</a:t>
             </a:fld>
             <a:endParaRPr lang="en-US"/>
           </a:p>
@@ -2644,10 +2641,9 @@
           <a:lstStyle/>
           <a:p>
             <a:r>
-              <a:rPr lang="en-US" smtClean="0"/>
+              <a:rPr lang="en-US"/>
               <a:t>Click to edit Master title style</a:t>
             </a:r>
-            <a:endParaRPr lang="en-US"/>
           </a:p>
         </p:txBody>
       </p:sp>
@@ -2678,38 +2674,37 @@
           <a:p>
             <a:pPr lvl="0"/>
             <a:r>
-              <a:rPr lang="en-US" smtClean="0"/>
+              <a:rPr lang="en-US"/>
               <a:t>Click to edit Master text styles</a:t>
             </a:r>
           </a:p>
           <a:p>
             <a:pPr lvl="1"/>
             <a:r>
-              <a:rPr lang="en-US" smtClean="0"/>
+              <a:rPr lang="en-US"/>
               <a:t>Second level</a:t>
             </a:r>
           </a:p>
           <a:p>
             <a:pPr lvl="2"/>
             <a:r>
-              <a:rPr lang="en-US" smtClean="0"/>
+              <a:rPr lang="en-US"/>
               <a:t>Third level</a:t>
             </a:r>
           </a:p>
           <a:p>
             <a:pPr lvl="3"/>
             <a:r>
-              <a:rPr lang="en-US" smtClean="0"/>
+              <a:rPr lang="en-US"/>
               <a:t>Fourth level</a:t>
             </a:r>
           </a:p>
           <a:p>
             <a:pPr lvl="4"/>
             <a:r>
-              <a:rPr lang="en-US" smtClean="0"/>
+              <a:rPr lang="en-US"/>
               <a:t>Fifth level</a:t>
             </a:r>
-            <a:endParaRPr lang="en-US"/>
           </a:p>
         </p:txBody>
       </p:sp>
@@ -2748,7 +2743,7 @@
           <a:p>
             <a:fld id="{5BCAD085-E8A6-8845-BD4E-CB4CCA059FC4}" type="datetimeFigureOut">
               <a:rPr lang="en-US" smtClean="0"/>
-              <a:t>1/27/13</a:t>
+              <a:t>4/6/26</a:t>
             </a:fld>
             <a:endParaRPr lang="en-US"/>
           </a:p>
@@ -3107,7 +3102,7 @@
 </file>
 
 <file path=ppt/slides/slide1.xml><?xml version="1.0" encoding="utf-8"?>
-<p:sld xmlns:a="http://schemas.openxmlformats.org/drawingml/2006/main" xmlns:p="http://schemas.openxmlformats.org/presentationml/2006/main" xmlns:r="http://schemas.openxmlformats.org/officeDocument/2006/relationships">
+<p:sld xmlns:a="http://schemas.openxmlformats.org/drawingml/2006/main" xmlns:r="http://schemas.openxmlformats.org/officeDocument/2006/relationships" xmlns:p="http://schemas.openxmlformats.org/presentationml/2006/main">
   <p:cSld>
     <p:bg>
       <p:bgPr>
@@ -3123,7 +3118,14 @@
         <p:cNvGrpSpPr/>
         <p:nvPr/>
       </p:nvGrpSpPr>
-      <p:grpSpPr/>
+      <p:grpSpPr>
+        <a:xfrm>
+          <a:off x="0" y="0"/>
+          <a:ext cx="0" cy="0"/>
+          <a:chOff x="0" y="0"/>
+          <a:chExt cx="0" cy="0"/>
+        </a:xfrm>
+      </p:grpSpPr>
       <p:sp>
         <p:nvSpPr>
           <p:cNvPr id="2" name="Rectangle 1"/>
@@ -3164,6 +3166,7 @@
           <a:lstStyle/>
           <a:p>
             <a:pPr algn="ctr"/>
+            <a:endParaRPr/>
           </a:p>
         </p:txBody>
       </p:sp>
@@ -3275,6 +3278,7 @@
           <a:lstStyle/>
           <a:p>
             <a:pPr algn="ctr"/>
+            <a:endParaRPr/>
           </a:p>
         </p:txBody>
       </p:sp>
@@ -3355,7 +3359,7 @@
 </file>
 
 <file path=ppt/slides/slide10.xml><?xml version="1.0" encoding="utf-8"?>
-<p:sld xmlns:a="http://schemas.openxmlformats.org/drawingml/2006/main" xmlns:p="http://schemas.openxmlformats.org/presentationml/2006/main" xmlns:r="http://schemas.openxmlformats.org/officeDocument/2006/relationships">
+<p:sld xmlns:a="http://schemas.openxmlformats.org/drawingml/2006/main" xmlns:r="http://schemas.openxmlformats.org/officeDocument/2006/relationships" xmlns:p="http://schemas.openxmlformats.org/presentationml/2006/main">
   <p:cSld>
     <p:bg>
       <p:bgPr>
@@ -3371,7 +3375,14 @@
         <p:cNvGrpSpPr/>
         <p:nvPr/>
       </p:nvGrpSpPr>
-      <p:grpSpPr/>
+      <p:grpSpPr>
+        <a:xfrm>
+          <a:off x="0" y="0"/>
+          <a:ext cx="0" cy="0"/>
+          <a:chOff x="0" y="0"/>
+          <a:chExt cx="0" cy="0"/>
+        </a:xfrm>
+      </p:grpSpPr>
       <p:sp>
         <p:nvSpPr>
           <p:cNvPr id="2" name="Rectangle 1"/>
@@ -3412,6 +3423,7 @@
           <a:lstStyle/>
           <a:p>
             <a:pPr algn="ctr"/>
+            <a:endParaRPr/>
           </a:p>
         </p:txBody>
       </p:sp>
@@ -3525,6 +3537,7 @@
           <a:lstStyle/>
           <a:p>
             <a:pPr algn="ctr"/>
+            <a:endParaRPr/>
           </a:p>
         </p:txBody>
       </p:sp>
@@ -3604,6 +3617,7 @@
           <a:lstStyle/>
           <a:p>
             <a:pPr algn="ctr"/>
+            <a:endParaRPr/>
           </a:p>
         </p:txBody>
       </p:sp>
@@ -3683,6 +3697,7 @@
           <a:lstStyle/>
           <a:p>
             <a:pPr algn="ctr"/>
+            <a:endParaRPr/>
           </a:p>
         </p:txBody>
       </p:sp>
@@ -3762,6 +3777,7 @@
           <a:lstStyle/>
           <a:p>
             <a:pPr algn="ctr"/>
+            <a:endParaRPr/>
           </a:p>
         </p:txBody>
       </p:sp>
@@ -3841,6 +3857,7 @@
           <a:lstStyle/>
           <a:p>
             <a:pPr algn="ctr"/>
+            <a:endParaRPr/>
           </a:p>
         </p:txBody>
       </p:sp>
@@ -3920,6 +3937,7 @@
           <a:lstStyle/>
           <a:p>
             <a:pPr algn="ctr"/>
+            <a:endParaRPr/>
           </a:p>
         </p:txBody>
       </p:sp>
@@ -3999,6 +4017,7 @@
           <a:lstStyle/>
           <a:p>
             <a:pPr algn="ctr"/>
+            <a:endParaRPr/>
           </a:p>
         </p:txBody>
       </p:sp>
@@ -4078,6 +4097,7 @@
           <a:lstStyle/>
           <a:p>
             <a:pPr algn="ctr"/>
+            <a:endParaRPr/>
           </a:p>
         </p:txBody>
       </p:sp>
@@ -4157,6 +4177,7 @@
           <a:lstStyle/>
           <a:p>
             <a:pPr algn="ctr"/>
+            <a:endParaRPr/>
           </a:p>
         </p:txBody>
       </p:sp>
@@ -4236,6 +4257,7 @@
           <a:lstStyle/>
           <a:p>
             <a:pPr algn="ctr"/>
+            <a:endParaRPr/>
           </a:p>
         </p:txBody>
       </p:sp>
@@ -4315,6 +4337,7 @@
           <a:lstStyle/>
           <a:p>
             <a:pPr algn="ctr"/>
+            <a:endParaRPr/>
           </a:p>
         </p:txBody>
       </p:sp>
@@ -4394,6 +4417,7 @@
           <a:lstStyle/>
           <a:p>
             <a:pPr algn="ctr"/>
+            <a:endParaRPr/>
           </a:p>
         </p:txBody>
       </p:sp>
@@ -4471,6 +4495,7 @@
           <a:lstStyle/>
           <a:p>
             <a:pPr algn="ctr"/>
+            <a:endParaRPr/>
           </a:p>
         </p:txBody>
       </p:sp>
@@ -4551,7 +4576,7 @@
 </file>
 
 <file path=ppt/slides/slide11.xml><?xml version="1.0" encoding="utf-8"?>
-<p:sld xmlns:a="http://schemas.openxmlformats.org/drawingml/2006/main" xmlns:p="http://schemas.openxmlformats.org/presentationml/2006/main" xmlns:r="http://schemas.openxmlformats.org/officeDocument/2006/relationships">
+<p:sld xmlns:a="http://schemas.openxmlformats.org/drawingml/2006/main" xmlns:r="http://schemas.openxmlformats.org/officeDocument/2006/relationships" xmlns:p="http://schemas.openxmlformats.org/presentationml/2006/main">
   <p:cSld>
     <p:bg>
       <p:bgPr>
@@ -4567,7 +4592,14 @@
         <p:cNvGrpSpPr/>
         <p:nvPr/>
       </p:nvGrpSpPr>
-      <p:grpSpPr/>
+      <p:grpSpPr>
+        <a:xfrm>
+          <a:off x="0" y="0"/>
+          <a:ext cx="0" cy="0"/>
+          <a:chOff x="0" y="0"/>
+          <a:chExt cx="0" cy="0"/>
+        </a:xfrm>
+      </p:grpSpPr>
       <p:sp>
         <p:nvSpPr>
           <p:cNvPr id="2" name="Rectangle 1"/>
@@ -4608,6 +4640,7 @@
           <a:lstStyle/>
           <a:p>
             <a:pPr algn="ctr"/>
+            <a:endParaRPr/>
           </a:p>
         </p:txBody>
       </p:sp>
@@ -4685,6 +4718,7 @@
           <a:lstStyle/>
           <a:p>
             <a:pPr algn="ctr"/>
+            <a:endParaRPr/>
           </a:p>
         </p:txBody>
       </p:sp>
@@ -4783,6 +4817,7 @@
           <a:lstStyle/>
           <a:p>
             <a:pPr algn="ctr"/>
+            <a:endParaRPr/>
           </a:p>
         </p:txBody>
       </p:sp>
@@ -4896,6 +4931,7 @@
           <a:lstStyle/>
           <a:p>
             <a:pPr algn="ctr"/>
+            <a:endParaRPr/>
           </a:p>
         </p:txBody>
       </p:sp>
@@ -4975,6 +5011,7 @@
           <a:lstStyle/>
           <a:p>
             <a:pPr algn="ctr"/>
+            <a:endParaRPr/>
           </a:p>
         </p:txBody>
       </p:sp>
@@ -5054,6 +5091,7 @@
           <a:lstStyle/>
           <a:p>
             <a:pPr algn="ctr"/>
+            <a:endParaRPr/>
           </a:p>
         </p:txBody>
       </p:sp>
@@ -5133,6 +5171,7 @@
           <a:lstStyle/>
           <a:p>
             <a:pPr algn="ctr"/>
+            <a:endParaRPr/>
           </a:p>
         </p:txBody>
       </p:sp>
@@ -5212,6 +5251,7 @@
           <a:lstStyle/>
           <a:p>
             <a:pPr algn="ctr"/>
+            <a:endParaRPr/>
           </a:p>
         </p:txBody>
       </p:sp>
@@ -5291,6 +5331,7 @@
           <a:lstStyle/>
           <a:p>
             <a:pPr algn="ctr"/>
+            <a:endParaRPr/>
           </a:p>
         </p:txBody>
       </p:sp>
@@ -5370,6 +5411,7 @@
           <a:lstStyle/>
           <a:p>
             <a:pPr algn="ctr"/>
+            <a:endParaRPr/>
           </a:p>
         </p:txBody>
       </p:sp>
@@ -5449,6 +5491,7 @@
           <a:lstStyle/>
           <a:p>
             <a:pPr algn="ctr"/>
+            <a:endParaRPr/>
           </a:p>
         </p:txBody>
       </p:sp>
@@ -5528,6 +5571,7 @@
           <a:lstStyle/>
           <a:p>
             <a:pPr algn="ctr"/>
+            <a:endParaRPr/>
           </a:p>
         </p:txBody>
       </p:sp>
@@ -5607,6 +5651,7 @@
           <a:lstStyle/>
           <a:p>
             <a:pPr algn="ctr"/>
+            <a:endParaRPr/>
           </a:p>
         </p:txBody>
       </p:sp>
@@ -5686,6 +5731,7 @@
           <a:lstStyle/>
           <a:p>
             <a:pPr algn="ctr"/>
+            <a:endParaRPr/>
           </a:p>
         </p:txBody>
       </p:sp>
@@ -5765,6 +5811,7 @@
           <a:lstStyle/>
           <a:p>
             <a:pPr algn="ctr"/>
+            <a:endParaRPr/>
           </a:p>
         </p:txBody>
       </p:sp>
@@ -5811,7 +5858,7 @@
 </file>
 
 <file path=ppt/slides/slide12.xml><?xml version="1.0" encoding="utf-8"?>
-<p:sld xmlns:a="http://schemas.openxmlformats.org/drawingml/2006/main" xmlns:p="http://schemas.openxmlformats.org/presentationml/2006/main" xmlns:r="http://schemas.openxmlformats.org/officeDocument/2006/relationships">
+<p:sld xmlns:a="http://schemas.openxmlformats.org/drawingml/2006/main" xmlns:r="http://schemas.openxmlformats.org/officeDocument/2006/relationships" xmlns:p="http://schemas.openxmlformats.org/presentationml/2006/main">
   <p:cSld>
     <p:bg>
       <p:bgPr>
@@ -5827,7 +5874,14 @@
         <p:cNvGrpSpPr/>
         <p:nvPr/>
       </p:nvGrpSpPr>
-      <p:grpSpPr/>
+      <p:grpSpPr>
+        <a:xfrm>
+          <a:off x="0" y="0"/>
+          <a:ext cx="0" cy="0"/>
+          <a:chOff x="0" y="0"/>
+          <a:chExt cx="0" cy="0"/>
+        </a:xfrm>
+      </p:grpSpPr>
       <p:sp>
         <p:nvSpPr>
           <p:cNvPr id="2" name="Rectangle 1"/>
@@ -5868,6 +5922,7 @@
           <a:lstStyle/>
           <a:p>
             <a:pPr algn="ctr"/>
+            <a:endParaRPr/>
           </a:p>
         </p:txBody>
       </p:sp>
@@ -5979,6 +6034,7 @@
           <a:lstStyle/>
           <a:p>
             <a:pPr algn="ctr"/>
+            <a:endParaRPr/>
           </a:p>
         </p:txBody>
       </p:sp>
@@ -6056,6 +6112,7 @@
           <a:lstStyle/>
           <a:p>
             <a:pPr algn="ctr"/>
+            <a:endParaRPr/>
           </a:p>
         </p:txBody>
       </p:sp>
@@ -6189,6 +6246,7 @@
           <a:lstStyle/>
           <a:p>
             <a:pPr algn="ctr"/>
+            <a:endParaRPr/>
           </a:p>
         </p:txBody>
       </p:sp>
@@ -6266,6 +6324,7 @@
           <a:lstStyle/>
           <a:p>
             <a:pPr algn="ctr"/>
+            <a:endParaRPr/>
           </a:p>
         </p:txBody>
       </p:sp>
@@ -6415,6 +6474,7 @@
           <a:lstStyle/>
           <a:p>
             <a:pPr algn="ctr"/>
+            <a:endParaRPr/>
           </a:p>
         </p:txBody>
       </p:sp>
@@ -6461,7 +6521,7 @@
 </file>
 
 <file path=ppt/slides/slide13.xml><?xml version="1.0" encoding="utf-8"?>
-<p:sld xmlns:a="http://schemas.openxmlformats.org/drawingml/2006/main" xmlns:p="http://schemas.openxmlformats.org/presentationml/2006/main" xmlns:r="http://schemas.openxmlformats.org/officeDocument/2006/relationships">
+<p:sld xmlns:a="http://schemas.openxmlformats.org/drawingml/2006/main" xmlns:r="http://schemas.openxmlformats.org/officeDocument/2006/relationships" xmlns:p="http://schemas.openxmlformats.org/presentationml/2006/main">
   <p:cSld>
     <p:bg>
       <p:bgPr>
@@ -6477,7 +6537,14 @@
         <p:cNvGrpSpPr/>
         <p:nvPr/>
       </p:nvGrpSpPr>
-      <p:grpSpPr/>
+      <p:grpSpPr>
+        <a:xfrm>
+          <a:off x="0" y="0"/>
+          <a:ext cx="0" cy="0"/>
+          <a:chOff x="0" y="0"/>
+          <a:chExt cx="0" cy="0"/>
+        </a:xfrm>
+      </p:grpSpPr>
       <p:sp>
         <p:nvSpPr>
           <p:cNvPr id="2" name="Rectangle 1"/>
@@ -6518,6 +6585,7 @@
           <a:lstStyle/>
           <a:p>
             <a:pPr algn="ctr"/>
+            <a:endParaRPr/>
           </a:p>
         </p:txBody>
       </p:sp>
@@ -6629,6 +6697,7 @@
           <a:lstStyle/>
           <a:p>
             <a:pPr algn="ctr"/>
+            <a:endParaRPr/>
           </a:p>
         </p:txBody>
       </p:sp>
@@ -6775,6 +6844,7 @@
           <a:lstStyle/>
           <a:p>
             <a:pPr algn="ctr"/>
+            <a:endParaRPr/>
           </a:p>
         </p:txBody>
       </p:sp>
@@ -6888,6 +6958,7 @@
           <a:lstStyle/>
           <a:p>
             <a:pPr algn="ctr"/>
+            <a:endParaRPr/>
           </a:p>
         </p:txBody>
       </p:sp>
@@ -7002,7 +7073,7 @@
 </file>
 
 <file path=ppt/slides/slide14.xml><?xml version="1.0" encoding="utf-8"?>
-<p:sld xmlns:a="http://schemas.openxmlformats.org/drawingml/2006/main" xmlns:p="http://schemas.openxmlformats.org/presentationml/2006/main" xmlns:r="http://schemas.openxmlformats.org/officeDocument/2006/relationships">
+<p:sld xmlns:a="http://schemas.openxmlformats.org/drawingml/2006/main" xmlns:r="http://schemas.openxmlformats.org/officeDocument/2006/relationships" xmlns:p="http://schemas.openxmlformats.org/presentationml/2006/main">
   <p:cSld>
     <p:bg>
       <p:bgPr>
@@ -7018,7 +7089,14 @@
         <p:cNvGrpSpPr/>
         <p:nvPr/>
       </p:nvGrpSpPr>
-      <p:grpSpPr/>
+      <p:grpSpPr>
+        <a:xfrm>
+          <a:off x="0" y="0"/>
+          <a:ext cx="0" cy="0"/>
+          <a:chOff x="0" y="0"/>
+          <a:chExt cx="0" cy="0"/>
+        </a:xfrm>
+      </p:grpSpPr>
       <p:sp>
         <p:nvSpPr>
           <p:cNvPr id="2" name="Rectangle 1"/>
@@ -7059,6 +7137,7 @@
           <a:lstStyle/>
           <a:p>
             <a:pPr algn="ctr"/>
+            <a:endParaRPr/>
           </a:p>
         </p:txBody>
       </p:sp>
@@ -7139,7 +7218,7 @@
 </file>
 
 <file path=ppt/slides/slide15.xml><?xml version="1.0" encoding="utf-8"?>
-<p:sld xmlns:a="http://schemas.openxmlformats.org/drawingml/2006/main" xmlns:p="http://schemas.openxmlformats.org/presentationml/2006/main" xmlns:r="http://schemas.openxmlformats.org/officeDocument/2006/relationships">
+<p:sld xmlns:a="http://schemas.openxmlformats.org/drawingml/2006/main" xmlns:r="http://schemas.openxmlformats.org/officeDocument/2006/relationships" xmlns:p="http://schemas.openxmlformats.org/presentationml/2006/main">
   <p:cSld>
     <p:bg>
       <p:bgPr>
@@ -7155,7 +7234,14 @@
         <p:cNvGrpSpPr/>
         <p:nvPr/>
       </p:nvGrpSpPr>
-      <p:grpSpPr/>
+      <p:grpSpPr>
+        <a:xfrm>
+          <a:off x="0" y="0"/>
+          <a:ext cx="0" cy="0"/>
+          <a:chOff x="0" y="0"/>
+          <a:chExt cx="0" cy="0"/>
+        </a:xfrm>
+      </p:grpSpPr>
       <p:sp>
         <p:nvSpPr>
           <p:cNvPr id="2" name="Rectangle 1"/>
@@ -7196,6 +7282,7 @@
           <a:lstStyle/>
           <a:p>
             <a:pPr algn="ctr"/>
+            <a:endParaRPr/>
           </a:p>
         </p:txBody>
       </p:sp>
@@ -7307,6 +7394,7 @@
           <a:lstStyle/>
           <a:p>
             <a:pPr algn="ctr"/>
+            <a:endParaRPr/>
           </a:p>
         </p:txBody>
       </p:sp>
@@ -7418,6 +7506,7 @@
           <a:lstStyle/>
           <a:p>
             <a:pPr algn="ctr"/>
+            <a:endParaRPr/>
           </a:p>
         </p:txBody>
       </p:sp>
@@ -7529,6 +7618,7 @@
           <a:lstStyle/>
           <a:p>
             <a:pPr algn="ctr"/>
+            <a:endParaRPr/>
           </a:p>
         </p:txBody>
       </p:sp>
@@ -7575,7 +7665,7 @@
 </file>
 
 <file path=ppt/slides/slide16.xml><?xml version="1.0" encoding="utf-8"?>
-<p:sld xmlns:a="http://schemas.openxmlformats.org/drawingml/2006/main" xmlns:p="http://schemas.openxmlformats.org/presentationml/2006/main" xmlns:r="http://schemas.openxmlformats.org/officeDocument/2006/relationships">
+<p:sld xmlns:a="http://schemas.openxmlformats.org/drawingml/2006/main" xmlns:r="http://schemas.openxmlformats.org/officeDocument/2006/relationships" xmlns:p="http://schemas.openxmlformats.org/presentationml/2006/main">
   <p:cSld>
     <p:bg>
       <p:bgPr>
@@ -7591,7 +7681,14 @@
         <p:cNvGrpSpPr/>
         <p:nvPr/>
       </p:nvGrpSpPr>
-      <p:grpSpPr/>
+      <p:grpSpPr>
+        <a:xfrm>
+          <a:off x="0" y="0"/>
+          <a:ext cx="0" cy="0"/>
+          <a:chOff x="0" y="0"/>
+          <a:chExt cx="0" cy="0"/>
+        </a:xfrm>
+      </p:grpSpPr>
       <p:sp>
         <p:nvSpPr>
           <p:cNvPr id="2" name="Rectangle 1"/>
@@ -7632,6 +7729,7 @@
           <a:lstStyle/>
           <a:p>
             <a:pPr algn="ctr"/>
+            <a:endParaRPr/>
           </a:p>
         </p:txBody>
       </p:sp>
@@ -7709,6 +7807,7 @@
           <a:lstStyle/>
           <a:p>
             <a:pPr algn="ctr"/>
+            <a:endParaRPr/>
           </a:p>
         </p:txBody>
       </p:sp>
@@ -7887,6 +7986,7 @@
           <a:lstStyle/>
           <a:p>
             <a:pPr algn="ctr"/>
+            <a:endParaRPr/>
           </a:p>
         </p:txBody>
       </p:sp>
@@ -8069,7 +8169,7 @@
 </file>
 
 <file path=ppt/slides/slide17.xml><?xml version="1.0" encoding="utf-8"?>
-<p:sld xmlns:a="http://schemas.openxmlformats.org/drawingml/2006/main" xmlns:p="http://schemas.openxmlformats.org/presentationml/2006/main" xmlns:r="http://schemas.openxmlformats.org/officeDocument/2006/relationships">
+<p:sld xmlns:a="http://schemas.openxmlformats.org/drawingml/2006/main" xmlns:r="http://schemas.openxmlformats.org/officeDocument/2006/relationships" xmlns:p="http://schemas.openxmlformats.org/presentationml/2006/main">
   <p:cSld>
     <p:bg>
       <p:bgPr>
@@ -8085,7 +8185,14 @@
         <p:cNvGrpSpPr/>
         <p:nvPr/>
       </p:nvGrpSpPr>
-      <p:grpSpPr/>
+      <p:grpSpPr>
+        <a:xfrm>
+          <a:off x="0" y="0"/>
+          <a:ext cx="0" cy="0"/>
+          <a:chOff x="0" y="0"/>
+          <a:chExt cx="0" cy="0"/>
+        </a:xfrm>
+      </p:grpSpPr>
       <p:sp>
         <p:nvSpPr>
           <p:cNvPr id="2" name="Rectangle 1"/>
@@ -8126,6 +8233,7 @@
           <a:lstStyle/>
           <a:p>
             <a:pPr algn="ctr"/>
+            <a:endParaRPr/>
           </a:p>
         </p:txBody>
       </p:sp>
@@ -8239,6 +8347,7 @@
           <a:lstStyle/>
           <a:p>
             <a:pPr algn="ctr"/>
+            <a:endParaRPr/>
           </a:p>
         </p:txBody>
       </p:sp>
@@ -8318,6 +8427,7 @@
           <a:lstStyle/>
           <a:p>
             <a:pPr algn="ctr"/>
+            <a:endParaRPr/>
           </a:p>
         </p:txBody>
       </p:sp>
@@ -8397,6 +8507,7 @@
           <a:lstStyle/>
           <a:p>
             <a:pPr algn="ctr"/>
+            <a:endParaRPr/>
           </a:p>
         </p:txBody>
       </p:sp>
@@ -8476,6 +8587,7 @@
           <a:lstStyle/>
           <a:p>
             <a:pPr algn="ctr"/>
+            <a:endParaRPr/>
           </a:p>
         </p:txBody>
       </p:sp>
@@ -8555,6 +8667,7 @@
           <a:lstStyle/>
           <a:p>
             <a:pPr algn="ctr"/>
+            <a:endParaRPr/>
           </a:p>
         </p:txBody>
       </p:sp>
@@ -8634,6 +8747,7 @@
           <a:lstStyle/>
           <a:p>
             <a:pPr algn="ctr"/>
+            <a:endParaRPr/>
           </a:p>
         </p:txBody>
       </p:sp>
@@ -8713,6 +8827,7 @@
           <a:lstStyle/>
           <a:p>
             <a:pPr algn="ctr"/>
+            <a:endParaRPr/>
           </a:p>
         </p:txBody>
       </p:sp>
@@ -8792,6 +8907,7 @@
           <a:lstStyle/>
           <a:p>
             <a:pPr algn="ctr"/>
+            <a:endParaRPr/>
           </a:p>
         </p:txBody>
       </p:sp>
@@ -8871,6 +8987,7 @@
           <a:lstStyle/>
           <a:p>
             <a:pPr algn="ctr"/>
+            <a:endParaRPr/>
           </a:p>
         </p:txBody>
       </p:sp>
@@ -8950,6 +9067,7 @@
           <a:lstStyle/>
           <a:p>
             <a:pPr algn="ctr"/>
+            <a:endParaRPr/>
           </a:p>
         </p:txBody>
       </p:sp>
@@ -8995,7 +9113,7 @@
         </p:nvSpPr>
         <p:spPr>
           <a:xfrm>
-            <a:off x="365760" y="3794760"/>
+            <a:off x="365760" y="4306824"/>
             <a:ext cx="11430000" cy="594360"/>
           </a:xfrm>
           <a:prstGeom prst="rect">
@@ -9027,6 +9145,7 @@
           <a:lstStyle/>
           <a:p>
             <a:pPr algn="ctr"/>
+            <a:endParaRPr/>
           </a:p>
         </p:txBody>
       </p:sp>
@@ -9038,7 +9157,7 @@
         </p:nvSpPr>
         <p:spPr>
           <a:xfrm>
-            <a:off x="502920" y="3886200"/>
+            <a:off x="502920" y="4398264"/>
             <a:ext cx="11201400" cy="457200"/>
           </a:xfrm>
           <a:prstGeom prst="rect">
@@ -9072,8 +9191,8 @@
         </p:nvSpPr>
         <p:spPr>
           <a:xfrm>
-            <a:off x="365760" y="4572000"/>
-            <a:ext cx="11430000" cy="1508760"/>
+            <a:off x="365760" y="5084064"/>
+            <a:ext cx="11430000" cy="1234440"/>
           </a:xfrm>
           <a:prstGeom prst="rect">
             <a:avLst/>
@@ -9104,6 +9223,7 @@
           <a:lstStyle/>
           <a:p>
             <a:pPr algn="ctr"/>
+            <a:endParaRPr/>
           </a:p>
         </p:txBody>
       </p:sp>
@@ -9115,8 +9235,8 @@
         </p:nvSpPr>
         <p:spPr>
           <a:xfrm>
-            <a:off x="548640" y="4709160"/>
-            <a:ext cx="11109960" cy="1280160"/>
+            <a:off x="548640" y="5221224"/>
+            <a:ext cx="11109960" cy="1005840"/>
           </a:xfrm>
           <a:prstGeom prst="rect">
             <a:avLst/>
@@ -9141,7 +9261,7 @@
                 </a:solidFill>
                 <a:latin typeface="Courier New"/>
               </a:rPr>
-              <a:t>Dicionário: "Our team won the championship last year."</a:t>
+              <a:t>Frente: "Brazil _______ its first World Cup in 1958."</a:t>
             </a:r>
           </a:p>
           <a:p>
@@ -9157,7 +9277,7 @@
                 </a:solidFill>
                 <a:latin typeface="Courier New"/>
               </a:rPr>
-              <a:t>Substituição: trocar "Our team" → "My university"</a:t>
+              <a:t>Verso:  won — ganhou</a:t>
             </a:r>
           </a:p>
           <a:p>
@@ -9173,39 +9293,7 @@
                 </a:solidFill>
                 <a:latin typeface="Courier New"/>
               </a:rPr>
-              <a:t> </a:t>
-            </a:r>
-          </a:p>
-          <a:p>
-            <a:pPr>
-              <a:spcBef>
-                <a:spcPts val="200"/>
-              </a:spcBef>
-            </a:pPr>
-            <a:r>
-              <a:rPr sz="1500">
-                <a:solidFill>
-                  <a:srgbClr val="A8FFC8"/>
-                </a:solidFill>
-                <a:latin typeface="Courier New"/>
-              </a:rPr>
-              <a:t>Frente: "My university [WON] the state championship last year."</a:t>
-            </a:r>
-          </a:p>
-          <a:p>
-            <a:pPr>
-              <a:spcBef>
-                <a:spcPts val="200"/>
-              </a:spcBef>
-            </a:pPr>
-            <a:r>
-              <a:rPr sz="1500">
-                <a:solidFill>
-                  <a:srgbClr val="A8FFC8"/>
-                </a:solidFill>
-                <a:latin typeface="Courier New"/>
-              </a:rPr>
-              <a:t>Verso:  won = ganhou</a:t>
+              <a:t>        Minha frase: "My team won the game yesterday."</a:t>
             </a:r>
           </a:p>
         </p:txBody>
@@ -9219,7 +9307,7 @@
 </file>
 
 <file path=ppt/slides/slide18.xml><?xml version="1.0" encoding="utf-8"?>
-<p:sld xmlns:a="http://schemas.openxmlformats.org/drawingml/2006/main" xmlns:p="http://schemas.openxmlformats.org/presentationml/2006/main" xmlns:r="http://schemas.openxmlformats.org/officeDocument/2006/relationships">
+<p:sld xmlns:a="http://schemas.openxmlformats.org/drawingml/2006/main" xmlns:r="http://schemas.openxmlformats.org/officeDocument/2006/relationships" xmlns:p="http://schemas.openxmlformats.org/presentationml/2006/main">
   <p:cSld>
     <p:bg>
       <p:bgPr>
@@ -9235,7 +9323,14 @@
         <p:cNvGrpSpPr/>
         <p:nvPr/>
       </p:nvGrpSpPr>
-      <p:grpSpPr/>
+      <p:grpSpPr>
+        <a:xfrm>
+          <a:off x="0" y="0"/>
+          <a:ext cx="0" cy="0"/>
+          <a:chOff x="0" y="0"/>
+          <a:chExt cx="0" cy="0"/>
+        </a:xfrm>
+      </p:grpSpPr>
       <p:sp>
         <p:nvSpPr>
           <p:cNvPr id="2" name="Rectangle 1"/>
@@ -9276,6 +9371,7 @@
           <a:lstStyle/>
           <a:p>
             <a:pPr algn="ctr"/>
+            <a:endParaRPr/>
           </a:p>
         </p:txBody>
       </p:sp>
@@ -9389,6 +9485,7 @@
           <a:lstStyle/>
           <a:p>
             <a:pPr algn="ctr"/>
+            <a:endParaRPr/>
           </a:p>
         </p:txBody>
       </p:sp>
@@ -9468,6 +9565,7 @@
           <a:lstStyle/>
           <a:p>
             <a:pPr algn="ctr"/>
+            <a:endParaRPr/>
           </a:p>
         </p:txBody>
       </p:sp>
@@ -9547,6 +9645,7 @@
           <a:lstStyle/>
           <a:p>
             <a:pPr algn="ctr"/>
+            <a:endParaRPr/>
           </a:p>
         </p:txBody>
       </p:sp>
@@ -9626,6 +9725,7 @@
           <a:lstStyle/>
           <a:p>
             <a:pPr algn="ctr"/>
+            <a:endParaRPr/>
           </a:p>
         </p:txBody>
       </p:sp>
@@ -9705,6 +9805,7 @@
           <a:lstStyle/>
           <a:p>
             <a:pPr algn="ctr"/>
+            <a:endParaRPr/>
           </a:p>
         </p:txBody>
       </p:sp>
@@ -9784,6 +9885,7 @@
           <a:lstStyle/>
           <a:p>
             <a:pPr algn="ctr"/>
+            <a:endParaRPr/>
           </a:p>
         </p:txBody>
       </p:sp>
@@ -9863,6 +9965,7 @@
           <a:lstStyle/>
           <a:p>
             <a:pPr algn="ctr"/>
+            <a:endParaRPr/>
           </a:p>
         </p:txBody>
       </p:sp>
@@ -9942,6 +10045,7 @@
           <a:lstStyle/>
           <a:p>
             <a:pPr algn="ctr"/>
+            <a:endParaRPr/>
           </a:p>
         </p:txBody>
       </p:sp>
@@ -10021,6 +10125,7 @@
           <a:lstStyle/>
           <a:p>
             <a:pPr algn="ctr"/>
+            <a:endParaRPr/>
           </a:p>
         </p:txBody>
       </p:sp>
@@ -10100,6 +10205,7 @@
           <a:lstStyle/>
           <a:p>
             <a:pPr algn="ctr"/>
+            <a:endParaRPr/>
           </a:p>
         </p:txBody>
       </p:sp>
@@ -10179,6 +10285,7 @@
           <a:lstStyle/>
           <a:p>
             <a:pPr algn="ctr"/>
+            <a:endParaRPr/>
           </a:p>
         </p:txBody>
       </p:sp>
@@ -10258,6 +10365,7 @@
           <a:lstStyle/>
           <a:p>
             <a:pPr algn="ctr"/>
+            <a:endParaRPr/>
           </a:p>
         </p:txBody>
       </p:sp>
@@ -10335,6 +10443,7 @@
           <a:lstStyle/>
           <a:p>
             <a:pPr algn="ctr"/>
+            <a:endParaRPr/>
           </a:p>
         </p:txBody>
       </p:sp>
@@ -10412,6 +10521,7 @@
           <a:lstStyle/>
           <a:p>
             <a:pPr algn="ctr"/>
+            <a:endParaRPr/>
           </a:p>
         </p:txBody>
       </p:sp>
@@ -10449,7 +10559,7 @@
                 </a:solidFill>
                 <a:latin typeface="Courier New"/>
               </a:rPr>
-              <a:t>Dicionário: "The captain lifted the trophy after the final."</a:t>
+              <a:t>Frente: "Brazil defeated Sweden and _______ the trophy."</a:t>
             </a:r>
           </a:p>
           <a:p>
@@ -10465,7 +10575,7 @@
                 </a:solidFill>
                 <a:latin typeface="Courier New"/>
               </a:rPr>
-              <a:t>Substituição: trocar "The captain" → "Our team leader"</a:t>
+              <a:t>Verso:  lifted — levantou, ergueu</a:t>
             </a:r>
           </a:p>
           <a:p>
@@ -10481,7 +10591,7 @@
                 </a:solidFill>
                 <a:latin typeface="Courier New"/>
               </a:rPr>
-              <a:t> </a:t>
+              <a:t>        Colocação: lift the trophy</a:t>
             </a:r>
           </a:p>
           <a:p>
@@ -10497,23 +10607,7 @@
                 </a:solidFill>
                 <a:latin typeface="Courier New"/>
               </a:rPr>
-              <a:t>Frente: "Our team leader [LIFTED] the award at the ceremony."</a:t>
-            </a:r>
-          </a:p>
-          <a:p>
-            <a:pPr>
-              <a:spcBef>
-                <a:spcPts val="200"/>
-              </a:spcBef>
-            </a:pPr>
-            <a:r>
-              <a:rPr sz="1400">
-                <a:solidFill>
-                  <a:srgbClr val="A8FFC8"/>
-                </a:solidFill>
-                <a:latin typeface="Courier New"/>
-              </a:rPr>
-              <a:t>Verso:  lifted = ergueu, levantou</a:t>
+              <a:t>        Minha frase: "The captain lifted the trophy after the final."</a:t>
             </a:r>
           </a:p>
         </p:txBody>
@@ -10527,7 +10621,7 @@
 </file>
 
 <file path=ppt/slides/slide19.xml><?xml version="1.0" encoding="utf-8"?>
-<p:sld xmlns:a="http://schemas.openxmlformats.org/drawingml/2006/main" xmlns:p="http://schemas.openxmlformats.org/presentationml/2006/main" xmlns:r="http://schemas.openxmlformats.org/officeDocument/2006/relationships">
+<p:sld xmlns:a="http://schemas.openxmlformats.org/drawingml/2006/main" xmlns:r="http://schemas.openxmlformats.org/officeDocument/2006/relationships" xmlns:p="http://schemas.openxmlformats.org/presentationml/2006/main">
   <p:cSld>
     <p:bg>
       <p:bgPr>
@@ -10543,7 +10637,14 @@
         <p:cNvGrpSpPr/>
         <p:nvPr/>
       </p:nvGrpSpPr>
-      <p:grpSpPr/>
+      <p:grpSpPr>
+        <a:xfrm>
+          <a:off x="0" y="0"/>
+          <a:ext cx="0" cy="0"/>
+          <a:chOff x="0" y="0"/>
+          <a:chExt cx="0" cy="0"/>
+        </a:xfrm>
+      </p:grpSpPr>
       <p:sp>
         <p:nvSpPr>
           <p:cNvPr id="2" name="Rectangle 1"/>
@@ -10584,6 +10685,7 @@
           <a:lstStyle/>
           <a:p>
             <a:pPr algn="ctr"/>
+            <a:endParaRPr/>
           </a:p>
         </p:txBody>
       </p:sp>
@@ -10697,6 +10799,7 @@
           <a:lstStyle/>
           <a:p>
             <a:pPr algn="ctr"/>
+            <a:endParaRPr/>
           </a:p>
         </p:txBody>
       </p:sp>
@@ -10776,6 +10879,7 @@
           <a:lstStyle/>
           <a:p>
             <a:pPr algn="ctr"/>
+            <a:endParaRPr/>
           </a:p>
         </p:txBody>
       </p:sp>
@@ -10855,6 +10959,7 @@
           <a:lstStyle/>
           <a:p>
             <a:pPr algn="ctr"/>
+            <a:endParaRPr/>
           </a:p>
         </p:txBody>
       </p:sp>
@@ -10934,6 +11039,7 @@
           <a:lstStyle/>
           <a:p>
             <a:pPr algn="ctr"/>
+            <a:endParaRPr/>
           </a:p>
         </p:txBody>
       </p:sp>
@@ -11013,6 +11119,7 @@
           <a:lstStyle/>
           <a:p>
             <a:pPr algn="ctr"/>
+            <a:endParaRPr/>
           </a:p>
         </p:txBody>
       </p:sp>
@@ -11092,6 +11199,7 @@
           <a:lstStyle/>
           <a:p>
             <a:pPr algn="ctr"/>
+            <a:endParaRPr/>
           </a:p>
         </p:txBody>
       </p:sp>
@@ -11171,6 +11279,7 @@
           <a:lstStyle/>
           <a:p>
             <a:pPr algn="ctr"/>
+            <a:endParaRPr/>
           </a:p>
         </p:txBody>
       </p:sp>
@@ -11250,6 +11359,7 @@
           <a:lstStyle/>
           <a:p>
             <a:pPr algn="ctr"/>
+            <a:endParaRPr/>
           </a:p>
         </p:txBody>
       </p:sp>
@@ -11329,6 +11439,7 @@
           <a:lstStyle/>
           <a:p>
             <a:pPr algn="ctr"/>
+            <a:endParaRPr/>
           </a:p>
         </p:txBody>
       </p:sp>
@@ -11408,6 +11519,7 @@
           <a:lstStyle/>
           <a:p>
             <a:pPr algn="ctr"/>
+            <a:endParaRPr/>
           </a:p>
         </p:txBody>
       </p:sp>
@@ -11485,6 +11597,7 @@
           <a:lstStyle/>
           <a:p>
             <a:pPr algn="ctr"/>
+            <a:endParaRPr/>
           </a:p>
         </p:txBody>
       </p:sp>
@@ -11531,7 +11644,7 @@
         <p:spPr>
           <a:xfrm>
             <a:off x="365760" y="4572000"/>
-            <a:ext cx="11430000" cy="1417320"/>
+            <a:ext cx="11430000" cy="1280160"/>
           </a:xfrm>
           <a:prstGeom prst="rect">
             <a:avLst/>
@@ -11562,6 +11675,7 @@
           <a:lstStyle/>
           <a:p>
             <a:pPr algn="ctr"/>
+            <a:endParaRPr/>
           </a:p>
         </p:txBody>
       </p:sp>
@@ -11574,7 +11688,7 @@
         <p:spPr>
           <a:xfrm>
             <a:off x="548640" y="4709160"/>
-            <a:ext cx="11109960" cy="1188720"/>
+            <a:ext cx="11109960" cy="1051560"/>
           </a:xfrm>
           <a:prstGeom prst="rect">
             <a:avLst/>
@@ -11599,7 +11713,7 @@
                 </a:solidFill>
                 <a:latin typeface="Courier New"/>
               </a:rPr>
-              <a:t>Dicionário: "Brazil defeated their opponents in the final."</a:t>
+              <a:t>Frente: "Brazil _______ Sweden in the final."</a:t>
             </a:r>
           </a:p>
           <a:p>
@@ -11615,7 +11729,7 @@
                 </a:solidFill>
                 <a:latin typeface="Courier New"/>
               </a:rPr>
-              <a:t>Substituição: trocar "Brazil" → "Our class team"</a:t>
+              <a:t>Verso:  defeated — derrotou</a:t>
             </a:r>
           </a:p>
           <a:p>
@@ -11631,7 +11745,7 @@
                 </a:solidFill>
                 <a:latin typeface="Courier New"/>
               </a:rPr>
-              <a:t> </a:t>
+              <a:t>        Colocação: defeat a team / defeat an opponent</a:t>
             </a:r>
           </a:p>
           <a:p>
@@ -11647,23 +11761,7 @@
                 </a:solidFill>
                 <a:latin typeface="Courier New"/>
               </a:rPr>
-              <a:t>Frente: "Our class team [DEFEATED] the opponents in the tournament."</a:t>
-            </a:r>
-          </a:p>
-          <a:p>
-            <a:pPr>
-              <a:spcBef>
-                <a:spcPts val="200"/>
-              </a:spcBef>
-            </a:pPr>
-            <a:r>
-              <a:rPr sz="1400">
-                <a:solidFill>
-                  <a:srgbClr val="A8FFC8"/>
-                </a:solidFill>
-                <a:latin typeface="Courier New"/>
-              </a:rPr>
-              <a:t>Verso:  defeated = derrotou</a:t>
+              <a:t>        Minha frase: "Brazil defeated Argentina in the semifinals."</a:t>
             </a:r>
           </a:p>
         </p:txBody>
@@ -11677,7 +11775,7 @@
 </file>
 
 <file path=ppt/slides/slide2.xml><?xml version="1.0" encoding="utf-8"?>
-<p:sld xmlns:a="http://schemas.openxmlformats.org/drawingml/2006/main" xmlns:p="http://schemas.openxmlformats.org/presentationml/2006/main" xmlns:r="http://schemas.openxmlformats.org/officeDocument/2006/relationships">
+<p:sld xmlns:a="http://schemas.openxmlformats.org/drawingml/2006/main" xmlns:r="http://schemas.openxmlformats.org/officeDocument/2006/relationships" xmlns:p="http://schemas.openxmlformats.org/presentationml/2006/main">
   <p:cSld>
     <p:bg>
       <p:bgPr>
@@ -11693,7 +11791,14 @@
         <p:cNvGrpSpPr/>
         <p:nvPr/>
       </p:nvGrpSpPr>
-      <p:grpSpPr/>
+      <p:grpSpPr>
+        <a:xfrm>
+          <a:off x="0" y="0"/>
+          <a:ext cx="0" cy="0"/>
+          <a:chOff x="0" y="0"/>
+          <a:chExt cx="0" cy="0"/>
+        </a:xfrm>
+      </p:grpSpPr>
       <p:sp>
         <p:nvSpPr>
           <p:cNvPr id="2" name="Rectangle 1"/>
@@ -11734,6 +11839,7 @@
           <a:lstStyle/>
           <a:p>
             <a:pPr algn="ctr"/>
+            <a:endParaRPr/>
           </a:p>
         </p:txBody>
       </p:sp>
@@ -11761,13 +11867,74 @@
           <a:p>
             <a:pPr algn="l"/>
             <a:r>
-              <a:rPr sz="3200" b="1" i="0">
+              <a:rPr sz="3200" b="1" i="0" dirty="0">
                 <a:solidFill>
                   <a:srgbClr val="1E1E2E"/>
                 </a:solidFill>
               </a:rPr>
-              <a:t>As duas passagens de leitura — visão geral</a:t>
-            </a:r>
+              <a:t>As duas </a:t>
+            </a:r>
+            <a:r>
+              <a:rPr sz="3200" b="1" i="0" dirty="0" err="1">
+                <a:solidFill>
+                  <a:srgbClr val="1E1E2E"/>
+                </a:solidFill>
+              </a:rPr>
+              <a:t>passagens</a:t>
+            </a:r>
+            <a:r>
+              <a:rPr sz="3200" b="1" i="0" dirty="0">
+                <a:solidFill>
+                  <a:srgbClr val="1E1E2E"/>
+                </a:solidFill>
+              </a:rPr>
+              <a:t> de </a:t>
+            </a:r>
+            <a:r>
+              <a:rPr sz="3200" b="1" i="0" dirty="0" err="1">
+                <a:solidFill>
+                  <a:srgbClr val="1E1E2E"/>
+                </a:solidFill>
+              </a:rPr>
+              <a:t>leitura</a:t>
+            </a:r>
+            <a:r>
+              <a:rPr sz="3200" b="1" i="0" dirty="0">
+                <a:solidFill>
+                  <a:srgbClr val="1E1E2E"/>
+                </a:solidFill>
+              </a:rPr>
+              <a:t> — </a:t>
+            </a:r>
+            <a:r>
+              <a:rPr sz="3200" b="1" i="0" dirty="0" err="1">
+                <a:solidFill>
+                  <a:srgbClr val="1E1E2E"/>
+                </a:solidFill>
+              </a:rPr>
+              <a:t>visão</a:t>
+            </a:r>
+            <a:r>
+              <a:rPr sz="3200" b="1" i="0" dirty="0">
+                <a:solidFill>
+                  <a:srgbClr val="1E1E2E"/>
+                </a:solidFill>
+              </a:rPr>
+              <a:t> </a:t>
+            </a:r>
+            <a:r>
+              <a:rPr sz="3200" b="1" i="0" dirty="0" err="1">
+                <a:solidFill>
+                  <a:srgbClr val="1E1E2E"/>
+                </a:solidFill>
+              </a:rPr>
+              <a:t>geral</a:t>
+            </a:r>
+            <a:endParaRPr sz="3200" b="1" i="0" dirty="0">
+              <a:solidFill>
+                <a:srgbClr val="1E1E2E"/>
+              </a:solidFill>
+            </a:endParaRPr>
           </a:p>
         </p:txBody>
       </p:sp>
@@ -11813,6 +11980,7 @@
           <a:lstStyle/>
           <a:p>
             <a:pPr algn="ctr"/>
+            <a:endParaRPr/>
           </a:p>
         </p:txBody>
       </p:sp>
@@ -11839,14 +12007,7 @@
           <a:lstStyle/>
           <a:p>
             <a:pPr algn="l"/>
-            <a:r>
-              <a:rPr sz="1600" b="1" i="0">
-                <a:solidFill>
-                  <a:srgbClr val="F9C742"/>
-                </a:solidFill>
-              </a:rPr>
-              <a:t/>
-            </a:r>
+            <a:endParaRPr/>
           </a:p>
         </p:txBody>
       </p:sp>
@@ -11892,6 +12053,7 @@
           <a:lstStyle/>
           <a:p>
             <a:pPr algn="ctr"/>
+            <a:endParaRPr/>
           </a:p>
         </p:txBody>
       </p:sp>
@@ -11971,6 +12133,7 @@
           <a:lstStyle/>
           <a:p>
             <a:pPr algn="ctr"/>
+            <a:endParaRPr/>
           </a:p>
         </p:txBody>
       </p:sp>
@@ -12050,6 +12213,7 @@
           <a:lstStyle/>
           <a:p>
             <a:pPr algn="ctr"/>
+            <a:endParaRPr/>
           </a:p>
         </p:txBody>
       </p:sp>
@@ -12129,6 +12293,7 @@
           <a:lstStyle/>
           <a:p>
             <a:pPr algn="ctr"/>
+            <a:endParaRPr/>
           </a:p>
         </p:txBody>
       </p:sp>
@@ -12208,6 +12373,7 @@
           <a:lstStyle/>
           <a:p>
             <a:pPr algn="ctr"/>
+            <a:endParaRPr/>
           </a:p>
         </p:txBody>
       </p:sp>
@@ -12287,6 +12453,7 @@
           <a:lstStyle/>
           <a:p>
             <a:pPr algn="ctr"/>
+            <a:endParaRPr/>
           </a:p>
         </p:txBody>
       </p:sp>
@@ -12366,6 +12533,7 @@
           <a:lstStyle/>
           <a:p>
             <a:pPr algn="ctr"/>
+            <a:endParaRPr/>
           </a:p>
         </p:txBody>
       </p:sp>
@@ -12445,6 +12613,7 @@
           <a:lstStyle/>
           <a:p>
             <a:pPr algn="ctr"/>
+            <a:endParaRPr/>
           </a:p>
         </p:txBody>
       </p:sp>
@@ -12524,6 +12693,7 @@
           <a:lstStyle/>
           <a:p>
             <a:pPr algn="ctr"/>
+            <a:endParaRPr/>
           </a:p>
         </p:txBody>
       </p:sp>
@@ -12603,6 +12773,7 @@
           <a:lstStyle/>
           <a:p>
             <a:pPr algn="ctr"/>
+            <a:endParaRPr/>
           </a:p>
         </p:txBody>
       </p:sp>
@@ -12682,6 +12853,7 @@
           <a:lstStyle/>
           <a:p>
             <a:pPr algn="ctr"/>
+            <a:endParaRPr/>
           </a:p>
         </p:txBody>
       </p:sp>
@@ -12761,6 +12933,7 @@
           <a:lstStyle/>
           <a:p>
             <a:pPr algn="ctr"/>
+            <a:endParaRPr/>
           </a:p>
         </p:txBody>
       </p:sp>
@@ -12840,6 +13013,7 @@
           <a:lstStyle/>
           <a:p>
             <a:pPr algn="ctr"/>
+            <a:endParaRPr/>
           </a:p>
         </p:txBody>
       </p:sp>
@@ -12919,6 +13093,7 @@
           <a:lstStyle/>
           <a:p>
             <a:pPr algn="ctr"/>
+            <a:endParaRPr/>
           </a:p>
         </p:txBody>
       </p:sp>
@@ -12998,6 +13173,7 @@
           <a:lstStyle/>
           <a:p>
             <a:pPr algn="ctr"/>
+            <a:endParaRPr/>
           </a:p>
         </p:txBody>
       </p:sp>
@@ -13077,6 +13253,7 @@
           <a:lstStyle/>
           <a:p>
             <a:pPr algn="ctr"/>
+            <a:endParaRPr/>
           </a:p>
         </p:txBody>
       </p:sp>
@@ -13156,6 +13333,7 @@
           <a:lstStyle/>
           <a:p>
             <a:pPr algn="ctr"/>
+            <a:endParaRPr/>
           </a:p>
         </p:txBody>
       </p:sp>
@@ -13235,6 +13413,7 @@
           <a:lstStyle/>
           <a:p>
             <a:pPr algn="ctr"/>
+            <a:endParaRPr/>
           </a:p>
         </p:txBody>
       </p:sp>
@@ -13314,6 +13493,7 @@
           <a:lstStyle/>
           <a:p>
             <a:pPr algn="ctr"/>
+            <a:endParaRPr/>
           </a:p>
         </p:txBody>
       </p:sp>
@@ -13393,6 +13573,7 @@
           <a:lstStyle/>
           <a:p>
             <a:pPr algn="ctr"/>
+            <a:endParaRPr/>
           </a:p>
         </p:txBody>
       </p:sp>
@@ -13439,7 +13620,7 @@
 </file>
 
 <file path=ppt/slides/slide20.xml><?xml version="1.0" encoding="utf-8"?>
-<p:sld xmlns:a="http://schemas.openxmlformats.org/drawingml/2006/main" xmlns:p="http://schemas.openxmlformats.org/presentationml/2006/main" xmlns:r="http://schemas.openxmlformats.org/officeDocument/2006/relationships">
+<p:sld xmlns:a="http://schemas.openxmlformats.org/drawingml/2006/main" xmlns:r="http://schemas.openxmlformats.org/officeDocument/2006/relationships" xmlns:p="http://schemas.openxmlformats.org/presentationml/2006/main">
   <p:cSld>
     <p:bg>
       <p:bgPr>
@@ -13455,7 +13636,14 @@
         <p:cNvGrpSpPr/>
         <p:nvPr/>
       </p:nvGrpSpPr>
-      <p:grpSpPr/>
+      <p:grpSpPr>
+        <a:xfrm>
+          <a:off x="0" y="0"/>
+          <a:ext cx="0" cy="0"/>
+          <a:chOff x="0" y="0"/>
+          <a:chExt cx="0" cy="0"/>
+        </a:xfrm>
+      </p:grpSpPr>
       <p:sp>
         <p:nvSpPr>
           <p:cNvPr id="2" name="Rectangle 1"/>
@@ -13496,6 +13684,7 @@
           <a:lstStyle/>
           <a:p>
             <a:pPr algn="ctr"/>
+            <a:endParaRPr/>
           </a:p>
         </p:txBody>
       </p:sp>
@@ -13609,6 +13798,7 @@
           <a:lstStyle/>
           <a:p>
             <a:pPr algn="ctr"/>
+            <a:endParaRPr/>
           </a:p>
         </p:txBody>
       </p:sp>
@@ -13688,6 +13878,7 @@
           <a:lstStyle/>
           <a:p>
             <a:pPr algn="ctr"/>
+            <a:endParaRPr/>
           </a:p>
         </p:txBody>
       </p:sp>
@@ -13767,6 +13958,7 @@
           <a:lstStyle/>
           <a:p>
             <a:pPr algn="ctr"/>
+            <a:endParaRPr/>
           </a:p>
         </p:txBody>
       </p:sp>
@@ -13846,6 +14038,7 @@
           <a:lstStyle/>
           <a:p>
             <a:pPr algn="ctr"/>
+            <a:endParaRPr/>
           </a:p>
         </p:txBody>
       </p:sp>
@@ -13925,6 +14118,7 @@
           <a:lstStyle/>
           <a:p>
             <a:pPr algn="ctr"/>
+            <a:endParaRPr/>
           </a:p>
         </p:txBody>
       </p:sp>
@@ -14004,6 +14198,7 @@
           <a:lstStyle/>
           <a:p>
             <a:pPr algn="ctr"/>
+            <a:endParaRPr/>
           </a:p>
         </p:txBody>
       </p:sp>
@@ -14083,6 +14278,7 @@
           <a:lstStyle/>
           <a:p>
             <a:pPr algn="ctr"/>
+            <a:endParaRPr/>
           </a:p>
         </p:txBody>
       </p:sp>
@@ -14162,6 +14358,7 @@
           <a:lstStyle/>
           <a:p>
             <a:pPr algn="ctr"/>
+            <a:endParaRPr/>
           </a:p>
         </p:txBody>
       </p:sp>
@@ -14241,6 +14438,7 @@
           <a:lstStyle/>
           <a:p>
             <a:pPr algn="ctr"/>
+            <a:endParaRPr/>
           </a:p>
         </p:txBody>
       </p:sp>
@@ -14320,6 +14518,7 @@
           <a:lstStyle/>
           <a:p>
             <a:pPr algn="ctr"/>
+            <a:endParaRPr/>
           </a:p>
         </p:txBody>
       </p:sp>
@@ -14365,7 +14564,7 @@
         </p:nvSpPr>
         <p:spPr>
           <a:xfrm>
-            <a:off x="365760" y="3794760"/>
+            <a:off x="365760" y="4306824"/>
             <a:ext cx="11430000" cy="658368"/>
           </a:xfrm>
           <a:prstGeom prst="rect">
@@ -14397,6 +14596,7 @@
           <a:lstStyle/>
           <a:p>
             <a:pPr algn="ctr"/>
+            <a:endParaRPr/>
           </a:p>
         </p:txBody>
       </p:sp>
@@ -14408,7 +14608,7 @@
         </p:nvSpPr>
         <p:spPr>
           <a:xfrm>
-            <a:off x="502920" y="3886200"/>
+            <a:off x="502920" y="4398264"/>
             <a:ext cx="11201400" cy="521208"/>
           </a:xfrm>
           <a:prstGeom prst="rect">
@@ -14442,8 +14642,8 @@
         </p:nvSpPr>
         <p:spPr>
           <a:xfrm>
-            <a:off x="365760" y="4663440"/>
-            <a:ext cx="11430000" cy="1417320"/>
+            <a:off x="365760" y="5175504"/>
+            <a:ext cx="11430000" cy="1280160"/>
           </a:xfrm>
           <a:prstGeom prst="rect">
             <a:avLst/>
@@ -14474,6 +14674,7 @@
           <a:lstStyle/>
           <a:p>
             <a:pPr algn="ctr"/>
+            <a:endParaRPr/>
           </a:p>
         </p:txBody>
       </p:sp>
@@ -14485,8 +14686,8 @@
         </p:nvSpPr>
         <p:spPr>
           <a:xfrm>
-            <a:off x="548640" y="4800600"/>
-            <a:ext cx="11109960" cy="1188720"/>
+            <a:off x="548640" y="5312664"/>
+            <a:ext cx="11109960" cy="1051560"/>
           </a:xfrm>
           <a:prstGeom prst="rect">
             <a:avLst/>
@@ -14511,7 +14712,7 @@
                 </a:solidFill>
                 <a:latin typeface="Courier New"/>
               </a:rPr>
-              <a:t>Dicionário: "The team competed in the national tournament."</a:t>
+              <a:t>Frente: "Brazil has _______ in every single World Cup."</a:t>
             </a:r>
           </a:p>
           <a:p>
@@ -14527,7 +14728,7 @@
                 </a:solidFill>
                 <a:latin typeface="Courier New"/>
               </a:rPr>
-              <a:t>Substituição: trocar "The team" → "My university"</a:t>
+              <a:t>Verso:  competed — competiu, participou</a:t>
             </a:r>
           </a:p>
           <a:p>
@@ -14543,7 +14744,7 @@
                 </a:solidFill>
                 <a:latin typeface="Courier New"/>
               </a:rPr>
-              <a:t> </a:t>
+              <a:t>        Colocação: compete in the World Cup</a:t>
             </a:r>
           </a:p>
           <a:p>
@@ -14559,23 +14760,7 @@
                 </a:solidFill>
                 <a:latin typeface="Courier New"/>
               </a:rPr>
-              <a:t>Frente: "My university [COMPETED] in the regional tournament."</a:t>
-            </a:r>
-          </a:p>
-          <a:p>
-            <a:pPr>
-              <a:spcBef>
-                <a:spcPts val="200"/>
-              </a:spcBef>
-            </a:pPr>
-            <a:r>
-              <a:rPr sz="1400">
-                <a:solidFill>
-                  <a:srgbClr val="A8FFC8"/>
-                </a:solidFill>
-                <a:latin typeface="Courier New"/>
-              </a:rPr>
-              <a:t>Verso:  competed = competiu, participou</a:t>
+              <a:t>        Minha frase: "My university competed in the national championship."</a:t>
             </a:r>
           </a:p>
         </p:txBody>
@@ -14589,7 +14774,7 @@
 </file>
 
 <file path=ppt/slides/slide21.xml><?xml version="1.0" encoding="utf-8"?>
-<p:sld xmlns:a="http://schemas.openxmlformats.org/drawingml/2006/main" xmlns:p="http://schemas.openxmlformats.org/presentationml/2006/main" xmlns:r="http://schemas.openxmlformats.org/officeDocument/2006/relationships">
+<p:sld xmlns:a="http://schemas.openxmlformats.org/drawingml/2006/main" xmlns:r="http://schemas.openxmlformats.org/officeDocument/2006/relationships" xmlns:p="http://schemas.openxmlformats.org/presentationml/2006/main">
   <p:cSld>
     <p:bg>
       <p:bgPr>
@@ -14605,7 +14790,14 @@
         <p:cNvGrpSpPr/>
         <p:nvPr/>
       </p:nvGrpSpPr>
-      <p:grpSpPr/>
+      <p:grpSpPr>
+        <a:xfrm>
+          <a:off x="0" y="0"/>
+          <a:ext cx="0" cy="0"/>
+          <a:chOff x="0" y="0"/>
+          <a:chExt cx="0" cy="0"/>
+        </a:xfrm>
+      </p:grpSpPr>
       <p:sp>
         <p:nvSpPr>
           <p:cNvPr id="2" name="Rectangle 1"/>
@@ -14646,6 +14838,7 @@
           <a:lstStyle/>
           <a:p>
             <a:pPr algn="ctr"/>
+            <a:endParaRPr/>
           </a:p>
         </p:txBody>
       </p:sp>
@@ -14759,6 +14952,7 @@
           <a:lstStyle/>
           <a:p>
             <a:pPr algn="ctr"/>
+            <a:endParaRPr/>
           </a:p>
         </p:txBody>
       </p:sp>
@@ -14838,6 +15032,7 @@
           <a:lstStyle/>
           <a:p>
             <a:pPr algn="ctr"/>
+            <a:endParaRPr/>
           </a:p>
         </p:txBody>
       </p:sp>
@@ -14917,6 +15112,7 @@
           <a:lstStyle/>
           <a:p>
             <a:pPr algn="ctr"/>
+            <a:endParaRPr/>
           </a:p>
         </p:txBody>
       </p:sp>
@@ -14996,6 +15192,7 @@
           <a:lstStyle/>
           <a:p>
             <a:pPr algn="ctr"/>
+            <a:endParaRPr/>
           </a:p>
         </p:txBody>
       </p:sp>
@@ -15075,6 +15272,7 @@
           <a:lstStyle/>
           <a:p>
             <a:pPr algn="ctr"/>
+            <a:endParaRPr/>
           </a:p>
         </p:txBody>
       </p:sp>
@@ -15154,6 +15352,7 @@
           <a:lstStyle/>
           <a:p>
             <a:pPr algn="ctr"/>
+            <a:endParaRPr/>
           </a:p>
         </p:txBody>
       </p:sp>
@@ -15233,6 +15432,7 @@
           <a:lstStyle/>
           <a:p>
             <a:pPr algn="ctr"/>
+            <a:endParaRPr/>
           </a:p>
         </p:txBody>
       </p:sp>
@@ -15312,6 +15512,7 @@
           <a:lstStyle/>
           <a:p>
             <a:pPr algn="ctr"/>
+            <a:endParaRPr/>
           </a:p>
         </p:txBody>
       </p:sp>
@@ -15391,6 +15592,7 @@
           <a:lstStyle/>
           <a:p>
             <a:pPr algn="ctr"/>
+            <a:endParaRPr/>
           </a:p>
         </p:txBody>
       </p:sp>
@@ -15471,6 +15673,7 @@
           <a:lstStyle/>
           <a:p>
             <a:pPr algn="ctr"/>
+            <a:endParaRPr/>
           </a:p>
         </p:txBody>
       </p:sp>
@@ -15516,7 +15719,7 @@
         </p:nvSpPr>
         <p:spPr>
           <a:xfrm>
-            <a:off x="365760" y="3794760"/>
+            <a:off x="365760" y="4379977"/>
             <a:ext cx="11430000" cy="594360"/>
           </a:xfrm>
           <a:prstGeom prst="rect">
@@ -15548,6 +15751,7 @@
           <a:lstStyle/>
           <a:p>
             <a:pPr algn="ctr"/>
+            <a:endParaRPr/>
           </a:p>
         </p:txBody>
       </p:sp>
@@ -15559,7 +15763,7 @@
         </p:nvSpPr>
         <p:spPr>
           <a:xfrm>
-            <a:off x="502920" y="3886200"/>
+            <a:off x="502920" y="4471417"/>
             <a:ext cx="11201400" cy="457200"/>
           </a:xfrm>
           <a:prstGeom prst="rect">
@@ -15593,8 +15797,8 @@
         </p:nvSpPr>
         <p:spPr>
           <a:xfrm>
-            <a:off x="365760" y="4572000"/>
-            <a:ext cx="11430000" cy="1417320"/>
+            <a:off x="365760" y="5157217"/>
+            <a:ext cx="11430000" cy="1188720"/>
           </a:xfrm>
           <a:prstGeom prst="rect">
             <a:avLst/>
@@ -15625,6 +15829,7 @@
           <a:lstStyle/>
           <a:p>
             <a:pPr algn="ctr"/>
+            <a:endParaRPr/>
           </a:p>
         </p:txBody>
       </p:sp>
@@ -15636,8 +15841,8 @@
         </p:nvSpPr>
         <p:spPr>
           <a:xfrm>
-            <a:off x="548640" y="4709160"/>
-            <a:ext cx="11109960" cy="1188720"/>
+            <a:off x="548640" y="5294377"/>
+            <a:ext cx="11109960" cy="960120"/>
           </a:xfrm>
           <a:prstGeom prst="rect">
             <a:avLst/>
@@ -15662,7 +15867,7 @@
                 </a:solidFill>
                 <a:latin typeface="Courier New"/>
               </a:rPr>
-              <a:t>Dicionário: "The coach selected the squad for the championship."</a:t>
+              <a:t>Frente: "Many experts consider the 1970 _______ the best team ever."</a:t>
             </a:r>
           </a:p>
           <a:p>
@@ -15678,7 +15883,7 @@
                 </a:solidFill>
                 <a:latin typeface="Courier New"/>
               </a:rPr>
-              <a:t>Substituição: trocar "The coach" → "Our professor"</a:t>
+              <a:t>Verso:  squad — elenco, seleção</a:t>
             </a:r>
           </a:p>
           <a:p>
@@ -15694,39 +15899,7 @@
                 </a:solidFill>
                 <a:latin typeface="Courier New"/>
               </a:rPr>
-              <a:t> </a:t>
-            </a:r>
-          </a:p>
-          <a:p>
-            <a:pPr>
-              <a:spcBef>
-                <a:spcPts val="200"/>
-              </a:spcBef>
-            </a:pPr>
-            <a:r>
-              <a:rPr sz="1400">
-                <a:solidFill>
-                  <a:srgbClr val="A8FFC8"/>
-                </a:solidFill>
-                <a:latin typeface="Courier New"/>
-              </a:rPr>
-              <a:t>Frente: "Our professor selected the [SQUAD] for the science fair."</a:t>
-            </a:r>
-          </a:p>
-          <a:p>
-            <a:pPr>
-              <a:spcBef>
-                <a:spcPts val="200"/>
-              </a:spcBef>
-            </a:pPr>
-            <a:r>
-              <a:rPr sz="1400">
-                <a:solidFill>
-                  <a:srgbClr val="A8FFC8"/>
-                </a:solidFill>
-                <a:latin typeface="Courier New"/>
-              </a:rPr>
-              <a:t>Verso:  squad = elenco, grupo selecionado</a:t>
+              <a:t>        Minha frase: "The coach announced the squad for the World Cup."</a:t>
             </a:r>
           </a:p>
         </p:txBody>
@@ -15740,7 +15913,7 @@
 </file>
 
 <file path=ppt/slides/slide22.xml><?xml version="1.0" encoding="utf-8"?>
-<p:sld xmlns:a="http://schemas.openxmlformats.org/drawingml/2006/main" xmlns:p="http://schemas.openxmlformats.org/presentationml/2006/main" xmlns:r="http://schemas.openxmlformats.org/officeDocument/2006/relationships">
+<p:sld xmlns:a="http://schemas.openxmlformats.org/drawingml/2006/main" xmlns:r="http://schemas.openxmlformats.org/officeDocument/2006/relationships" xmlns:p="http://schemas.openxmlformats.org/presentationml/2006/main">
   <p:cSld>
     <p:bg>
       <p:bgPr>
@@ -15756,7 +15929,14 @@
         <p:cNvGrpSpPr/>
         <p:nvPr/>
       </p:nvGrpSpPr>
-      <p:grpSpPr/>
+      <p:grpSpPr>
+        <a:xfrm>
+          <a:off x="0" y="0"/>
+          <a:ext cx="0" cy="0"/>
+          <a:chOff x="0" y="0"/>
+          <a:chExt cx="0" cy="0"/>
+        </a:xfrm>
+      </p:grpSpPr>
       <p:sp>
         <p:nvSpPr>
           <p:cNvPr id="2" name="Rectangle 1"/>
@@ -15797,6 +15977,7 @@
           <a:lstStyle/>
           <a:p>
             <a:pPr algn="ctr"/>
+            <a:endParaRPr/>
           </a:p>
         </p:txBody>
       </p:sp>
@@ -15910,6 +16091,7 @@
           <a:lstStyle/>
           <a:p>
             <a:pPr algn="ctr"/>
+            <a:endParaRPr/>
           </a:p>
         </p:txBody>
       </p:sp>
@@ -15989,6 +16171,7 @@
           <a:lstStyle/>
           <a:p>
             <a:pPr algn="ctr"/>
+            <a:endParaRPr/>
           </a:p>
         </p:txBody>
       </p:sp>
@@ -16068,6 +16251,7 @@
           <a:lstStyle/>
           <a:p>
             <a:pPr algn="ctr"/>
+            <a:endParaRPr/>
           </a:p>
         </p:txBody>
       </p:sp>
@@ -16147,6 +16331,7 @@
           <a:lstStyle/>
           <a:p>
             <a:pPr algn="ctr"/>
+            <a:endParaRPr/>
           </a:p>
         </p:txBody>
       </p:sp>
@@ -16226,6 +16411,7 @@
           <a:lstStyle/>
           <a:p>
             <a:pPr algn="ctr"/>
+            <a:endParaRPr/>
           </a:p>
         </p:txBody>
       </p:sp>
@@ -16305,6 +16491,7 @@
           <a:lstStyle/>
           <a:p>
             <a:pPr algn="ctr"/>
+            <a:endParaRPr/>
           </a:p>
         </p:txBody>
       </p:sp>
@@ -16384,6 +16571,7 @@
           <a:lstStyle/>
           <a:p>
             <a:pPr algn="ctr"/>
+            <a:endParaRPr/>
           </a:p>
         </p:txBody>
       </p:sp>
@@ -16463,6 +16651,7 @@
           <a:lstStyle/>
           <a:p>
             <a:pPr algn="ctr"/>
+            <a:endParaRPr/>
           </a:p>
         </p:txBody>
       </p:sp>
@@ -16542,6 +16731,7 @@
           <a:lstStyle/>
           <a:p>
             <a:pPr algn="ctr"/>
+            <a:endParaRPr/>
           </a:p>
         </p:txBody>
       </p:sp>
@@ -16621,6 +16811,7 @@
           <a:lstStyle/>
           <a:p>
             <a:pPr algn="ctr"/>
+            <a:endParaRPr/>
           </a:p>
         </p:txBody>
       </p:sp>
@@ -16666,8 +16857,8 @@
         </p:nvSpPr>
         <p:spPr>
           <a:xfrm>
-            <a:off x="365760" y="3794760"/>
-            <a:ext cx="11430000" cy="502920"/>
+            <a:off x="365760" y="4385775"/>
+            <a:ext cx="11430000" cy="594360"/>
           </a:xfrm>
           <a:prstGeom prst="rect">
             <a:avLst/>
@@ -16698,6 +16889,7 @@
           <a:lstStyle/>
           <a:p>
             <a:pPr algn="ctr"/>
+            <a:endParaRPr/>
           </a:p>
         </p:txBody>
       </p:sp>
@@ -16709,8 +16901,8 @@
         </p:nvSpPr>
         <p:spPr>
           <a:xfrm>
-            <a:off x="502920" y="3886200"/>
-            <a:ext cx="11201400" cy="365760"/>
+            <a:off x="502920" y="4477215"/>
+            <a:ext cx="11201400" cy="457200"/>
           </a:xfrm>
           <a:prstGeom prst="rect">
             <a:avLst/>
@@ -16730,7 +16922,7 @@
                   <a:srgbClr val="FFFFFF"/>
                 </a:solidFill>
               </a:rPr>
-              <a:t>ℹ  title parece título — cognato parcial. O aluno provavelmente já sabe.</a:t>
+              <a:t>ℹ  title é cognato parcial — o aluno pode reconhecer. O valor está na colocação: win the title / World Cup title.</a:t>
             </a:r>
           </a:p>
         </p:txBody>
@@ -16743,8 +16935,8 @@
         </p:nvSpPr>
         <p:spPr>
           <a:xfrm>
-            <a:off x="365760" y="4480560"/>
-            <a:ext cx="11430000" cy="1417320"/>
+            <a:off x="365760" y="5163015"/>
+            <a:ext cx="11430000" cy="1234440"/>
           </a:xfrm>
           <a:prstGeom prst="rect">
             <a:avLst/>
@@ -16775,6 +16967,7 @@
           <a:lstStyle/>
           <a:p>
             <a:pPr algn="ctr"/>
+            <a:endParaRPr/>
           </a:p>
         </p:txBody>
       </p:sp>
@@ -16786,8 +16979,8 @@
         </p:nvSpPr>
         <p:spPr>
           <a:xfrm>
-            <a:off x="548640" y="4617720"/>
-            <a:ext cx="11109960" cy="1188720"/>
+            <a:off x="548640" y="5300175"/>
+            <a:ext cx="11109960" cy="1005840"/>
           </a:xfrm>
           <a:prstGeom prst="rect">
             <a:avLst/>
@@ -16812,7 +17005,7 @@
                 </a:solidFill>
                 <a:latin typeface="Courier New"/>
               </a:rPr>
-              <a:t>Dicionário: "The team won the championship title last year."</a:t>
+              <a:t>Frente: "Brazil has won five World Cup _______."  </a:t>
             </a:r>
           </a:p>
           <a:p>
@@ -16828,7 +17021,7 @@
                 </a:solidFill>
                 <a:latin typeface="Courier New"/>
               </a:rPr>
-              <a:t>Substituição: trocar "The team" → "Our lab"</a:t>
+              <a:t>Verso:  title — título</a:t>
             </a:r>
           </a:p>
           <a:p>
@@ -16844,7 +17037,7 @@
                 </a:solidFill>
                 <a:latin typeface="Courier New"/>
               </a:rPr>
-              <a:t> </a:t>
+              <a:t>        Colocação: win a title / World Cup title</a:t>
             </a:r>
           </a:p>
           <a:p>
@@ -16860,23 +17053,7 @@
                 </a:solidFill>
                 <a:latin typeface="Courier New"/>
               </a:rPr>
-              <a:t>Frente: "Our lab won the innovation [TITLE] at the conference."</a:t>
-            </a:r>
-          </a:p>
-          <a:p>
-            <a:pPr>
-              <a:spcBef>
-                <a:spcPts val="200"/>
-              </a:spcBef>
-            </a:pPr>
-            <a:r>
-              <a:rPr sz="1400">
-                <a:solidFill>
-                  <a:srgbClr val="A8FFC8"/>
-                </a:solidFill>
-                <a:latin typeface="Courier New"/>
-              </a:rPr>
-              <a:t>Verso:  title = título</a:t>
+              <a:t>        Minha frase: "Brazil wants to win a sixth title in 2026."</a:t>
             </a:r>
           </a:p>
         </p:txBody>
@@ -16890,7 +17067,7 @@
 </file>
 
 <file path=ppt/slides/slide23.xml><?xml version="1.0" encoding="utf-8"?>
-<p:sld xmlns:a="http://schemas.openxmlformats.org/drawingml/2006/main" xmlns:p="http://schemas.openxmlformats.org/presentationml/2006/main" xmlns:r="http://schemas.openxmlformats.org/officeDocument/2006/relationships">
+<p:sld xmlns:a="http://schemas.openxmlformats.org/drawingml/2006/main" xmlns:r="http://schemas.openxmlformats.org/officeDocument/2006/relationships" xmlns:p="http://schemas.openxmlformats.org/presentationml/2006/main">
   <p:cSld>
     <p:bg>
       <p:bgPr>
@@ -16906,7 +17083,14 @@
         <p:cNvGrpSpPr/>
         <p:nvPr/>
       </p:nvGrpSpPr>
-      <p:grpSpPr/>
+      <p:grpSpPr>
+        <a:xfrm>
+          <a:off x="0" y="0"/>
+          <a:ext cx="0" cy="0"/>
+          <a:chOff x="0" y="0"/>
+          <a:chExt cx="0" cy="0"/>
+        </a:xfrm>
+      </p:grpSpPr>
       <p:sp>
         <p:nvSpPr>
           <p:cNvPr id="2" name="Rectangle 1"/>
@@ -16947,6 +17131,7 @@
           <a:lstStyle/>
           <a:p>
             <a:pPr algn="ctr"/>
+            <a:endParaRPr/>
           </a:p>
         </p:txBody>
       </p:sp>
@@ -17060,6 +17245,7 @@
           <a:lstStyle/>
           <a:p>
             <a:pPr algn="ctr"/>
+            <a:endParaRPr/>
           </a:p>
         </p:txBody>
       </p:sp>
@@ -17139,6 +17325,7 @@
           <a:lstStyle/>
           <a:p>
             <a:pPr algn="ctr"/>
+            <a:endParaRPr/>
           </a:p>
         </p:txBody>
       </p:sp>
@@ -17218,6 +17405,7 @@
           <a:lstStyle/>
           <a:p>
             <a:pPr algn="ctr"/>
+            <a:endParaRPr/>
           </a:p>
         </p:txBody>
       </p:sp>
@@ -17297,6 +17485,7 @@
           <a:lstStyle/>
           <a:p>
             <a:pPr algn="ctr"/>
+            <a:endParaRPr/>
           </a:p>
         </p:txBody>
       </p:sp>
@@ -17376,6 +17565,7 @@
           <a:lstStyle/>
           <a:p>
             <a:pPr algn="ctr"/>
+            <a:endParaRPr/>
           </a:p>
         </p:txBody>
       </p:sp>
@@ -17455,6 +17645,7 @@
           <a:lstStyle/>
           <a:p>
             <a:pPr algn="ctr"/>
+            <a:endParaRPr/>
           </a:p>
         </p:txBody>
       </p:sp>
@@ -17534,6 +17725,7 @@
           <a:lstStyle/>
           <a:p>
             <a:pPr algn="ctr"/>
+            <a:endParaRPr/>
           </a:p>
         </p:txBody>
       </p:sp>
@@ -17613,6 +17805,7 @@
           <a:lstStyle/>
           <a:p>
             <a:pPr algn="ctr"/>
+            <a:endParaRPr/>
           </a:p>
         </p:txBody>
       </p:sp>
@@ -17692,6 +17885,7 @@
           <a:lstStyle/>
           <a:p>
             <a:pPr algn="ctr"/>
+            <a:endParaRPr/>
           </a:p>
         </p:txBody>
       </p:sp>
@@ -17771,6 +17965,7 @@
           <a:lstStyle/>
           <a:p>
             <a:pPr algn="ctr"/>
+            <a:endParaRPr/>
           </a:p>
         </p:txBody>
       </p:sp>
@@ -17817,7 +18012,7 @@
         <p:spPr>
           <a:xfrm>
             <a:off x="365760" y="3794760"/>
-            <a:ext cx="11430000" cy="502920"/>
+            <a:ext cx="11430000" cy="594360"/>
           </a:xfrm>
           <a:prstGeom prst="rect">
             <a:avLst/>
@@ -17848,6 +18043,7 @@
           <a:lstStyle/>
           <a:p>
             <a:pPr algn="ctr"/>
+            <a:endParaRPr/>
           </a:p>
         </p:txBody>
       </p:sp>
@@ -17860,7 +18056,7 @@
         <p:spPr>
           <a:xfrm>
             <a:off x="502920" y="3886200"/>
-            <a:ext cx="11201400" cy="365760"/>
+            <a:ext cx="11201400" cy="457200"/>
           </a:xfrm>
           <a:prstGeom prst="rect">
             <a:avLst/>
@@ -17880,7 +18076,7 @@
                   <a:srgbClr val="FFFFFF"/>
                 </a:solidFill>
               </a:rPr>
-              <a:t>ℹ  rival é cognato direto — o aluno reconhece na hora. Mesmo assim vale criar o cartão: a palavra existe no contexto do texto.</a:t>
+              <a:t>ℹ  rival é cognato direto — o aluno reconhece na hora. O valor do cartão está na colocação greatest rival.</a:t>
             </a:r>
           </a:p>
         </p:txBody>
@@ -17893,8 +18089,8 @@
         </p:nvSpPr>
         <p:spPr>
           <a:xfrm>
-            <a:off x="365760" y="4480560"/>
-            <a:ext cx="11430000" cy="1417320"/>
+            <a:off x="365760" y="4572000"/>
+            <a:ext cx="11430000" cy="1234440"/>
           </a:xfrm>
           <a:prstGeom prst="rect">
             <a:avLst/>
@@ -17925,6 +18121,7 @@
           <a:lstStyle/>
           <a:p>
             <a:pPr algn="ctr"/>
+            <a:endParaRPr/>
           </a:p>
         </p:txBody>
       </p:sp>
@@ -17936,8 +18133,8 @@
         </p:nvSpPr>
         <p:spPr>
           <a:xfrm>
-            <a:off x="548640" y="4617720"/>
-            <a:ext cx="11109960" cy="1188720"/>
+            <a:off x="548640" y="4709160"/>
+            <a:ext cx="11109960" cy="1005840"/>
           </a:xfrm>
           <a:prstGeom prst="rect">
             <a:avLst/>
@@ -17962,7 +18159,7 @@
                 </a:solidFill>
                 <a:latin typeface="Courier New"/>
               </a:rPr>
-              <a:t>Dicionário: "The two clubs are great rivals in the championship."</a:t>
+              <a:t>Frente: "Brazil's _______ rival is Argentina."</a:t>
             </a:r>
           </a:p>
           <a:p>
@@ -17978,7 +18175,7 @@
                 </a:solidFill>
                 <a:latin typeface="Courier New"/>
               </a:rPr>
-              <a:t>Substituição: trocar "clubs" → "universities"</a:t>
+              <a:t>Verso:  greatest rival — maior rival</a:t>
             </a:r>
           </a:p>
           <a:p>
@@ -17994,7 +18191,7 @@
                 </a:solidFill>
                 <a:latin typeface="Courier New"/>
               </a:rPr>
-              <a:t> </a:t>
+              <a:t>        Colocação: greatest rival / fierce rival</a:t>
             </a:r>
           </a:p>
           <a:p>
@@ -18010,23 +18207,7 @@
                 </a:solidFill>
                 <a:latin typeface="Courier New"/>
               </a:rPr>
-              <a:t>Frente: "The two universities are great [RIVALS] in the championship."</a:t>
-            </a:r>
-          </a:p>
-          <a:p>
-            <a:pPr>
-              <a:spcBef>
-                <a:spcPts val="200"/>
-              </a:spcBef>
-            </a:pPr>
-            <a:r>
-              <a:rPr sz="1400">
-                <a:solidFill>
-                  <a:srgbClr val="A8FFC8"/>
-                </a:solidFill>
-                <a:latin typeface="Courier New"/>
-              </a:rPr>
-              <a:t>Verso:  rival = rival</a:t>
+              <a:t>        Minha frase: "Real Madrid's greatest rival is Barcelona."</a:t>
             </a:r>
           </a:p>
         </p:txBody>
@@ -18040,7 +18221,7 @@
 </file>
 
 <file path=ppt/slides/slide24.xml><?xml version="1.0" encoding="utf-8"?>
-<p:sld xmlns:a="http://schemas.openxmlformats.org/drawingml/2006/main" xmlns:p="http://schemas.openxmlformats.org/presentationml/2006/main" xmlns:r="http://schemas.openxmlformats.org/officeDocument/2006/relationships">
+<p:sld xmlns:a="http://schemas.openxmlformats.org/drawingml/2006/main" xmlns:r="http://schemas.openxmlformats.org/officeDocument/2006/relationships" xmlns:p="http://schemas.openxmlformats.org/presentationml/2006/main">
   <p:cSld>
     <p:bg>
       <p:bgPr>
@@ -18056,7 +18237,14 @@
         <p:cNvGrpSpPr/>
         <p:nvPr/>
       </p:nvGrpSpPr>
-      <p:grpSpPr/>
+      <p:grpSpPr>
+        <a:xfrm>
+          <a:off x="0" y="0"/>
+          <a:ext cx="0" cy="0"/>
+          <a:chOff x="0" y="0"/>
+          <a:chExt cx="0" cy="0"/>
+        </a:xfrm>
+      </p:grpSpPr>
       <p:sp>
         <p:nvSpPr>
           <p:cNvPr id="2" name="Rectangle 1"/>
@@ -18097,6 +18285,7 @@
           <a:lstStyle/>
           <a:p>
             <a:pPr algn="ctr"/>
+            <a:endParaRPr/>
           </a:p>
         </p:txBody>
       </p:sp>
@@ -18210,6 +18399,7 @@
           <a:lstStyle/>
           <a:p>
             <a:pPr algn="ctr"/>
+            <a:endParaRPr/>
           </a:p>
         </p:txBody>
       </p:sp>
@@ -18289,6 +18479,7 @@
           <a:lstStyle/>
           <a:p>
             <a:pPr algn="ctr"/>
+            <a:endParaRPr/>
           </a:p>
         </p:txBody>
       </p:sp>
@@ -18368,6 +18559,7 @@
           <a:lstStyle/>
           <a:p>
             <a:pPr algn="ctr"/>
+            <a:endParaRPr/>
           </a:p>
         </p:txBody>
       </p:sp>
@@ -18447,6 +18639,7 @@
           <a:lstStyle/>
           <a:p>
             <a:pPr algn="ctr"/>
+            <a:endParaRPr/>
           </a:p>
         </p:txBody>
       </p:sp>
@@ -18526,6 +18719,7 @@
           <a:lstStyle/>
           <a:p>
             <a:pPr algn="ctr"/>
+            <a:endParaRPr/>
           </a:p>
         </p:txBody>
       </p:sp>
@@ -18605,6 +18799,7 @@
           <a:lstStyle/>
           <a:p>
             <a:pPr algn="ctr"/>
+            <a:endParaRPr/>
           </a:p>
         </p:txBody>
       </p:sp>
@@ -18684,6 +18879,7 @@
           <a:lstStyle/>
           <a:p>
             <a:pPr algn="ctr"/>
+            <a:endParaRPr/>
           </a:p>
         </p:txBody>
       </p:sp>
@@ -18763,6 +18959,7 @@
           <a:lstStyle/>
           <a:p>
             <a:pPr algn="ctr"/>
+            <a:endParaRPr/>
           </a:p>
         </p:txBody>
       </p:sp>
@@ -18842,6 +19039,7 @@
           <a:lstStyle/>
           <a:p>
             <a:pPr algn="ctr"/>
+            <a:endParaRPr/>
           </a:p>
         </p:txBody>
       </p:sp>
@@ -18921,6 +19119,7 @@
           <a:lstStyle/>
           <a:p>
             <a:pPr algn="ctr"/>
+            <a:endParaRPr/>
           </a:p>
         </p:txBody>
       </p:sp>
@@ -18998,6 +19197,7 @@
           <a:lstStyle/>
           <a:p>
             <a:pPr algn="ctr"/>
+            <a:endParaRPr/>
           </a:p>
         </p:txBody>
       </p:sp>
@@ -19044,7 +19244,7 @@
         <p:spPr>
           <a:xfrm>
             <a:off x="365760" y="4572000"/>
-            <a:ext cx="11430000" cy="1417320"/>
+            <a:ext cx="11430000" cy="1234440"/>
           </a:xfrm>
           <a:prstGeom prst="rect">
             <a:avLst/>
@@ -19075,6 +19275,7 @@
           <a:lstStyle/>
           <a:p>
             <a:pPr algn="ctr"/>
+            <a:endParaRPr/>
           </a:p>
         </p:txBody>
       </p:sp>
@@ -19087,7 +19288,7 @@
         <p:spPr>
           <a:xfrm>
             <a:off x="548640" y="4709160"/>
-            <a:ext cx="11109960" cy="1188720"/>
+            <a:ext cx="11109960" cy="1005840"/>
           </a:xfrm>
           <a:prstGeom prst="rect">
             <a:avLst/>
@@ -19112,7 +19313,7 @@
                 </a:solidFill>
                 <a:latin typeface="Courier New"/>
               </a:rPr>
-              <a:t>Dicionário: "The athletes competed fiercely for the medal."</a:t>
+              <a:t>Frente: "The two teams compete _______."  </a:t>
             </a:r>
           </a:p>
           <a:p>
@@ -19128,7 +19329,7 @@
                 </a:solidFill>
                 <a:latin typeface="Courier New"/>
               </a:rPr>
-              <a:t>Substituição: trocar "The athletes" → "The students"</a:t>
+              <a:t>Verso:  fiercely — ferozmente, com intensidade</a:t>
             </a:r>
           </a:p>
           <a:p>
@@ -19144,7 +19345,7 @@
                 </a:solidFill>
                 <a:latin typeface="Courier New"/>
               </a:rPr>
-              <a:t> </a:t>
+              <a:t>        Colocação: compete fiercely</a:t>
             </a:r>
           </a:p>
           <a:p>
@@ -19160,23 +19361,7 @@
                 </a:solidFill>
                 <a:latin typeface="Courier New"/>
               </a:rPr>
-              <a:t>Frente: "The students competed [FIERCELY] for the scholarship."</a:t>
-            </a:r>
-          </a:p>
-          <a:p>
-            <a:pPr>
-              <a:spcBef>
-                <a:spcPts val="200"/>
-              </a:spcBef>
-            </a:pPr>
-            <a:r>
-              <a:rPr sz="1400">
-                <a:solidFill>
-                  <a:srgbClr val="A8FFC8"/>
-                </a:solidFill>
-                <a:latin typeface="Courier New"/>
-              </a:rPr>
-              <a:t>Verso:  fiercely = ferozmente, com intensidade</a:t>
+              <a:t>        Minha frase: "The students competed fiercely for the scholarship."</a:t>
             </a:r>
           </a:p>
         </p:txBody>
@@ -19190,7 +19375,7 @@
 </file>
 
 <file path=ppt/slides/slide25.xml><?xml version="1.0" encoding="utf-8"?>
-<p:sld xmlns:a="http://schemas.openxmlformats.org/drawingml/2006/main" xmlns:p="http://schemas.openxmlformats.org/presentationml/2006/main" xmlns:r="http://schemas.openxmlformats.org/officeDocument/2006/relationships">
+<p:sld xmlns:a="http://schemas.openxmlformats.org/drawingml/2006/main" xmlns:r="http://schemas.openxmlformats.org/officeDocument/2006/relationships" xmlns:p="http://schemas.openxmlformats.org/presentationml/2006/main">
   <p:cSld>
     <p:bg>
       <p:bgPr>
@@ -19206,7 +19391,14 @@
         <p:cNvGrpSpPr/>
         <p:nvPr/>
       </p:nvGrpSpPr>
-      <p:grpSpPr/>
+      <p:grpSpPr>
+        <a:xfrm>
+          <a:off x="0" y="0"/>
+          <a:ext cx="0" cy="0"/>
+          <a:chOff x="0" y="0"/>
+          <a:chExt cx="0" cy="0"/>
+        </a:xfrm>
+      </p:grpSpPr>
       <p:sp>
         <p:nvSpPr>
           <p:cNvPr id="2" name="Rectangle 1"/>
@@ -19247,6 +19439,7 @@
           <a:lstStyle/>
           <a:p>
             <a:pPr algn="ctr"/>
+            <a:endParaRPr/>
           </a:p>
         </p:txBody>
       </p:sp>
@@ -19360,6 +19553,7 @@
           <a:lstStyle/>
           <a:p>
             <a:pPr algn="ctr"/>
+            <a:endParaRPr/>
           </a:p>
         </p:txBody>
       </p:sp>
@@ -19439,6 +19633,7 @@
           <a:lstStyle/>
           <a:p>
             <a:pPr algn="ctr"/>
+            <a:endParaRPr/>
           </a:p>
         </p:txBody>
       </p:sp>
@@ -19518,6 +19713,7 @@
           <a:lstStyle/>
           <a:p>
             <a:pPr algn="ctr"/>
+            <a:endParaRPr/>
           </a:p>
         </p:txBody>
       </p:sp>
@@ -19597,6 +19793,7 @@
           <a:lstStyle/>
           <a:p>
             <a:pPr algn="ctr"/>
+            <a:endParaRPr/>
           </a:p>
         </p:txBody>
       </p:sp>
@@ -19676,6 +19873,7 @@
           <a:lstStyle/>
           <a:p>
             <a:pPr algn="ctr"/>
+            <a:endParaRPr/>
           </a:p>
         </p:txBody>
       </p:sp>
@@ -19755,6 +19953,7 @@
           <a:lstStyle/>
           <a:p>
             <a:pPr algn="ctr"/>
+            <a:endParaRPr/>
           </a:p>
         </p:txBody>
       </p:sp>
@@ -19834,6 +20033,7 @@
           <a:lstStyle/>
           <a:p>
             <a:pPr algn="ctr"/>
+            <a:endParaRPr/>
           </a:p>
         </p:txBody>
       </p:sp>
@@ -19913,6 +20113,7 @@
           <a:lstStyle/>
           <a:p>
             <a:pPr algn="ctr"/>
+            <a:endParaRPr/>
           </a:p>
         </p:txBody>
       </p:sp>
@@ -19992,6 +20193,7 @@
           <a:lstStyle/>
           <a:p>
             <a:pPr algn="ctr"/>
+            <a:endParaRPr/>
           </a:p>
         </p:txBody>
       </p:sp>
@@ -20071,6 +20273,7 @@
           <a:lstStyle/>
           <a:p>
             <a:pPr algn="ctr"/>
+            <a:endParaRPr/>
           </a:p>
         </p:txBody>
       </p:sp>
@@ -20148,6 +20351,7 @@
           <a:lstStyle/>
           <a:p>
             <a:pPr algn="ctr"/>
+            <a:endParaRPr/>
           </a:p>
         </p:txBody>
       </p:sp>
@@ -20194,7 +20398,7 @@
         <p:spPr>
           <a:xfrm>
             <a:off x="365760" y="4572000"/>
-            <a:ext cx="11430000" cy="1417320"/>
+            <a:ext cx="11430000" cy="1188720"/>
           </a:xfrm>
           <a:prstGeom prst="rect">
             <a:avLst/>
@@ -20225,6 +20429,7 @@
           <a:lstStyle/>
           <a:p>
             <a:pPr algn="ctr"/>
+            <a:endParaRPr/>
           </a:p>
         </p:txBody>
       </p:sp>
@@ -20237,7 +20442,7 @@
         <p:spPr>
           <a:xfrm>
             <a:off x="548640" y="4709160"/>
-            <a:ext cx="11109960" cy="1188720"/>
+            <a:ext cx="11109960" cy="960120"/>
           </a:xfrm>
           <a:prstGeom prst="rect">
             <a:avLst/>
@@ -20262,7 +20467,7 @@
                 </a:solidFill>
                 <a:latin typeface="Courier New"/>
               </a:rPr>
-              <a:t>Dicionário: "The project has a solid plan."</a:t>
+              <a:t>Frente: "The team has talented players and a _______ squad."</a:t>
             </a:r>
           </a:p>
           <a:p>
@@ -20278,7 +20483,7 @@
                 </a:solidFill>
                 <a:latin typeface="Courier New"/>
               </a:rPr>
-              <a:t>Substituição: trocar "project" → "experiment"</a:t>
+              <a:t>Verso:  solid — sólido, forte, consistente</a:t>
             </a:r>
           </a:p>
           <a:p>
@@ -20294,39 +20499,7 @@
                 </a:solidFill>
                 <a:latin typeface="Courier New"/>
               </a:rPr>
-              <a:t> </a:t>
-            </a:r>
-          </a:p>
-          <a:p>
-            <a:pPr>
-              <a:spcBef>
-                <a:spcPts val="200"/>
-              </a:spcBef>
-            </a:pPr>
-            <a:r>
-              <a:rPr sz="1400">
-                <a:solidFill>
-                  <a:srgbClr val="A8FFC8"/>
-                </a:solidFill>
-                <a:latin typeface="Courier New"/>
-              </a:rPr>
-              <a:t>Frente: "The experiment has a [SOLID] design."</a:t>
-            </a:r>
-          </a:p>
-          <a:p>
-            <a:pPr>
-              <a:spcBef>
-                <a:spcPts val="200"/>
-              </a:spcBef>
-            </a:pPr>
-            <a:r>
-              <a:rPr sz="1400">
-                <a:solidFill>
-                  <a:srgbClr val="A8FFC8"/>
-                </a:solidFill>
-                <a:latin typeface="Courier New"/>
-              </a:rPr>
-              <a:t>Verso:  solid = sólido, consistente</a:t>
+              <a:t>        Minha frase: "Brazil has a solid squad for the 2026 World Cup."</a:t>
             </a:r>
           </a:p>
         </p:txBody>
@@ -20340,7 +20513,7 @@
 </file>
 
 <file path=ppt/slides/slide26.xml><?xml version="1.0" encoding="utf-8"?>
-<p:sld xmlns:a="http://schemas.openxmlformats.org/drawingml/2006/main" xmlns:p="http://schemas.openxmlformats.org/presentationml/2006/main" xmlns:r="http://schemas.openxmlformats.org/officeDocument/2006/relationships">
+<p:sld xmlns:a="http://schemas.openxmlformats.org/drawingml/2006/main" xmlns:r="http://schemas.openxmlformats.org/officeDocument/2006/relationships" xmlns:p="http://schemas.openxmlformats.org/presentationml/2006/main">
   <p:cSld>
     <p:bg>
       <p:bgPr>
@@ -20356,7 +20529,14 @@
         <p:cNvGrpSpPr/>
         <p:nvPr/>
       </p:nvGrpSpPr>
-      <p:grpSpPr/>
+      <p:grpSpPr>
+        <a:xfrm>
+          <a:off x="0" y="0"/>
+          <a:ext cx="0" cy="0"/>
+          <a:chOff x="0" y="0"/>
+          <a:chExt cx="0" cy="0"/>
+        </a:xfrm>
+      </p:grpSpPr>
       <p:sp>
         <p:nvSpPr>
           <p:cNvPr id="2" name="Rectangle 1"/>
@@ -20397,6 +20577,7 @@
           <a:lstStyle/>
           <a:p>
             <a:pPr algn="ctr"/>
+            <a:endParaRPr/>
           </a:p>
         </p:txBody>
       </p:sp>
@@ -20510,6 +20691,7 @@
           <a:lstStyle/>
           <a:p>
             <a:pPr algn="ctr"/>
+            <a:endParaRPr/>
           </a:p>
         </p:txBody>
       </p:sp>
@@ -20589,6 +20771,7 @@
           <a:lstStyle/>
           <a:p>
             <a:pPr algn="ctr"/>
+            <a:endParaRPr/>
           </a:p>
         </p:txBody>
       </p:sp>
@@ -20668,6 +20851,7 @@
           <a:lstStyle/>
           <a:p>
             <a:pPr algn="ctr"/>
+            <a:endParaRPr/>
           </a:p>
         </p:txBody>
       </p:sp>
@@ -20747,6 +20931,7 @@
           <a:lstStyle/>
           <a:p>
             <a:pPr algn="ctr"/>
+            <a:endParaRPr/>
           </a:p>
         </p:txBody>
       </p:sp>
@@ -20826,6 +21011,7 @@
           <a:lstStyle/>
           <a:p>
             <a:pPr algn="ctr"/>
+            <a:endParaRPr/>
           </a:p>
         </p:txBody>
       </p:sp>
@@ -20905,6 +21091,7 @@
           <a:lstStyle/>
           <a:p>
             <a:pPr algn="ctr"/>
+            <a:endParaRPr/>
           </a:p>
         </p:txBody>
       </p:sp>
@@ -20984,6 +21171,7 @@
           <a:lstStyle/>
           <a:p>
             <a:pPr algn="ctr"/>
+            <a:endParaRPr/>
           </a:p>
         </p:txBody>
       </p:sp>
@@ -21063,6 +21251,7 @@
           <a:lstStyle/>
           <a:p>
             <a:pPr algn="ctr"/>
+            <a:endParaRPr/>
           </a:p>
         </p:txBody>
       </p:sp>
@@ -21142,6 +21331,7 @@
           <a:lstStyle/>
           <a:p>
             <a:pPr algn="ctr"/>
+            <a:endParaRPr/>
           </a:p>
         </p:txBody>
       </p:sp>
@@ -21221,6 +21411,7 @@
           <a:lstStyle/>
           <a:p>
             <a:pPr algn="ctr"/>
+            <a:endParaRPr/>
           </a:p>
         </p:txBody>
       </p:sp>
@@ -21298,6 +21489,7 @@
           <a:lstStyle/>
           <a:p>
             <a:pPr algn="ctr"/>
+            <a:endParaRPr/>
           </a:p>
         </p:txBody>
       </p:sp>
@@ -21344,7 +21536,7 @@
         <p:spPr>
           <a:xfrm>
             <a:off x="365760" y="4526280"/>
-            <a:ext cx="11430000" cy="1417320"/>
+            <a:ext cx="11430000" cy="1280160"/>
           </a:xfrm>
           <a:prstGeom prst="rect">
             <a:avLst/>
@@ -21375,6 +21567,7 @@
           <a:lstStyle/>
           <a:p>
             <a:pPr algn="ctr"/>
+            <a:endParaRPr/>
           </a:p>
         </p:txBody>
       </p:sp>
@@ -21387,7 +21580,7 @@
         <p:spPr>
           <a:xfrm>
             <a:off x="548640" y="4663440"/>
-            <a:ext cx="11109960" cy="1188720"/>
+            <a:ext cx="11109960" cy="1051560"/>
           </a:xfrm>
           <a:prstGeom prst="rect">
             <a:avLst/>
@@ -21412,7 +21605,7 @@
                 </a:solidFill>
                 <a:latin typeface="Courier New"/>
               </a:rPr>
-              <a:t>Dicionário: "Fans around the world watched the match on TV."</a:t>
+              <a:t>Frente: "_______ around the world hope Brazil will win a sixth title."</a:t>
             </a:r>
           </a:p>
           <a:p>
@@ -21428,7 +21621,7 @@
                 </a:solidFill>
                 <a:latin typeface="Courier New"/>
               </a:rPr>
-              <a:t>Substituição: trocar "match" → "launch event"</a:t>
+              <a:t>Verso:  fans — torcedores, fãs</a:t>
             </a:r>
           </a:p>
           <a:p>
@@ -21444,7 +21637,7 @@
                 </a:solidFill>
                 <a:latin typeface="Courier New"/>
               </a:rPr>
-              <a:t> </a:t>
+              <a:t>        Colocação: fans around the world / football fans</a:t>
             </a:r>
           </a:p>
           <a:p>
@@ -21460,23 +21653,7 @@
                 </a:solidFill>
                 <a:latin typeface="Courier New"/>
               </a:rPr>
-              <a:t>Frente: "[FANS] of technology filled the auditorium for the launch event."</a:t>
-            </a:r>
-          </a:p>
-          <a:p>
-            <a:pPr>
-              <a:spcBef>
-                <a:spcPts val="200"/>
-              </a:spcBef>
-            </a:pPr>
-            <a:r>
-              <a:rPr sz="1400">
-                <a:solidFill>
-                  <a:srgbClr val="A8FFC8"/>
-                </a:solidFill>
-                <a:latin typeface="Courier New"/>
-              </a:rPr>
-              <a:t>Verso:  fans = torcedores, fãs</a:t>
+              <a:t>        Minha frase: "Fans around the world watched the final on TV."</a:t>
             </a:r>
           </a:p>
         </p:txBody>
@@ -21490,7 +21667,7 @@
 </file>
 
 <file path=ppt/slides/slide27.xml><?xml version="1.0" encoding="utf-8"?>
-<p:sld xmlns:a="http://schemas.openxmlformats.org/drawingml/2006/main" xmlns:p="http://schemas.openxmlformats.org/presentationml/2006/main" xmlns:r="http://schemas.openxmlformats.org/officeDocument/2006/relationships">
+<p:sld xmlns:a="http://schemas.openxmlformats.org/drawingml/2006/main" xmlns:r="http://schemas.openxmlformats.org/officeDocument/2006/relationships" xmlns:p="http://schemas.openxmlformats.org/presentationml/2006/main">
   <p:cSld>
     <p:bg>
       <p:bgPr>
@@ -21506,7 +21683,14 @@
         <p:cNvGrpSpPr/>
         <p:nvPr/>
       </p:nvGrpSpPr>
-      <p:grpSpPr/>
+      <p:grpSpPr>
+        <a:xfrm>
+          <a:off x="0" y="0"/>
+          <a:ext cx="0" cy="0"/>
+          <a:chOff x="0" y="0"/>
+          <a:chExt cx="0" cy="0"/>
+        </a:xfrm>
+      </p:grpSpPr>
       <p:sp>
         <p:nvSpPr>
           <p:cNvPr id="2" name="Rectangle 1"/>
@@ -21547,6 +21731,7 @@
           <a:lstStyle/>
           <a:p>
             <a:pPr algn="ctr"/>
+            <a:endParaRPr/>
           </a:p>
         </p:txBody>
       </p:sp>
@@ -21624,6 +21809,7 @@
           <a:lstStyle/>
           <a:p>
             <a:pPr algn="ctr"/>
+            <a:endParaRPr/>
           </a:p>
         </p:txBody>
       </p:sp>
@@ -21769,6 +21955,7 @@
           <a:lstStyle/>
           <a:p>
             <a:pPr algn="ctr"/>
+            <a:endParaRPr/>
           </a:p>
         </p:txBody>
       </p:sp>
@@ -21914,6 +22101,7 @@
           <a:lstStyle/>
           <a:p>
             <a:pPr algn="ctr"/>
+            <a:endParaRPr/>
           </a:p>
         </p:txBody>
       </p:sp>
@@ -21980,7 +22168,7 @@
                   <a:srgbClr val="FFFFFF"/>
                 </a:solidFill>
               </a:rPr>
-              <a:t>Criou 10 cartões no formato [MAIÚSCULO] com 1 substituição pessoal</a:t>
+              <a:t>Criou 10 cartões com frente cloze e frase própria</a:t>
             </a:r>
           </a:p>
         </p:txBody>
@@ -22059,6 +22247,7 @@
           <a:lstStyle/>
           <a:p>
             <a:pPr algn="ctr"/>
+            <a:endParaRPr/>
           </a:p>
         </p:txBody>
       </p:sp>
@@ -22173,7 +22362,7 @@
 </file>
 
 <file path=ppt/slides/slide28.xml><?xml version="1.0" encoding="utf-8"?>
-<p:sld xmlns:a="http://schemas.openxmlformats.org/drawingml/2006/main" xmlns:p="http://schemas.openxmlformats.org/presentationml/2006/main" xmlns:r="http://schemas.openxmlformats.org/officeDocument/2006/relationships">
+<p:sld xmlns:a="http://schemas.openxmlformats.org/drawingml/2006/main" xmlns:r="http://schemas.openxmlformats.org/officeDocument/2006/relationships" xmlns:p="http://schemas.openxmlformats.org/presentationml/2006/main">
   <p:cSld>
     <p:bg>
       <p:bgPr>
@@ -22189,7 +22378,14 @@
         <p:cNvGrpSpPr/>
         <p:nvPr/>
       </p:nvGrpSpPr>
-      <p:grpSpPr/>
+      <p:grpSpPr>
+        <a:xfrm>
+          <a:off x="0" y="0"/>
+          <a:ext cx="0" cy="0"/>
+          <a:chOff x="0" y="0"/>
+          <a:chExt cx="0" cy="0"/>
+        </a:xfrm>
+      </p:grpSpPr>
       <p:sp>
         <p:nvSpPr>
           <p:cNvPr id="2" name="Rectangle 1"/>
@@ -22230,6 +22426,7 @@
           <a:lstStyle/>
           <a:p>
             <a:pPr algn="ctr"/>
+            <a:endParaRPr/>
           </a:p>
         </p:txBody>
       </p:sp>
@@ -22309,6 +22506,7 @@
           <a:lstStyle/>
           <a:p>
             <a:pPr algn="ctr"/>
+            <a:endParaRPr/>
           </a:p>
         </p:txBody>
       </p:sp>
@@ -22335,14 +22533,7 @@
           <a:lstStyle/>
           <a:p>
             <a:pPr algn="l"/>
-            <a:r>
-              <a:rPr sz="1600" b="1" i="0">
-                <a:solidFill>
-                  <a:srgbClr val="F9C742"/>
-                </a:solidFill>
-              </a:rPr>
-              <a:t/>
-            </a:r>
+            <a:endParaRPr/>
           </a:p>
         </p:txBody>
       </p:sp>
@@ -22388,6 +22579,7 @@
           <a:lstStyle/>
           <a:p>
             <a:pPr algn="ctr"/>
+            <a:endParaRPr/>
           </a:p>
         </p:txBody>
       </p:sp>
@@ -22467,6 +22659,7 @@
           <a:lstStyle/>
           <a:p>
             <a:pPr algn="ctr"/>
+            <a:endParaRPr/>
           </a:p>
         </p:txBody>
       </p:sp>
@@ -22546,6 +22739,7 @@
           <a:lstStyle/>
           <a:p>
             <a:pPr algn="ctr"/>
+            <a:endParaRPr/>
           </a:p>
         </p:txBody>
       </p:sp>
@@ -22625,6 +22819,7 @@
           <a:lstStyle/>
           <a:p>
             <a:pPr algn="ctr"/>
+            <a:endParaRPr/>
           </a:p>
         </p:txBody>
       </p:sp>
@@ -22704,6 +22899,7 @@
           <a:lstStyle/>
           <a:p>
             <a:pPr algn="ctr"/>
+            <a:endParaRPr/>
           </a:p>
         </p:txBody>
       </p:sp>
@@ -22783,6 +22979,7 @@
           <a:lstStyle/>
           <a:p>
             <a:pPr algn="ctr"/>
+            <a:endParaRPr/>
           </a:p>
         </p:txBody>
       </p:sp>
@@ -22862,6 +23059,7 @@
           <a:lstStyle/>
           <a:p>
             <a:pPr algn="ctr"/>
+            <a:endParaRPr/>
           </a:p>
         </p:txBody>
       </p:sp>
@@ -22941,6 +23139,7 @@
           <a:lstStyle/>
           <a:p>
             <a:pPr algn="ctr"/>
+            <a:endParaRPr/>
           </a:p>
         </p:txBody>
       </p:sp>
@@ -23020,6 +23219,7 @@
           <a:lstStyle/>
           <a:p>
             <a:pPr algn="ctr"/>
+            <a:endParaRPr/>
           </a:p>
         </p:txBody>
       </p:sp>
@@ -23099,6 +23299,7 @@
           <a:lstStyle/>
           <a:p>
             <a:pPr algn="ctr"/>
+            <a:endParaRPr/>
           </a:p>
         </p:txBody>
       </p:sp>
@@ -23178,6 +23379,7 @@
           <a:lstStyle/>
           <a:p>
             <a:pPr algn="ctr"/>
+            <a:endParaRPr/>
           </a:p>
         </p:txBody>
       </p:sp>
@@ -23257,6 +23459,7 @@
           <a:lstStyle/>
           <a:p>
             <a:pPr algn="ctr"/>
+            <a:endParaRPr/>
           </a:p>
         </p:txBody>
       </p:sp>
@@ -23336,6 +23539,7 @@
           <a:lstStyle/>
           <a:p>
             <a:pPr algn="ctr"/>
+            <a:endParaRPr/>
           </a:p>
         </p:txBody>
       </p:sp>
@@ -23415,6 +23619,7 @@
           <a:lstStyle/>
           <a:p>
             <a:pPr algn="ctr"/>
+            <a:endParaRPr/>
           </a:p>
         </p:txBody>
       </p:sp>
@@ -23494,6 +23699,7 @@
           <a:lstStyle/>
           <a:p>
             <a:pPr algn="ctr"/>
+            <a:endParaRPr/>
           </a:p>
         </p:txBody>
       </p:sp>
@@ -23573,6 +23779,7 @@
           <a:lstStyle/>
           <a:p>
             <a:pPr algn="ctr"/>
+            <a:endParaRPr/>
           </a:p>
         </p:txBody>
       </p:sp>
@@ -23652,6 +23859,7 @@
           <a:lstStyle/>
           <a:p>
             <a:pPr algn="ctr"/>
+            <a:endParaRPr/>
           </a:p>
         </p:txBody>
       </p:sp>
@@ -23684,7 +23892,7 @@
                   <a:srgbClr val="2ECC71"/>
                 </a:solidFill>
               </a:rPr>
-              <a:t>10 cartões: [MAIÚSCULO] + 1 substituição pessoal</a:t>
+              <a:t>10 cartões prontos para revisão</a:t>
             </a:r>
           </a:p>
         </p:txBody>
@@ -23731,6 +23939,7 @@
           <a:lstStyle/>
           <a:p>
             <a:pPr algn="ctr"/>
+            <a:endParaRPr/>
           </a:p>
         </p:txBody>
       </p:sp>
@@ -23810,6 +24019,7 @@
           <a:lstStyle/>
           <a:p>
             <a:pPr algn="ctr"/>
+            <a:endParaRPr/>
           </a:p>
         </p:txBody>
       </p:sp>
@@ -23889,6 +24099,7 @@
           <a:lstStyle/>
           <a:p>
             <a:pPr algn="ctr"/>
+            <a:endParaRPr/>
           </a:p>
         </p:txBody>
       </p:sp>
@@ -23935,7 +24146,7 @@
 </file>
 
 <file path=ppt/slides/slide29.xml><?xml version="1.0" encoding="utf-8"?>
-<p:sld xmlns:a="http://schemas.openxmlformats.org/drawingml/2006/main" xmlns:p="http://schemas.openxmlformats.org/presentationml/2006/main" xmlns:r="http://schemas.openxmlformats.org/officeDocument/2006/relationships">
+<p:sld xmlns:a="http://schemas.openxmlformats.org/drawingml/2006/main" xmlns:r="http://schemas.openxmlformats.org/officeDocument/2006/relationships" xmlns:p="http://schemas.openxmlformats.org/presentationml/2006/main">
   <p:cSld>
     <p:bg>
       <p:bgPr>
@@ -23951,7 +24162,14 @@
         <p:cNvGrpSpPr/>
         <p:nvPr/>
       </p:nvGrpSpPr>
-      <p:grpSpPr/>
+      <p:grpSpPr>
+        <a:xfrm>
+          <a:off x="0" y="0"/>
+          <a:ext cx="0" cy="0"/>
+          <a:chOff x="0" y="0"/>
+          <a:chExt cx="0" cy="0"/>
+        </a:xfrm>
+      </p:grpSpPr>
       <p:sp>
         <p:nvSpPr>
           <p:cNvPr id="2" name="Rectangle 1"/>
@@ -23992,6 +24210,7 @@
           <a:lstStyle/>
           <a:p>
             <a:pPr algn="ctr"/>
+            <a:endParaRPr/>
           </a:p>
         </p:txBody>
       </p:sp>
@@ -24103,6 +24322,7 @@
           <a:lstStyle/>
           <a:p>
             <a:pPr algn="ctr"/>
+            <a:endParaRPr/>
           </a:p>
         </p:txBody>
       </p:sp>
@@ -24251,6 +24471,7 @@
           <a:lstStyle/>
           <a:p>
             <a:pPr algn="ctr"/>
+            <a:endParaRPr/>
           </a:p>
         </p:txBody>
       </p:sp>
@@ -24415,6 +24636,7 @@
           <a:lstStyle/>
           <a:p>
             <a:pPr algn="ctr"/>
+            <a:endParaRPr/>
           </a:p>
         </p:txBody>
       </p:sp>
@@ -24452,7 +24674,7 @@
                 </a:solidFill>
                 <a:latin typeface="Courier New"/>
               </a:rPr>
-              <a:t>"Encontre 1 exemplo de frase com a palavra num dicionário online.</a:t>
+              <a:t>"Copie a frase do texto e retire a palavra (deixe um blank).</a:t>
             </a:r>
           </a:p>
           <a:p>
@@ -24468,39 +24690,7 @@
                 </a:solidFill>
                 <a:latin typeface="Courier New"/>
               </a:rPr>
-              <a:t>Troque 1 palavra do exemplo por algo da sua área ou vida.</a:t>
-            </a:r>
-          </a:p>
-          <a:p>
-            <a:pPr>
-              <a:spcBef>
-                <a:spcPts val="200"/>
-              </a:spcBef>
-            </a:pPr>
-            <a:r>
-              <a:rPr sz="1500">
-                <a:solidFill>
-                  <a:srgbClr val="A8FFC8"/>
-                </a:solidFill>
-                <a:latin typeface="Courier New"/>
-              </a:rPr>
-              <a:t>Frente: frase modificada com a palavra em [MAIÚSCULO].</a:t>
-            </a:r>
-          </a:p>
-          <a:p>
-            <a:pPr>
-              <a:spcBef>
-                <a:spcPts val="200"/>
-              </a:spcBef>
-            </a:pPr>
-            <a:r>
-              <a:rPr sz="1500">
-                <a:solidFill>
-                  <a:srgbClr val="A8FFC8"/>
-                </a:solidFill>
-                <a:latin typeface="Courier New"/>
-              </a:rPr>
-              <a:t>Verso:  palavra = tradução em português."</a:t>
+              <a:t>No verso: escreva a tradução + uma frase sua trocando 1 palavra por algo da sua vida."</a:t>
             </a:r>
           </a:p>
         </p:txBody>
@@ -24514,7 +24704,7 @@
 </file>
 
 <file path=ppt/slides/slide3.xml><?xml version="1.0" encoding="utf-8"?>
-<p:sld xmlns:a="http://schemas.openxmlformats.org/drawingml/2006/main" xmlns:p="http://schemas.openxmlformats.org/presentationml/2006/main" xmlns:r="http://schemas.openxmlformats.org/officeDocument/2006/relationships">
+<p:sld xmlns:a="http://schemas.openxmlformats.org/drawingml/2006/main" xmlns:r="http://schemas.openxmlformats.org/officeDocument/2006/relationships" xmlns:p="http://schemas.openxmlformats.org/presentationml/2006/main">
   <p:cSld>
     <p:bg>
       <p:bgPr>
@@ -24530,7 +24720,14 @@
         <p:cNvGrpSpPr/>
         <p:nvPr/>
       </p:nvGrpSpPr>
-      <p:grpSpPr/>
+      <p:grpSpPr>
+        <a:xfrm>
+          <a:off x="0" y="0"/>
+          <a:ext cx="0" cy="0"/>
+          <a:chOff x="0" y="0"/>
+          <a:chExt cx="0" cy="0"/>
+        </a:xfrm>
+      </p:grpSpPr>
       <p:sp>
         <p:nvSpPr>
           <p:cNvPr id="2" name="Rectangle 1"/>
@@ -24571,6 +24768,7 @@
           <a:lstStyle/>
           <a:p>
             <a:pPr algn="ctr"/>
+            <a:endParaRPr/>
           </a:p>
         </p:txBody>
       </p:sp>
@@ -24648,6 +24846,7 @@
           <a:lstStyle/>
           <a:p>
             <a:pPr algn="ctr"/>
+            <a:endParaRPr/>
           </a:p>
         </p:txBody>
       </p:sp>
@@ -24760,6 +24959,7 @@
           <a:lstStyle/>
           <a:p>
             <a:pPr algn="ctr"/>
+            <a:endParaRPr/>
           </a:p>
         </p:txBody>
       </p:sp>
@@ -24872,6 +25072,7 @@
           <a:lstStyle/>
           <a:p>
             <a:pPr algn="ctr"/>
+            <a:endParaRPr/>
           </a:p>
         </p:txBody>
       </p:sp>
@@ -24983,6 +25184,7 @@
           <a:lstStyle/>
           <a:p>
             <a:pPr algn="ctr"/>
+            <a:endParaRPr/>
           </a:p>
         </p:txBody>
       </p:sp>
@@ -25029,7 +25231,7 @@
 </file>
 
 <file path=ppt/slides/slide4.xml><?xml version="1.0" encoding="utf-8"?>
-<p:sld xmlns:a="http://schemas.openxmlformats.org/drawingml/2006/main" xmlns:p="http://schemas.openxmlformats.org/presentationml/2006/main" xmlns:r="http://schemas.openxmlformats.org/officeDocument/2006/relationships">
+<p:sld xmlns:a="http://schemas.openxmlformats.org/drawingml/2006/main" xmlns:r="http://schemas.openxmlformats.org/officeDocument/2006/relationships" xmlns:p="http://schemas.openxmlformats.org/presentationml/2006/main">
   <p:cSld>
     <p:bg>
       <p:bgPr>
@@ -25045,7 +25247,14 @@
         <p:cNvGrpSpPr/>
         <p:nvPr/>
       </p:nvGrpSpPr>
-      <p:grpSpPr/>
+      <p:grpSpPr>
+        <a:xfrm>
+          <a:off x="0" y="0"/>
+          <a:ext cx="0" cy="0"/>
+          <a:chOff x="0" y="0"/>
+          <a:chExt cx="0" cy="0"/>
+        </a:xfrm>
+      </p:grpSpPr>
       <p:sp>
         <p:nvSpPr>
           <p:cNvPr id="2" name="Rectangle 1"/>
@@ -25086,6 +25295,7 @@
           <a:lstStyle/>
           <a:p>
             <a:pPr algn="ctr"/>
+            <a:endParaRPr/>
           </a:p>
         </p:txBody>
       </p:sp>
@@ -25163,6 +25373,7 @@
           <a:lstStyle/>
           <a:p>
             <a:pPr algn="ctr"/>
+            <a:endParaRPr/>
           </a:p>
         </p:txBody>
       </p:sp>
@@ -25274,6 +25485,7 @@
           <a:lstStyle/>
           <a:p>
             <a:pPr algn="ctr"/>
+            <a:endParaRPr/>
           </a:p>
         </p:txBody>
       </p:sp>
@@ -25351,6 +25563,7 @@
           <a:lstStyle/>
           <a:p>
             <a:pPr algn="ctr"/>
+            <a:endParaRPr/>
           </a:p>
         </p:txBody>
       </p:sp>
@@ -25481,6 +25694,7 @@
           <a:lstStyle/>
           <a:p>
             <a:pPr algn="ctr"/>
+            <a:endParaRPr/>
           </a:p>
         </p:txBody>
       </p:sp>
@@ -25527,7 +25741,7 @@
 </file>
 
 <file path=ppt/slides/slide5.xml><?xml version="1.0" encoding="utf-8"?>
-<p:sld xmlns:a="http://schemas.openxmlformats.org/drawingml/2006/main" xmlns:p="http://schemas.openxmlformats.org/presentationml/2006/main" xmlns:r="http://schemas.openxmlformats.org/officeDocument/2006/relationships">
+<p:sld xmlns:a="http://schemas.openxmlformats.org/drawingml/2006/main" xmlns:r="http://schemas.openxmlformats.org/officeDocument/2006/relationships" xmlns:p="http://schemas.openxmlformats.org/presentationml/2006/main">
   <p:cSld>
     <p:bg>
       <p:bgPr>
@@ -25543,7 +25757,14 @@
         <p:cNvGrpSpPr/>
         <p:nvPr/>
       </p:nvGrpSpPr>
-      <p:grpSpPr/>
+      <p:grpSpPr>
+        <a:xfrm>
+          <a:off x="0" y="0"/>
+          <a:ext cx="0" cy="0"/>
+          <a:chOff x="0" y="0"/>
+          <a:chExt cx="0" cy="0"/>
+        </a:xfrm>
+      </p:grpSpPr>
       <p:sp>
         <p:nvSpPr>
           <p:cNvPr id="2" name="Rectangle 1"/>
@@ -25584,6 +25805,7 @@
           <a:lstStyle/>
           <a:p>
             <a:pPr algn="ctr"/>
+            <a:endParaRPr/>
           </a:p>
         </p:txBody>
       </p:sp>
@@ -25695,6 +25917,7 @@
           <a:lstStyle/>
           <a:p>
             <a:pPr algn="ctr"/>
+            <a:endParaRPr/>
           </a:p>
         </p:txBody>
       </p:sp>
@@ -26100,7 +26323,7 @@
 </file>
 
 <file path=ppt/slides/slide6.xml><?xml version="1.0" encoding="utf-8"?>
-<p:sld xmlns:a="http://schemas.openxmlformats.org/drawingml/2006/main" xmlns:p="http://schemas.openxmlformats.org/presentationml/2006/main" xmlns:r="http://schemas.openxmlformats.org/officeDocument/2006/relationships">
+<p:sld xmlns:a="http://schemas.openxmlformats.org/drawingml/2006/main" xmlns:r="http://schemas.openxmlformats.org/officeDocument/2006/relationships" xmlns:p="http://schemas.openxmlformats.org/presentationml/2006/main">
   <p:cSld>
     <p:bg>
       <p:bgPr>
@@ -26116,7 +26339,14 @@
         <p:cNvGrpSpPr/>
         <p:nvPr/>
       </p:nvGrpSpPr>
-      <p:grpSpPr/>
+      <p:grpSpPr>
+        <a:xfrm>
+          <a:off x="0" y="0"/>
+          <a:ext cx="0" cy="0"/>
+          <a:chOff x="0" y="0"/>
+          <a:chExt cx="0" cy="0"/>
+        </a:xfrm>
+      </p:grpSpPr>
       <p:sp>
         <p:nvSpPr>
           <p:cNvPr id="2" name="Rectangle 1"/>
@@ -26157,6 +26387,7 @@
           <a:lstStyle/>
           <a:p>
             <a:pPr algn="ctr"/>
+            <a:endParaRPr/>
           </a:p>
         </p:txBody>
       </p:sp>
@@ -26218,13 +26449,130 @@
           <a:p>
             <a:pPr algn="l"/>
             <a:r>
-              <a:rPr sz="2400" b="0" i="1">
+              <a:rPr sz="2400" b="0" i="1" dirty="0" err="1">
                 <a:solidFill>
                   <a:srgbClr val="CCCCCC"/>
                 </a:solidFill>
               </a:rPr>
-              <a:t>Leitura do início ao fim — sem parar, sem dicionário</a:t>
-            </a:r>
+              <a:t>Leitura</a:t>
+            </a:r>
+            <a:r>
+              <a:rPr sz="2400" b="0" i="1" dirty="0">
+                <a:solidFill>
+                  <a:srgbClr val="CCCCCC"/>
+                </a:solidFill>
+              </a:rPr>
+              <a:t> do </a:t>
+            </a:r>
+            <a:r>
+              <a:rPr sz="2400" b="0" i="1" dirty="0" err="1">
+                <a:solidFill>
+                  <a:srgbClr val="CCCCCC"/>
+                </a:solidFill>
+              </a:rPr>
+              <a:t>início</a:t>
+            </a:r>
+            <a:r>
+              <a:rPr sz="2400" b="0" i="1" dirty="0">
+                <a:solidFill>
+                  <a:srgbClr val="CCCCCC"/>
+                </a:solidFill>
+              </a:rPr>
+              <a:t> </a:t>
+            </a:r>
+            <a:r>
+              <a:rPr sz="2400" b="0" i="1" dirty="0" err="1">
+                <a:solidFill>
+                  <a:srgbClr val="CCCCCC"/>
+                </a:solidFill>
+              </a:rPr>
+              <a:t>ao</a:t>
+            </a:r>
+            <a:r>
+              <a:rPr sz="2400" b="0" i="1" dirty="0">
+                <a:solidFill>
+                  <a:srgbClr val="CCCCCC"/>
+                </a:solidFill>
+              </a:rPr>
+              <a:t> </a:t>
+            </a:r>
+            <a:r>
+              <a:rPr sz="2400" b="0" i="1" dirty="0" err="1">
+                <a:solidFill>
+                  <a:srgbClr val="CCCCCC"/>
+                </a:solidFill>
+              </a:rPr>
+              <a:t>fim</a:t>
+            </a:r>
+            <a:r>
+              <a:rPr sz="2400" b="0" i="1" dirty="0">
+                <a:solidFill>
+                  <a:srgbClr val="CCCCCC"/>
+                </a:solidFill>
+              </a:rPr>
+              <a:t> — </a:t>
+            </a:r>
+            <a:r>
+              <a:rPr sz="2400" b="0" i="1" dirty="0" err="1">
+                <a:solidFill>
+                  <a:srgbClr val="CCCCCC"/>
+                </a:solidFill>
+              </a:rPr>
+              <a:t>sem</a:t>
+            </a:r>
+            <a:r>
+              <a:rPr sz="2400" b="0" i="1" dirty="0">
+                <a:solidFill>
+                  <a:srgbClr val="CCCCCC"/>
+                </a:solidFill>
+              </a:rPr>
+              <a:t> </a:t>
+            </a:r>
+            <a:r>
+              <a:rPr sz="2400" b="0" i="1" dirty="0" err="1">
+                <a:solidFill>
+                  <a:srgbClr val="CCCCCC"/>
+                </a:solidFill>
+              </a:rPr>
+              <a:t>parar</a:t>
+            </a:r>
+            <a:r>
+              <a:rPr sz="2400" b="0" i="1" dirty="0">
+                <a:solidFill>
+                  <a:srgbClr val="CCCCCC"/>
+                </a:solidFill>
+              </a:rPr>
+              <a:t>, </a:t>
+            </a:r>
+            <a:r>
+              <a:rPr sz="2400" b="0" i="1" dirty="0" err="1">
+                <a:solidFill>
+                  <a:srgbClr val="CCCCCC"/>
+                </a:solidFill>
+              </a:rPr>
+              <a:t>sem</a:t>
+            </a:r>
+            <a:r>
+              <a:rPr sz="2400" b="0" i="1" dirty="0">
+                <a:solidFill>
+                  <a:srgbClr val="CCCCCC"/>
+                </a:solidFill>
+              </a:rPr>
+              <a:t> </a:t>
+            </a:r>
+            <a:r>
+              <a:rPr sz="2400" b="0" i="1" dirty="0" err="1">
+                <a:solidFill>
+                  <a:srgbClr val="CCCCCC"/>
+                </a:solidFill>
+              </a:rPr>
+              <a:t>dicionário</a:t>
+            </a:r>
+            <a:endParaRPr sz="2400" b="0" i="1" dirty="0">
+              <a:solidFill>
+                <a:srgbClr val="CCCCCC"/>
+              </a:solidFill>
+            </a:endParaRPr>
           </a:p>
         </p:txBody>
       </p:sp>
@@ -26237,7 +26585,7 @@
 </file>
 
 <file path=ppt/slides/slide7.xml><?xml version="1.0" encoding="utf-8"?>
-<p:sld xmlns:a="http://schemas.openxmlformats.org/drawingml/2006/main" xmlns:p="http://schemas.openxmlformats.org/presentationml/2006/main" xmlns:r="http://schemas.openxmlformats.org/officeDocument/2006/relationships">
+<p:sld xmlns:a="http://schemas.openxmlformats.org/drawingml/2006/main" xmlns:r="http://schemas.openxmlformats.org/officeDocument/2006/relationships" xmlns:p="http://schemas.openxmlformats.org/presentationml/2006/main">
   <p:cSld>
     <p:bg>
       <p:bgPr>
@@ -26253,7 +26601,14 @@
         <p:cNvGrpSpPr/>
         <p:nvPr/>
       </p:nvGrpSpPr>
-      <p:grpSpPr/>
+      <p:grpSpPr>
+        <a:xfrm>
+          <a:off x="0" y="0"/>
+          <a:ext cx="0" cy="0"/>
+          <a:chOff x="0" y="0"/>
+          <a:chExt cx="0" cy="0"/>
+        </a:xfrm>
+      </p:grpSpPr>
       <p:sp>
         <p:nvSpPr>
           <p:cNvPr id="2" name="Rectangle 1"/>
@@ -26294,6 +26649,7 @@
           <a:lstStyle/>
           <a:p>
             <a:pPr algn="ctr"/>
+            <a:endParaRPr/>
           </a:p>
         </p:txBody>
       </p:sp>
@@ -26407,6 +26763,7 @@
           <a:lstStyle/>
           <a:p>
             <a:pPr algn="ctr"/>
+            <a:endParaRPr/>
           </a:p>
         </p:txBody>
       </p:sp>
@@ -26486,6 +26843,7 @@
           <a:lstStyle/>
           <a:p>
             <a:pPr algn="ctr"/>
+            <a:endParaRPr/>
           </a:p>
         </p:txBody>
       </p:sp>
@@ -26565,6 +26923,7 @@
           <a:lstStyle/>
           <a:p>
             <a:pPr algn="ctr"/>
+            <a:endParaRPr/>
           </a:p>
         </p:txBody>
       </p:sp>
@@ -26644,6 +27003,7 @@
           <a:lstStyle/>
           <a:p>
             <a:pPr algn="ctr"/>
+            <a:endParaRPr/>
           </a:p>
         </p:txBody>
       </p:sp>
@@ -26723,6 +27083,7 @@
           <a:lstStyle/>
           <a:p>
             <a:pPr algn="ctr"/>
+            <a:endParaRPr/>
           </a:p>
         </p:txBody>
       </p:sp>
@@ -26802,6 +27163,7 @@
           <a:lstStyle/>
           <a:p>
             <a:pPr algn="ctr"/>
+            <a:endParaRPr/>
           </a:p>
         </p:txBody>
       </p:sp>
@@ -26881,6 +27243,7 @@
           <a:lstStyle/>
           <a:p>
             <a:pPr algn="ctr"/>
+            <a:endParaRPr/>
           </a:p>
         </p:txBody>
       </p:sp>
@@ -26960,6 +27323,7 @@
           <a:lstStyle/>
           <a:p>
             <a:pPr algn="ctr"/>
+            <a:endParaRPr/>
           </a:p>
         </p:txBody>
       </p:sp>
@@ -27039,6 +27403,7 @@
           <a:lstStyle/>
           <a:p>
             <a:pPr algn="ctr"/>
+            <a:endParaRPr/>
           </a:p>
         </p:txBody>
       </p:sp>
@@ -27118,6 +27483,7 @@
           <a:lstStyle/>
           <a:p>
             <a:pPr algn="ctr"/>
+            <a:endParaRPr/>
           </a:p>
         </p:txBody>
       </p:sp>
@@ -27197,6 +27563,7 @@
           <a:lstStyle/>
           <a:p>
             <a:pPr algn="ctr"/>
+            <a:endParaRPr/>
           </a:p>
         </p:txBody>
       </p:sp>
@@ -27276,6 +27643,7 @@
           <a:lstStyle/>
           <a:p>
             <a:pPr algn="ctr"/>
+            <a:endParaRPr/>
           </a:p>
         </p:txBody>
       </p:sp>
@@ -27353,6 +27721,7 @@
           <a:lstStyle/>
           <a:p>
             <a:pPr algn="ctr"/>
+            <a:endParaRPr/>
           </a:p>
         </p:txBody>
       </p:sp>
@@ -27433,7 +27802,7 @@
 </file>
 
 <file path=ppt/slides/slide8.xml><?xml version="1.0" encoding="utf-8"?>
-<p:sld xmlns:a="http://schemas.openxmlformats.org/drawingml/2006/main" xmlns:p="http://schemas.openxmlformats.org/presentationml/2006/main" xmlns:r="http://schemas.openxmlformats.org/officeDocument/2006/relationships">
+<p:sld xmlns:a="http://schemas.openxmlformats.org/drawingml/2006/main" xmlns:r="http://schemas.openxmlformats.org/officeDocument/2006/relationships" xmlns:p="http://schemas.openxmlformats.org/presentationml/2006/main">
   <p:cSld>
     <p:bg>
       <p:bgPr>
@@ -27449,7 +27818,14 @@
         <p:cNvGrpSpPr/>
         <p:nvPr/>
       </p:nvGrpSpPr>
-      <p:grpSpPr/>
+      <p:grpSpPr>
+        <a:xfrm>
+          <a:off x="0" y="0"/>
+          <a:ext cx="0" cy="0"/>
+          <a:chOff x="0" y="0"/>
+          <a:chExt cx="0" cy="0"/>
+        </a:xfrm>
+      </p:grpSpPr>
       <p:sp>
         <p:nvSpPr>
           <p:cNvPr id="2" name="Rectangle 1"/>
@@ -27490,6 +27866,7 @@
           <a:lstStyle/>
           <a:p>
             <a:pPr algn="ctr"/>
+            <a:endParaRPr/>
           </a:p>
         </p:txBody>
       </p:sp>
@@ -27603,6 +27980,7 @@
           <a:lstStyle/>
           <a:p>
             <a:pPr algn="ctr"/>
+            <a:endParaRPr/>
           </a:p>
         </p:txBody>
       </p:sp>
@@ -27682,6 +28060,7 @@
           <a:lstStyle/>
           <a:p>
             <a:pPr algn="ctr"/>
+            <a:endParaRPr/>
           </a:p>
         </p:txBody>
       </p:sp>
@@ -27761,6 +28140,7 @@
           <a:lstStyle/>
           <a:p>
             <a:pPr algn="ctr"/>
+            <a:endParaRPr/>
           </a:p>
         </p:txBody>
       </p:sp>
@@ -27840,6 +28220,7 @@
           <a:lstStyle/>
           <a:p>
             <a:pPr algn="ctr"/>
+            <a:endParaRPr/>
           </a:p>
         </p:txBody>
       </p:sp>
@@ -27919,6 +28300,7 @@
           <a:lstStyle/>
           <a:p>
             <a:pPr algn="ctr"/>
+            <a:endParaRPr/>
           </a:p>
         </p:txBody>
       </p:sp>
@@ -27998,6 +28380,7 @@
           <a:lstStyle/>
           <a:p>
             <a:pPr algn="ctr"/>
+            <a:endParaRPr/>
           </a:p>
         </p:txBody>
       </p:sp>
@@ -28077,6 +28460,7 @@
           <a:lstStyle/>
           <a:p>
             <a:pPr algn="ctr"/>
+            <a:endParaRPr/>
           </a:p>
         </p:txBody>
       </p:sp>
@@ -28156,6 +28540,7 @@
           <a:lstStyle/>
           <a:p>
             <a:pPr algn="ctr"/>
+            <a:endParaRPr/>
           </a:p>
         </p:txBody>
       </p:sp>
@@ -28235,6 +28620,7 @@
           <a:lstStyle/>
           <a:p>
             <a:pPr algn="ctr"/>
+            <a:endParaRPr/>
           </a:p>
         </p:txBody>
       </p:sp>
@@ -28314,6 +28700,7 @@
           <a:lstStyle/>
           <a:p>
             <a:pPr algn="ctr"/>
+            <a:endParaRPr/>
           </a:p>
         </p:txBody>
       </p:sp>
@@ -28393,6 +28780,7 @@
           <a:lstStyle/>
           <a:p>
             <a:pPr algn="ctr"/>
+            <a:endParaRPr/>
           </a:p>
         </p:txBody>
       </p:sp>
@@ -28472,6 +28860,7 @@
           <a:lstStyle/>
           <a:p>
             <a:pPr algn="ctr"/>
+            <a:endParaRPr/>
           </a:p>
         </p:txBody>
       </p:sp>
@@ -28551,6 +28940,7 @@
           <a:lstStyle/>
           <a:p>
             <a:pPr algn="ctr"/>
+            <a:endParaRPr/>
           </a:p>
         </p:txBody>
       </p:sp>
@@ -28630,6 +29020,7 @@
           <a:lstStyle/>
           <a:p>
             <a:pPr algn="ctr"/>
+            <a:endParaRPr/>
           </a:p>
         </p:txBody>
       </p:sp>
@@ -28707,6 +29098,7 @@
           <a:lstStyle/>
           <a:p>
             <a:pPr algn="ctr"/>
+            <a:endParaRPr/>
           </a:p>
         </p:txBody>
       </p:sp>
@@ -28787,7 +29179,7 @@
 </file>
 
 <file path=ppt/slides/slide9.xml><?xml version="1.0" encoding="utf-8"?>
-<p:sld xmlns:a="http://schemas.openxmlformats.org/drawingml/2006/main" xmlns:p="http://schemas.openxmlformats.org/presentationml/2006/main" xmlns:r="http://schemas.openxmlformats.org/officeDocument/2006/relationships">
+<p:sld xmlns:a="http://schemas.openxmlformats.org/drawingml/2006/main" xmlns:r="http://schemas.openxmlformats.org/officeDocument/2006/relationships" xmlns:p="http://schemas.openxmlformats.org/presentationml/2006/main">
   <p:cSld>
     <p:bg>
       <p:bgPr>
@@ -28803,7 +29195,14 @@
         <p:cNvGrpSpPr/>
         <p:nvPr/>
       </p:nvGrpSpPr>
-      <p:grpSpPr/>
+      <p:grpSpPr>
+        <a:xfrm>
+          <a:off x="0" y="0"/>
+          <a:ext cx="0" cy="0"/>
+          <a:chOff x="0" y="0"/>
+          <a:chExt cx="0" cy="0"/>
+        </a:xfrm>
+      </p:grpSpPr>
       <p:sp>
         <p:nvSpPr>
           <p:cNvPr id="2" name="Rectangle 1"/>
@@ -28844,6 +29243,7 @@
           <a:lstStyle/>
           <a:p>
             <a:pPr algn="ctr"/>
+            <a:endParaRPr/>
           </a:p>
         </p:txBody>
       </p:sp>
@@ -28957,6 +29357,7 @@
           <a:lstStyle/>
           <a:p>
             <a:pPr algn="ctr"/>
+            <a:endParaRPr/>
           </a:p>
         </p:txBody>
       </p:sp>
@@ -29036,6 +29437,7 @@
           <a:lstStyle/>
           <a:p>
             <a:pPr algn="ctr"/>
+            <a:endParaRPr/>
           </a:p>
         </p:txBody>
       </p:sp>
@@ -29115,6 +29517,7 @@
           <a:lstStyle/>
           <a:p>
             <a:pPr algn="ctr"/>
+            <a:endParaRPr/>
           </a:p>
         </p:txBody>
       </p:sp>
@@ -29194,6 +29597,7 @@
           <a:lstStyle/>
           <a:p>
             <a:pPr algn="ctr"/>
+            <a:endParaRPr/>
           </a:p>
         </p:txBody>
       </p:sp>
@@ -29273,6 +29677,7 @@
           <a:lstStyle/>
           <a:p>
             <a:pPr algn="ctr"/>
+            <a:endParaRPr/>
           </a:p>
         </p:txBody>
       </p:sp>
@@ -29352,6 +29757,7 @@
           <a:lstStyle/>
           <a:p>
             <a:pPr algn="ctr"/>
+            <a:endParaRPr/>
           </a:p>
         </p:txBody>
       </p:sp>
@@ -29431,6 +29837,7 @@
           <a:lstStyle/>
           <a:p>
             <a:pPr algn="ctr"/>
+            <a:endParaRPr/>
           </a:p>
         </p:txBody>
       </p:sp>
@@ -29510,6 +29917,7 @@
           <a:lstStyle/>
           <a:p>
             <a:pPr algn="ctr"/>
+            <a:endParaRPr/>
           </a:p>
         </p:txBody>
       </p:sp>
@@ -29589,6 +29997,7 @@
           <a:lstStyle/>
           <a:p>
             <a:pPr algn="ctr"/>
+            <a:endParaRPr/>
           </a:p>
         </p:txBody>
       </p:sp>
@@ -29668,6 +30077,7 @@
           <a:lstStyle/>
           <a:p>
             <a:pPr algn="ctr"/>
+            <a:endParaRPr/>
           </a:p>
         </p:txBody>
       </p:sp>
@@ -29747,6 +30157,7 @@
           <a:lstStyle/>
           <a:p>
             <a:pPr algn="ctr"/>
+            <a:endParaRPr/>
           </a:p>
         </p:txBody>
       </p:sp>
@@ -29826,6 +30237,7 @@
           <a:lstStyle/>
           <a:p>
             <a:pPr algn="ctr"/>
+            <a:endParaRPr/>
           </a:p>
         </p:txBody>
       </p:sp>
@@ -29903,6 +30315,7 @@
           <a:lstStyle/>
           <a:p>
             <a:pPr algn="ctr"/>
+            <a:endParaRPr/>
           </a:p>
         </p:txBody>
       </p:sp>

</xml_diff>